<commit_message>
pptx slide title on chart slide
</commit_message>
<xml_diff>
--- a/notebooks/demo.pptx
+++ b/notebooks/demo.pptx
@@ -3307,7 +3307,11 @@
         <p:txBody>
           <a:bodyPr/>
           <a:lstStyle/>
-          <a:p/>
+          <a:p>
+            <a:r>
+              <a:t>Revenue Trend</a:t>
+            </a:r>
+          </a:p>
         </p:txBody>
       </p:sp>
       <p:graphicFrame>

</xml_diff>

<commit_message>
add two chart slide to demo
</commit_message>
<xml_diff>
--- a/notebooks/demo.pptx
+++ b/notebooks/demo.pptx
@@ -10,6 +10,7 @@
   <p:sldIdLst>
     <p:sldId id="256" r:id="rId18"/>
     <p:sldId id="257" r:id="rId19"/>
+    <p:sldId id="258" r:id="rId20"/>
   </p:sldIdLst>
   <p:sldSz cx="12188825" cy="6858000"/>
   <p:notesSz cx="6858000" cy="9144000"/>
@@ -294,7 +295,295 @@
           <a:lstStyle/>
           <a:p>
             <a:r>
-              <a:t>Revenue Trend</a:t>
+              <a:t>Revenue Trend - Chart Title</a:t>
+            </a:r>
+          </a:p>
+        </c:rich>
+      </c:tx>
+      <c:layout/>
+      <c:overlay val="0"/>
+    </c:title>
+    <c:autoTitleDeleted val="0"/>
+    <c:plotArea>
+      <c:lineChart>
+        <c:grouping val="standard"/>
+        <c:varyColors val="0"/>
+        <c:ser>
+          <c:idx val="0"/>
+          <c:order val="0"/>
+          <c:tx>
+            <c:strRef>
+              <c:f>Sheet1!$B$1</c:f>
+              <c:strCache>
+                <c:ptCount val="1"/>
+                <c:pt idx="0">
+                  <c:v>revenue</c:v>
+                </c:pt>
+              </c:strCache>
+            </c:strRef>
+          </c:tx>
+          <c:marker>
+            <c:symbol val="none"/>
+          </c:marker>
+          <c:cat>
+            <c:strRef>
+              <c:f>Sheet1!$A$2:$A$5</c:f>
+              <c:strCache>
+                <c:ptCount val="4"/>
+                <c:pt idx="0">
+                  <c:v>Jan</c:v>
+                </c:pt>
+                <c:pt idx="1">
+                  <c:v>Feb</c:v>
+                </c:pt>
+                <c:pt idx="2">
+                  <c:v>Mar</c:v>
+                </c:pt>
+                <c:pt idx="3">
+                  <c:v>Apr</c:v>
+                </c:pt>
+              </c:strCache>
+            </c:strRef>
+          </c:cat>
+          <c:val>
+            <c:numRef>
+              <c:f>Sheet1!$B$2:$B$5</c:f>
+              <c:numCache>
+                <c:formatCode>General</c:formatCode>
+                <c:ptCount val="4"/>
+                <c:pt idx="0">
+                  <c:v>10</c:v>
+                </c:pt>
+                <c:pt idx="1">
+                  <c:v>14</c:v>
+                </c:pt>
+                <c:pt idx="2">
+                  <c:v>9</c:v>
+                </c:pt>
+                <c:pt idx="3">
+                  <c:v>18</c:v>
+                </c:pt>
+              </c:numCache>
+            </c:numRef>
+          </c:val>
+          <c:smooth val="0"/>
+        </c:ser>
+        <c:marker val="1"/>
+        <c:smooth val="0"/>
+        <c:axId val="2118791784"/>
+        <c:axId val="2140495176"/>
+      </c:lineChart>
+      <c:catAx>
+        <c:axId val="2118791784"/>
+        <c:scaling>
+          <c:orientation val="minMax"/>
+        </c:scaling>
+        <c:delete val="0"/>
+        <c:axPos val="b"/>
+        <c:majorTickMark val="out"/>
+        <c:minorTickMark val="none"/>
+        <c:tickLblPos val="nextTo"/>
+        <c:crossAx val="2140495176"/>
+        <c:crosses val="autoZero"/>
+        <c:auto val="1"/>
+        <c:lblAlgn val="ctr"/>
+        <c:lblOffset val="100"/>
+        <c:noMultiLvlLbl val="0"/>
+      </c:catAx>
+      <c:valAx>
+        <c:axId val="2140495176"/>
+        <c:scaling/>
+        <c:delete val="0"/>
+        <c:axPos val="l"/>
+        <c:majorGridlines/>
+        <c:majorTickMark val="out"/>
+        <c:minorTickMark val="none"/>
+        <c:tickLblPos val="nextTo"/>
+        <c:crossAx val="2118791784"/>
+        <c:crosses val="autoZero"/>
+      </c:valAx>
+    </c:plotArea>
+    <c:legend>
+      <c:legendPos val="r"/>
+      <c:layout/>
+      <c:overlay val="0"/>
+    </c:legend>
+    <c:plotVisOnly val="1"/>
+    <c:dispBlanksAs val="gap"/>
+    <c:showDLblsOverMax val="0"/>
+  </c:chart>
+  <c:txPr>
+    <a:bodyPr/>
+    <a:lstStyle/>
+    <a:p>
+      <a:pPr>
+        <a:defRPr sz="1800"/>
+      </a:pPr>
+      <a:endParaRPr lang="en-US"/>
+    </a:p>
+  </c:txPr>
+  <c:externalData r:id="rId1">
+    <c:autoUpdate val="0"/>
+  </c:externalData>
+</c:chartSpace>
+</file>
+
+<file path=ppt/charts/chart2.xml><?xml version="1.0" encoding="utf-8"?>
+<c:chartSpace xmlns:c="http://schemas.openxmlformats.org/drawingml/2006/chart" xmlns:a="http://schemas.openxmlformats.org/drawingml/2006/main" xmlns:r="http://schemas.openxmlformats.org/officeDocument/2006/relationships">
+  <c:date1904 val="0"/>
+  <c:chart>
+    <c:title>
+      <c:tx>
+        <c:rich>
+          <a:bodyPr/>
+          <a:lstStyle/>
+          <a:p>
+            <a:r>
+              <a:t>Revenue Trend - Chart Title</a:t>
+            </a:r>
+          </a:p>
+        </c:rich>
+      </c:tx>
+      <c:layout/>
+      <c:overlay val="0"/>
+    </c:title>
+    <c:autoTitleDeleted val="0"/>
+    <c:plotArea>
+      <c:lineChart>
+        <c:grouping val="standard"/>
+        <c:varyColors val="0"/>
+        <c:ser>
+          <c:idx val="0"/>
+          <c:order val="0"/>
+          <c:tx>
+            <c:strRef>
+              <c:f>Sheet1!$B$1</c:f>
+              <c:strCache>
+                <c:ptCount val="1"/>
+                <c:pt idx="0">
+                  <c:v>revenue</c:v>
+                </c:pt>
+              </c:strCache>
+            </c:strRef>
+          </c:tx>
+          <c:marker>
+            <c:symbol val="none"/>
+          </c:marker>
+          <c:cat>
+            <c:strRef>
+              <c:f>Sheet1!$A$2:$A$5</c:f>
+              <c:strCache>
+                <c:ptCount val="4"/>
+                <c:pt idx="0">
+                  <c:v>Jan</c:v>
+                </c:pt>
+                <c:pt idx="1">
+                  <c:v>Feb</c:v>
+                </c:pt>
+                <c:pt idx="2">
+                  <c:v>Mar</c:v>
+                </c:pt>
+                <c:pt idx="3">
+                  <c:v>Apr</c:v>
+                </c:pt>
+              </c:strCache>
+            </c:strRef>
+          </c:cat>
+          <c:val>
+            <c:numRef>
+              <c:f>Sheet1!$B$2:$B$5</c:f>
+              <c:numCache>
+                <c:formatCode>General</c:formatCode>
+                <c:ptCount val="4"/>
+                <c:pt idx="0">
+                  <c:v>10</c:v>
+                </c:pt>
+                <c:pt idx="1">
+                  <c:v>14</c:v>
+                </c:pt>
+                <c:pt idx="2">
+                  <c:v>9</c:v>
+                </c:pt>
+                <c:pt idx="3">
+                  <c:v>18</c:v>
+                </c:pt>
+              </c:numCache>
+            </c:numRef>
+          </c:val>
+          <c:smooth val="0"/>
+        </c:ser>
+        <c:marker val="1"/>
+        <c:smooth val="0"/>
+        <c:axId val="2118791784"/>
+        <c:axId val="2140495176"/>
+      </c:lineChart>
+      <c:catAx>
+        <c:axId val="2118791784"/>
+        <c:scaling>
+          <c:orientation val="minMax"/>
+        </c:scaling>
+        <c:delete val="0"/>
+        <c:axPos val="b"/>
+        <c:majorTickMark val="out"/>
+        <c:minorTickMark val="none"/>
+        <c:tickLblPos val="nextTo"/>
+        <c:crossAx val="2140495176"/>
+        <c:crosses val="autoZero"/>
+        <c:auto val="1"/>
+        <c:lblAlgn val="ctr"/>
+        <c:lblOffset val="100"/>
+        <c:noMultiLvlLbl val="0"/>
+      </c:catAx>
+      <c:valAx>
+        <c:axId val="2140495176"/>
+        <c:scaling/>
+        <c:delete val="0"/>
+        <c:axPos val="l"/>
+        <c:majorGridlines/>
+        <c:majorTickMark val="out"/>
+        <c:minorTickMark val="none"/>
+        <c:tickLblPos val="nextTo"/>
+        <c:crossAx val="2118791784"/>
+        <c:crosses val="autoZero"/>
+      </c:valAx>
+    </c:plotArea>
+    <c:legend>
+      <c:legendPos val="r"/>
+      <c:layout/>
+      <c:overlay val="0"/>
+    </c:legend>
+    <c:plotVisOnly val="1"/>
+    <c:dispBlanksAs val="gap"/>
+    <c:showDLblsOverMax val="0"/>
+  </c:chart>
+  <c:txPr>
+    <a:bodyPr/>
+    <a:lstStyle/>
+    <a:p>
+      <a:pPr>
+        <a:defRPr sz="1800"/>
+      </a:pPr>
+      <a:endParaRPr lang="en-US"/>
+    </a:p>
+  </c:txPr>
+  <c:externalData r:id="rId1">
+    <c:autoUpdate val="0"/>
+  </c:externalData>
+</c:chartSpace>
+</file>
+
+<file path=ppt/charts/chart3.xml><?xml version="1.0" encoding="utf-8"?>
+<c:chartSpace xmlns:c="http://schemas.openxmlformats.org/drawingml/2006/chart" xmlns:a="http://schemas.openxmlformats.org/drawingml/2006/main" xmlns:r="http://schemas.openxmlformats.org/officeDocument/2006/relationships">
+  <c:date1904 val="0"/>
+  <c:chart>
+    <c:title>
+      <c:tx>
+        <c:rich>
+          <a:bodyPr/>
+          <a:lstStyle/>
+          <a:p>
+            <a:r>
+              <a:t>Revenue Trend - Chart Title</a:t>
             </a:r>
           </a:p>
         </c:rich>
@@ -3538,7 +3827,7 @@
           <a:lstStyle/>
           <a:p>
             <a:r>
-              <a:t>Demo</a:t>
+              <a:t>Demo - Title Slide</a:t>
             </a:r>
           </a:p>
         </p:txBody>
@@ -3559,7 +3848,7 @@
           <a:lstStyle/>
           <a:p>
             <a:r>
-              <a:t>Refactored Package</a:t>
+              <a:t>Refactored Package - Author</a:t>
             </a:r>
           </a:p>
         </p:txBody>
@@ -3598,7 +3887,7 @@
           <a:lstStyle/>
           <a:p>
             <a:r>
-              <a:t>Revenue Trend</a:t>
+              <a:t>Revenue Trend - Slide Title</a:t>
             </a:r>
           </a:p>
         </p:txBody>
@@ -3618,6 +3907,81 @@
         <a:graphic>
           <a:graphicData uri="http://schemas.openxmlformats.org/drawingml/2006/chart">
             <c:chart xmlns:c="http://schemas.openxmlformats.org/drawingml/2006/chart" r:id="rId2"/>
+          </a:graphicData>
+        </a:graphic>
+      </p:graphicFrame>
+    </p:spTree>
+  </p:cSld>
+  <p:clrMapOvr>
+    <a:masterClrMapping/>
+  </p:clrMapOvr>
+</p:sld>
+</file>
+
+<file path=ppt/slides/slide3.xml><?xml version="1.0" encoding="utf-8"?>
+<p:sld xmlns:a="http://schemas.openxmlformats.org/drawingml/2006/main" xmlns:p="http://schemas.openxmlformats.org/presentationml/2006/main" xmlns:r="http://schemas.openxmlformats.org/officeDocument/2006/relationships">
+  <p:cSld>
+    <p:spTree>
+      <p:nvGrpSpPr>
+        <p:cNvPr id="1" name=""/>
+        <p:cNvGrpSpPr/>
+        <p:nvPr/>
+      </p:nvGrpSpPr>
+      <p:grpSpPr/>
+      <p:sp>
+        <p:nvSpPr>
+          <p:cNvPr id="2" name="Title 1"/>
+          <p:cNvSpPr>
+            <a:spLocks noGrp="1"/>
+          </p:cNvSpPr>
+          <p:nvPr>
+            <p:ph type="title"/>
+          </p:nvPr>
+        </p:nvSpPr>
+        <p:spPr/>
+        <p:txBody>
+          <a:bodyPr/>
+          <a:lstStyle/>
+          <a:p>
+            <a:r>
+              <a:t>Revenue Trend - Slide Title</a:t>
+            </a:r>
+          </a:p>
+        </p:txBody>
+      </p:sp>
+      <p:graphicFrame>
+        <p:nvGraphicFramePr>
+          <p:cNvPr id="3" name="Chart 2"/>
+          <p:cNvGraphicFramePr>
+            <a:graphicFrameLocks noGrp="1"/>
+          </p:cNvGraphicFramePr>
+          <p:nvPr/>
+        </p:nvGraphicFramePr>
+        <p:xfrm>
+          <a:off x="457200" y="1371600"/>
+          <a:ext cx="4114800" cy="3657600"/>
+        </p:xfrm>
+        <a:graphic>
+          <a:graphicData uri="http://schemas.openxmlformats.org/drawingml/2006/chart">
+            <c:chart xmlns:c="http://schemas.openxmlformats.org/drawingml/2006/chart" r:id="rId2"/>
+          </a:graphicData>
+        </a:graphic>
+      </p:graphicFrame>
+      <p:graphicFrame>
+        <p:nvGraphicFramePr>
+          <p:cNvPr id="4" name="Chart 3"/>
+          <p:cNvGraphicFramePr>
+            <a:graphicFrameLocks noGrp="1"/>
+          </p:cNvGraphicFramePr>
+          <p:nvPr/>
+        </p:nvGraphicFramePr>
+        <p:xfrm>
+          <a:off x="4572000" y="1371600"/>
+          <a:ext cx="4114800" cy="3657600"/>
+        </p:xfrm>
+        <a:graphic>
+          <a:graphicData uri="http://schemas.openxmlformats.org/drawingml/2006/chart">
+            <c:chart xmlns:c="http://schemas.openxmlformats.org/drawingml/2006/chart" r:id="rId3"/>
           </a:graphicData>
         </a:graphic>
       </p:graphicFrame>

</xml_diff>

<commit_message>
chart titles as text boxes
</commit_message>
<xml_diff>
--- a/notebooks/demo.pptx
+++ b/notebooks/demo.pptx
@@ -11,6 +11,7 @@
     <p:sldId id="256" r:id="rId18"/>
     <p:sldId id="257" r:id="rId19"/>
     <p:sldId id="258" r:id="rId20"/>
+    <p:sldId id="259" r:id="rId21"/>
   </p:sldIdLst>
   <p:sldSz cx="12188825" cy="6858000"/>
   <p:notesSz cx="6858000" cy="9144000"/>
@@ -288,21 +289,6 @@
 <c:chartSpace xmlns:c="http://schemas.openxmlformats.org/drawingml/2006/chart" xmlns:a="http://schemas.openxmlformats.org/drawingml/2006/main" xmlns:r="http://schemas.openxmlformats.org/officeDocument/2006/relationships">
   <c:date1904 val="0"/>
   <c:chart>
-    <c:title>
-      <c:tx>
-        <c:rich>
-          <a:bodyPr/>
-          <a:lstStyle/>
-          <a:p>
-            <a:r>
-              <a:t>Revenue Trend - Chart Title</a:t>
-            </a:r>
-          </a:p>
-        </c:rich>
-      </c:tx>
-      <c:layout/>
-      <c:overlay val="0"/>
-    </c:title>
     <c:autoTitleDeleted val="0"/>
     <c:plotArea>
       <c:lineChart>
@@ -432,21 +418,6 @@
 <c:chartSpace xmlns:c="http://schemas.openxmlformats.org/drawingml/2006/chart" xmlns:a="http://schemas.openxmlformats.org/drawingml/2006/main" xmlns:r="http://schemas.openxmlformats.org/officeDocument/2006/relationships">
   <c:date1904 val="0"/>
   <c:chart>
-    <c:title>
-      <c:tx>
-        <c:rich>
-          <a:bodyPr/>
-          <a:lstStyle/>
-          <a:p>
-            <a:r>
-              <a:t>Revenue Trend - Chart Title</a:t>
-            </a:r>
-          </a:p>
-        </c:rich>
-      </c:tx>
-      <c:layout/>
-      <c:overlay val="0"/>
-    </c:title>
     <c:autoTitleDeleted val="0"/>
     <c:plotArea>
       <c:lineChart>
@@ -576,21 +547,122 @@
 <c:chartSpace xmlns:c="http://schemas.openxmlformats.org/drawingml/2006/chart" xmlns:a="http://schemas.openxmlformats.org/drawingml/2006/main" xmlns:r="http://schemas.openxmlformats.org/officeDocument/2006/relationships">
   <c:date1904 val="0"/>
   <c:chart>
-    <c:title>
-      <c:tx>
-        <c:rich>
-          <a:bodyPr/>
-          <a:lstStyle/>
-          <a:p>
-            <a:r>
-              <a:t>Revenue Trend - Chart Title</a:t>
-            </a:r>
-          </a:p>
-        </c:rich>
-      </c:tx>
-      <c:layout/>
-      <c:overlay val="0"/>
-    </c:title>
+    <c:autoTitleDeleted val="0"/>
+    <c:plotArea>
+      <c:barChart>
+        <c:barDir val="col"/>
+        <c:grouping val="clustered"/>
+        <c:ser>
+          <c:idx val="0"/>
+          <c:order val="0"/>
+          <c:tx>
+            <c:strRef>
+              <c:f>Sheet1!$B$1</c:f>
+              <c:strCache>
+                <c:ptCount val="1"/>
+                <c:pt idx="0">
+                  <c:v>revenue</c:v>
+                </c:pt>
+              </c:strCache>
+            </c:strRef>
+          </c:tx>
+          <c:cat>
+            <c:strRef>
+              <c:f>Sheet1!$A$2:$A$5</c:f>
+              <c:strCache>
+                <c:ptCount val="4"/>
+                <c:pt idx="0">
+                  <c:v>Jan</c:v>
+                </c:pt>
+                <c:pt idx="1">
+                  <c:v>Feb</c:v>
+                </c:pt>
+                <c:pt idx="2">
+                  <c:v>Mar</c:v>
+                </c:pt>
+                <c:pt idx="3">
+                  <c:v>Apr</c:v>
+                </c:pt>
+              </c:strCache>
+            </c:strRef>
+          </c:cat>
+          <c:val>
+            <c:numRef>
+              <c:f>Sheet1!$B$2:$B$5</c:f>
+              <c:numCache>
+                <c:formatCode>General</c:formatCode>
+                <c:ptCount val="4"/>
+                <c:pt idx="0">
+                  <c:v>10</c:v>
+                </c:pt>
+                <c:pt idx="1">
+                  <c:v>14</c:v>
+                </c:pt>
+                <c:pt idx="2">
+                  <c:v>9</c:v>
+                </c:pt>
+                <c:pt idx="3">
+                  <c:v>18</c:v>
+                </c:pt>
+              </c:numCache>
+            </c:numRef>
+          </c:val>
+        </c:ser>
+        <c:axId val="-2068027336"/>
+        <c:axId val="-2113994440"/>
+      </c:barChart>
+      <c:catAx>
+        <c:axId val="-2068027336"/>
+        <c:scaling>
+          <c:orientation val="minMax"/>
+        </c:scaling>
+        <c:delete val="0"/>
+        <c:axPos val="b"/>
+        <c:majorTickMark val="out"/>
+        <c:minorTickMark val="none"/>
+        <c:tickLblPos val="nextTo"/>
+        <c:crossAx val="-2113994440"/>
+        <c:crosses val="autoZero"/>
+        <c:auto val="1"/>
+        <c:lblAlgn val="ctr"/>
+        <c:lblOffset val="100"/>
+        <c:noMultiLvlLbl val="0"/>
+      </c:catAx>
+      <c:valAx>
+        <c:axId val="-2113994440"/>
+        <c:scaling/>
+        <c:delete val="0"/>
+        <c:axPos val="l"/>
+        <c:majorGridlines/>
+        <c:majorTickMark val="out"/>
+        <c:minorTickMark val="none"/>
+        <c:tickLblPos val="nextTo"/>
+        <c:crossAx val="-2068027336"/>
+        <c:crosses val="autoZero"/>
+      </c:valAx>
+    </c:plotArea>
+    <c:dispBlanksAs val="gap"/>
+  </c:chart>
+  <c:txPr>
+    <a:bodyPr/>
+    <a:lstStyle/>
+    <a:p>
+      <a:pPr>
+        <a:defRPr sz="1800"/>
+      </a:pPr>
+      <a:endParaRPr lang="en-US"/>
+    </a:p>
+  </c:txPr>
+  <c:externalData r:id="rId1">
+    <c:autoUpdate val="0"/>
+  </c:externalData>
+</c:chartSpace>
+</file>
+
+<file path=ppt/charts/chart4.xml><?xml version="1.0" encoding="utf-8"?>
+<c:chartSpace xmlns:c="http://schemas.openxmlformats.org/drawingml/2006/chart" xmlns:a="http://schemas.openxmlformats.org/drawingml/2006/main" xmlns:r="http://schemas.openxmlformats.org/officeDocument/2006/relationships">
+  <c:date1904 val="0"/>
+  <c:chart>
     <c:autoTitleDeleted val="0"/>
     <c:plotArea>
       <c:lineChart>
@@ -650,6 +722,251 @@
                 </c:pt>
                 <c:pt idx="3">
                   <c:v>18</c:v>
+                </c:pt>
+              </c:numCache>
+            </c:numRef>
+          </c:val>
+          <c:smooth val="0"/>
+        </c:ser>
+        <c:marker val="1"/>
+        <c:smooth val="0"/>
+        <c:axId val="2118791784"/>
+        <c:axId val="2140495176"/>
+      </c:lineChart>
+      <c:catAx>
+        <c:axId val="2118791784"/>
+        <c:scaling>
+          <c:orientation val="minMax"/>
+        </c:scaling>
+        <c:delete val="0"/>
+        <c:axPos val="b"/>
+        <c:majorTickMark val="out"/>
+        <c:minorTickMark val="none"/>
+        <c:tickLblPos val="nextTo"/>
+        <c:crossAx val="2140495176"/>
+        <c:crosses val="autoZero"/>
+        <c:auto val="1"/>
+        <c:lblAlgn val="ctr"/>
+        <c:lblOffset val="100"/>
+        <c:noMultiLvlLbl val="0"/>
+      </c:catAx>
+      <c:valAx>
+        <c:axId val="2140495176"/>
+        <c:scaling/>
+        <c:delete val="0"/>
+        <c:axPos val="l"/>
+        <c:majorGridlines/>
+        <c:majorTickMark val="out"/>
+        <c:minorTickMark val="none"/>
+        <c:tickLblPos val="nextTo"/>
+        <c:crossAx val="2118791784"/>
+        <c:crosses val="autoZero"/>
+      </c:valAx>
+    </c:plotArea>
+    <c:legend>
+      <c:legendPos val="r"/>
+      <c:layout/>
+      <c:overlay val="0"/>
+    </c:legend>
+    <c:plotVisOnly val="1"/>
+    <c:dispBlanksAs val="gap"/>
+    <c:showDLblsOverMax val="0"/>
+  </c:chart>
+  <c:txPr>
+    <a:bodyPr/>
+    <a:lstStyle/>
+    <a:p>
+      <a:pPr>
+        <a:defRPr sz="1800"/>
+      </a:pPr>
+      <a:endParaRPr lang="en-US"/>
+    </a:p>
+  </c:txPr>
+  <c:externalData r:id="rId1">
+    <c:autoUpdate val="0"/>
+  </c:externalData>
+</c:chartSpace>
+</file>
+
+<file path=ppt/charts/chart5.xml><?xml version="1.0" encoding="utf-8"?>
+<c:chartSpace xmlns:c="http://schemas.openxmlformats.org/drawingml/2006/chart" xmlns:a="http://schemas.openxmlformats.org/drawingml/2006/main" xmlns:r="http://schemas.openxmlformats.org/officeDocument/2006/relationships">
+  <c:date1904 val="0"/>
+  <c:chart>
+    <c:autoTitleDeleted val="0"/>
+    <c:plotArea>
+      <c:barChart>
+        <c:barDir val="col"/>
+        <c:grouping val="clustered"/>
+        <c:ser>
+          <c:idx val="0"/>
+          <c:order val="0"/>
+          <c:tx>
+            <c:strRef>
+              <c:f>Sheet1!$B$1</c:f>
+              <c:strCache>
+                <c:ptCount val="1"/>
+                <c:pt idx="0">
+                  <c:v>revenue</c:v>
+                </c:pt>
+              </c:strCache>
+            </c:strRef>
+          </c:tx>
+          <c:cat>
+            <c:strRef>
+              <c:f>Sheet1!$A$2:$A$5</c:f>
+              <c:strCache>
+                <c:ptCount val="4"/>
+                <c:pt idx="0">
+                  <c:v>Jan</c:v>
+                </c:pt>
+                <c:pt idx="1">
+                  <c:v>Feb</c:v>
+                </c:pt>
+                <c:pt idx="2">
+                  <c:v>Mar</c:v>
+                </c:pt>
+                <c:pt idx="3">
+                  <c:v>Apr</c:v>
+                </c:pt>
+              </c:strCache>
+            </c:strRef>
+          </c:cat>
+          <c:val>
+            <c:numRef>
+              <c:f>Sheet1!$B$2:$B$5</c:f>
+              <c:numCache>
+                <c:formatCode>General</c:formatCode>
+                <c:ptCount val="4"/>
+                <c:pt idx="0">
+                  <c:v>10</c:v>
+                </c:pt>
+                <c:pt idx="1">
+                  <c:v>14</c:v>
+                </c:pt>
+                <c:pt idx="2">
+                  <c:v>9</c:v>
+                </c:pt>
+                <c:pt idx="3">
+                  <c:v>18</c:v>
+                </c:pt>
+              </c:numCache>
+            </c:numRef>
+          </c:val>
+        </c:ser>
+        <c:axId val="-2068027336"/>
+        <c:axId val="-2113994440"/>
+      </c:barChart>
+      <c:catAx>
+        <c:axId val="-2068027336"/>
+        <c:scaling>
+          <c:orientation val="minMax"/>
+        </c:scaling>
+        <c:delete val="0"/>
+        <c:axPos val="b"/>
+        <c:majorTickMark val="out"/>
+        <c:minorTickMark val="none"/>
+        <c:tickLblPos val="nextTo"/>
+        <c:crossAx val="-2113994440"/>
+        <c:crosses val="autoZero"/>
+        <c:auto val="1"/>
+        <c:lblAlgn val="ctr"/>
+        <c:lblOffset val="100"/>
+        <c:noMultiLvlLbl val="0"/>
+      </c:catAx>
+      <c:valAx>
+        <c:axId val="-2113994440"/>
+        <c:scaling/>
+        <c:delete val="0"/>
+        <c:axPos val="l"/>
+        <c:majorGridlines/>
+        <c:majorTickMark val="out"/>
+        <c:minorTickMark val="none"/>
+        <c:tickLblPos val="nextTo"/>
+        <c:crossAx val="-2068027336"/>
+        <c:crosses val="autoZero"/>
+      </c:valAx>
+    </c:plotArea>
+    <c:dispBlanksAs val="gap"/>
+  </c:chart>
+  <c:txPr>
+    <a:bodyPr/>
+    <a:lstStyle/>
+    <a:p>
+      <a:pPr>
+        <a:defRPr sz="1800"/>
+      </a:pPr>
+      <a:endParaRPr lang="en-US"/>
+    </a:p>
+  </c:txPr>
+  <c:externalData r:id="rId1">
+    <c:autoUpdate val="0"/>
+  </c:externalData>
+</c:chartSpace>
+</file>
+
+<file path=ppt/charts/chart6.xml><?xml version="1.0" encoding="utf-8"?>
+<c:chartSpace xmlns:c="http://schemas.openxmlformats.org/drawingml/2006/chart" xmlns:a="http://schemas.openxmlformats.org/drawingml/2006/main" xmlns:r="http://schemas.openxmlformats.org/officeDocument/2006/relationships">
+  <c:date1904 val="0"/>
+  <c:chart>
+    <c:autoTitleDeleted val="0"/>
+    <c:plotArea>
+      <c:lineChart>
+        <c:grouping val="standard"/>
+        <c:varyColors val="0"/>
+        <c:ser>
+          <c:idx val="0"/>
+          <c:order val="0"/>
+          <c:tx>
+            <c:strRef>
+              <c:f>Sheet1!$B$1</c:f>
+              <c:strCache>
+                <c:ptCount val="1"/>
+                <c:pt idx="0">
+                  <c:v>revenue</c:v>
+                </c:pt>
+              </c:strCache>
+            </c:strRef>
+          </c:tx>
+          <c:marker>
+            <c:symbol val="none"/>
+          </c:marker>
+          <c:cat>
+            <c:strRef>
+              <c:f>Sheet1!$A$2:$A$5</c:f>
+              <c:strCache>
+                <c:ptCount val="4"/>
+                <c:pt idx="0">
+                  <c:v>JanJan</c:v>
+                </c:pt>
+                <c:pt idx="1">
+                  <c:v>FebFeb</c:v>
+                </c:pt>
+                <c:pt idx="2">
+                  <c:v>MarMar</c:v>
+                </c:pt>
+                <c:pt idx="3">
+                  <c:v>AprApr</c:v>
+                </c:pt>
+              </c:strCache>
+            </c:strRef>
+          </c:cat>
+          <c:val>
+            <c:numRef>
+              <c:f>Sheet1!$B$2:$B$5</c:f>
+              <c:numCache>
+                <c:formatCode>General</c:formatCode>
+                <c:ptCount val="4"/>
+                <c:pt idx="0">
+                  <c:v>20</c:v>
+                </c:pt>
+                <c:pt idx="1">
+                  <c:v>28</c:v>
+                </c:pt>
+                <c:pt idx="2">
+                  <c:v>18</c:v>
+                </c:pt>
+                <c:pt idx="3">
+                  <c:v>36</c:v>
                 </c:pt>
               </c:numCache>
             </c:numRef>
@@ -3873,17 +4190,24 @@
       <p:grpSpPr/>
       <p:sp>
         <p:nvSpPr>
-          <p:cNvPr id="2" name="Title 1"/>
-          <p:cNvSpPr>
-            <a:spLocks noGrp="1"/>
-          </p:cNvSpPr>
-          <p:nvPr>
-            <p:ph type="title"/>
-          </p:nvPr>
+          <p:cNvPr id="2" name="TextBox 1"/>
+          <p:cNvSpPr txBox="1"/>
+          <p:nvPr/>
         </p:nvSpPr>
-        <p:spPr/>
+        <p:spPr>
+          <a:xfrm>
+            <a:off x="914400" y="274320"/>
+            <a:ext cx="7315200" cy="731520"/>
+          </a:xfrm>
+          <a:prstGeom prst="rect">
+            <a:avLst/>
+          </a:prstGeom>
+          <a:noFill/>
+        </p:spPr>
         <p:txBody>
-          <a:bodyPr/>
+          <a:bodyPr wrap="none">
+            <a:spAutoFit/>
+          </a:bodyPr>
           <a:lstStyle/>
           <a:p>
             <a:r>
@@ -3901,7 +4225,7 @@
           <p:nvPr/>
         </p:nvGraphicFramePr>
         <p:xfrm>
-          <a:off x="914400" y="1371600"/>
+          <a:off x="914400" y="1554480"/>
           <a:ext cx="7315200" cy="4114800"/>
         </p:xfrm>
         <a:graphic>
@@ -3910,6 +4234,34 @@
           </a:graphicData>
         </a:graphic>
       </p:graphicFrame>
+      <p:sp>
+        <p:nvSpPr>
+          <p:cNvPr id="4" name="TextBox 3"/>
+          <p:cNvSpPr txBox="1"/>
+          <p:nvPr/>
+        </p:nvSpPr>
+        <p:spPr>
+          <a:xfrm>
+            <a:off x="914400" y="1097280"/>
+            <a:ext cx="7315200" cy="365760"/>
+          </a:xfrm>
+          <a:prstGeom prst="rect">
+            <a:avLst/>
+          </a:prstGeom>
+          <a:noFill/>
+        </p:spPr>
+        <p:txBody>
+          <a:bodyPr wrap="none">
+            <a:spAutoFit/>
+          </a:bodyPr>
+          <a:lstStyle/>
+          <a:p>
+            <a:r>
+              <a:t>Revenue Trend (Line) - Chart Title</a:t>
+            </a:r>
+          </a:p>
+        </p:txBody>
+      </p:sp>
     </p:spTree>
   </p:cSld>
   <p:clrMapOvr>
@@ -3930,17 +4282,24 @@
       <p:grpSpPr/>
       <p:sp>
         <p:nvSpPr>
-          <p:cNvPr id="2" name="Title 1"/>
-          <p:cNvSpPr>
-            <a:spLocks noGrp="1"/>
-          </p:cNvSpPr>
-          <p:nvPr>
-            <p:ph type="title"/>
-          </p:nvPr>
+          <p:cNvPr id="2" name="TextBox 1"/>
+          <p:cNvSpPr txBox="1"/>
+          <p:nvPr/>
         </p:nvSpPr>
-        <p:spPr/>
+        <p:spPr>
+          <a:xfrm>
+            <a:off x="914400" y="274320"/>
+            <a:ext cx="7315200" cy="731520"/>
+          </a:xfrm>
+          <a:prstGeom prst="rect">
+            <a:avLst/>
+          </a:prstGeom>
+          <a:noFill/>
+        </p:spPr>
         <p:txBody>
-          <a:bodyPr/>
+          <a:bodyPr wrap="none">
+            <a:spAutoFit/>
+          </a:bodyPr>
           <a:lstStyle/>
           <a:p>
             <a:r>
@@ -3958,7 +4317,7 @@
           <p:nvPr/>
         </p:nvGraphicFramePr>
         <p:xfrm>
-          <a:off x="457200" y="1371600"/>
+          <a:off x="457200" y="1554480"/>
           <a:ext cx="4114800" cy="3657600"/>
         </p:xfrm>
         <a:graphic>
@@ -3967,16 +4326,44 @@
           </a:graphicData>
         </a:graphic>
       </p:graphicFrame>
+      <p:sp>
+        <p:nvSpPr>
+          <p:cNvPr id="4" name="TextBox 3"/>
+          <p:cNvSpPr txBox="1"/>
+          <p:nvPr/>
+        </p:nvSpPr>
+        <p:spPr>
+          <a:xfrm>
+            <a:off x="457200" y="1097280"/>
+            <a:ext cx="4114800" cy="365760"/>
+          </a:xfrm>
+          <a:prstGeom prst="rect">
+            <a:avLst/>
+          </a:prstGeom>
+          <a:noFill/>
+        </p:spPr>
+        <p:txBody>
+          <a:bodyPr wrap="none">
+            <a:spAutoFit/>
+          </a:bodyPr>
+          <a:lstStyle/>
+          <a:p>
+            <a:r>
+              <a:t>Revenue Trend (Line) - Chart Title</a:t>
+            </a:r>
+          </a:p>
+        </p:txBody>
+      </p:sp>
       <p:graphicFrame>
         <p:nvGraphicFramePr>
-          <p:cNvPr id="4" name="Chart 3"/>
+          <p:cNvPr id="5" name="Chart 4"/>
           <p:cNvGraphicFramePr>
             <a:graphicFrameLocks noGrp="1"/>
           </p:cNvGraphicFramePr>
           <p:nvPr/>
         </p:nvGraphicFramePr>
         <p:xfrm>
-          <a:off x="4572000" y="1371600"/>
+          <a:off x="4572000" y="1554480"/>
           <a:ext cx="4114800" cy="3657600"/>
         </p:xfrm>
         <a:graphic>
@@ -3985,6 +4372,218 @@
           </a:graphicData>
         </a:graphic>
       </p:graphicFrame>
+      <p:sp>
+        <p:nvSpPr>
+          <p:cNvPr id="6" name="TextBox 5"/>
+          <p:cNvSpPr txBox="1"/>
+          <p:nvPr/>
+        </p:nvSpPr>
+        <p:spPr>
+          <a:xfrm>
+            <a:off x="4572000" y="1097280"/>
+            <a:ext cx="4114800" cy="365760"/>
+          </a:xfrm>
+          <a:prstGeom prst="rect">
+            <a:avLst/>
+          </a:prstGeom>
+          <a:noFill/>
+        </p:spPr>
+        <p:txBody>
+          <a:bodyPr wrap="none">
+            <a:spAutoFit/>
+          </a:bodyPr>
+          <a:lstStyle/>
+          <a:p>
+            <a:r>
+              <a:t>Revenue (Bar) - Chart Title</a:t>
+            </a:r>
+          </a:p>
+        </p:txBody>
+      </p:sp>
+    </p:spTree>
+  </p:cSld>
+  <p:clrMapOvr>
+    <a:masterClrMapping/>
+  </p:clrMapOvr>
+</p:sld>
+</file>
+
+<file path=ppt/slides/slide4.xml><?xml version="1.0" encoding="utf-8"?>
+<p:sld xmlns:a="http://schemas.openxmlformats.org/drawingml/2006/main" xmlns:p="http://schemas.openxmlformats.org/presentationml/2006/main" xmlns:r="http://schemas.openxmlformats.org/officeDocument/2006/relationships">
+  <p:cSld>
+    <p:spTree>
+      <p:nvGrpSpPr>
+        <p:cNvPr id="1" name=""/>
+        <p:cNvGrpSpPr/>
+        <p:nvPr/>
+      </p:nvGrpSpPr>
+      <p:grpSpPr/>
+      <p:sp>
+        <p:nvSpPr>
+          <p:cNvPr id="2" name="TextBox 1"/>
+          <p:cNvSpPr txBox="1"/>
+          <p:nvPr/>
+        </p:nvSpPr>
+        <p:spPr>
+          <a:xfrm>
+            <a:off x="914400" y="274320"/>
+            <a:ext cx="7315200" cy="731520"/>
+          </a:xfrm>
+          <a:prstGeom prst="rect">
+            <a:avLst/>
+          </a:prstGeom>
+          <a:noFill/>
+        </p:spPr>
+        <p:txBody>
+          <a:bodyPr wrap="none">
+            <a:spAutoFit/>
+          </a:bodyPr>
+          <a:lstStyle/>
+          <a:p>
+            <a:r>
+              <a:t>Revenue Trend - Slide Title</a:t>
+            </a:r>
+          </a:p>
+        </p:txBody>
+      </p:sp>
+      <p:graphicFrame>
+        <p:nvGraphicFramePr>
+          <p:cNvPr id="3" name="Chart 2"/>
+          <p:cNvGraphicFramePr>
+            <a:graphicFrameLocks noGrp="1"/>
+          </p:cNvGraphicFramePr>
+          <p:nvPr/>
+        </p:nvGraphicFramePr>
+        <p:xfrm>
+          <a:off x="457200" y="1554480"/>
+          <a:ext cx="2743200" cy="3657600"/>
+        </p:xfrm>
+        <a:graphic>
+          <a:graphicData uri="http://schemas.openxmlformats.org/drawingml/2006/chart">
+            <c:chart xmlns:c="http://schemas.openxmlformats.org/drawingml/2006/chart" r:id="rId2"/>
+          </a:graphicData>
+        </a:graphic>
+      </p:graphicFrame>
+      <p:sp>
+        <p:nvSpPr>
+          <p:cNvPr id="4" name="TextBox 3"/>
+          <p:cNvSpPr txBox="1"/>
+          <p:nvPr/>
+        </p:nvSpPr>
+        <p:spPr>
+          <a:xfrm>
+            <a:off x="457200" y="1097280"/>
+            <a:ext cx="2743200" cy="365760"/>
+          </a:xfrm>
+          <a:prstGeom prst="rect">
+            <a:avLst/>
+          </a:prstGeom>
+          <a:noFill/>
+        </p:spPr>
+        <p:txBody>
+          <a:bodyPr wrap="none">
+            <a:spAutoFit/>
+          </a:bodyPr>
+          <a:lstStyle/>
+          <a:p>
+            <a:r>
+              <a:t>Revenue Trend (Line) - Chart Title</a:t>
+            </a:r>
+          </a:p>
+        </p:txBody>
+      </p:sp>
+      <p:graphicFrame>
+        <p:nvGraphicFramePr>
+          <p:cNvPr id="5" name="Chart 4"/>
+          <p:cNvGraphicFramePr>
+            <a:graphicFrameLocks noGrp="1"/>
+          </p:cNvGraphicFramePr>
+          <p:nvPr/>
+        </p:nvGraphicFramePr>
+        <p:xfrm>
+          <a:off x="3200400" y="1554480"/>
+          <a:ext cx="2743200" cy="3657600"/>
+        </p:xfrm>
+        <a:graphic>
+          <a:graphicData uri="http://schemas.openxmlformats.org/drawingml/2006/chart">
+            <c:chart xmlns:c="http://schemas.openxmlformats.org/drawingml/2006/chart" r:id="rId3"/>
+          </a:graphicData>
+        </a:graphic>
+      </p:graphicFrame>
+      <p:sp>
+        <p:nvSpPr>
+          <p:cNvPr id="6" name="TextBox 5"/>
+          <p:cNvSpPr txBox="1"/>
+          <p:nvPr/>
+        </p:nvSpPr>
+        <p:spPr>
+          <a:xfrm>
+            <a:off x="3200400" y="1097280"/>
+            <a:ext cx="2743200" cy="365760"/>
+          </a:xfrm>
+          <a:prstGeom prst="rect">
+            <a:avLst/>
+          </a:prstGeom>
+          <a:noFill/>
+        </p:spPr>
+        <p:txBody>
+          <a:bodyPr wrap="none">
+            <a:spAutoFit/>
+          </a:bodyPr>
+          <a:lstStyle/>
+          <a:p>
+            <a:r>
+              <a:t>Revenue (Bar) - Chart Title</a:t>
+            </a:r>
+          </a:p>
+        </p:txBody>
+      </p:sp>
+      <p:graphicFrame>
+        <p:nvGraphicFramePr>
+          <p:cNvPr id="7" name="Chart 6"/>
+          <p:cNvGraphicFramePr>
+            <a:graphicFrameLocks noGrp="1"/>
+          </p:cNvGraphicFramePr>
+          <p:nvPr/>
+        </p:nvGraphicFramePr>
+        <p:xfrm>
+          <a:off x="5943600" y="1554480"/>
+          <a:ext cx="2743200" cy="3657600"/>
+        </p:xfrm>
+        <a:graphic>
+          <a:graphicData uri="http://schemas.openxmlformats.org/drawingml/2006/chart">
+            <c:chart xmlns:c="http://schemas.openxmlformats.org/drawingml/2006/chart" r:id="rId4"/>
+          </a:graphicData>
+        </a:graphic>
+      </p:graphicFrame>
+      <p:sp>
+        <p:nvSpPr>
+          <p:cNvPr id="8" name="TextBox 7"/>
+          <p:cNvSpPr txBox="1"/>
+          <p:nvPr/>
+        </p:nvSpPr>
+        <p:spPr>
+          <a:xfrm>
+            <a:off x="5943600" y="1097280"/>
+            <a:ext cx="2743200" cy="365760"/>
+          </a:xfrm>
+          <a:prstGeom prst="rect">
+            <a:avLst/>
+          </a:prstGeom>
+          <a:noFill/>
+        </p:spPr>
+        <p:txBody>
+          <a:bodyPr wrap="none">
+            <a:spAutoFit/>
+          </a:bodyPr>
+          <a:lstStyle/>
+          <a:p>
+            <a:r>
+              <a:t>Revenue Trend (Line) - Chart Title</a:t>
+            </a:r>
+          </a:p>
+        </p:txBody>
+      </p:sp>
     </p:spTree>
   </p:cSld>
   <p:clrMapOvr>

</xml_diff>

<commit_message>
one chart slide layout
</commit_message>
<xml_diff>
--- a/notebooks/demo.pptx
+++ b/notebooks/demo.pptx
@@ -4196,8 +4196,8 @@
         </p:nvSpPr>
         <p:spPr>
           <a:xfrm>
-            <a:off x="914400" y="274320"/>
-            <a:ext cx="7315200" cy="731520"/>
+            <a:off x="457200" y="91440"/>
+            <a:ext cx="11430000" cy="731520"/>
           </a:xfrm>
           <a:prstGeom prst="rect">
             <a:avLst/>
@@ -4225,8 +4225,8 @@
           <p:nvPr/>
         </p:nvGraphicFramePr>
         <p:xfrm>
-          <a:off x="914400" y="1554480"/>
-          <a:ext cx="7315200" cy="4114800"/>
+          <a:off x="457200" y="1463040"/>
+          <a:ext cx="11430000" cy="4800600"/>
         </p:xfrm>
         <a:graphic>
           <a:graphicData uri="http://schemas.openxmlformats.org/drawingml/2006/chart">
@@ -4242,8 +4242,8 @@
         </p:nvSpPr>
         <p:spPr>
           <a:xfrm>
-            <a:off x="914400" y="1097280"/>
-            <a:ext cx="7315200" cy="365760"/>
+            <a:off x="457200" y="1005840"/>
+            <a:ext cx="11430000" cy="457200"/>
           </a:xfrm>
           <a:prstGeom prst="rect">
             <a:avLst/>
@@ -4288,8 +4288,8 @@
         </p:nvSpPr>
         <p:spPr>
           <a:xfrm>
-            <a:off x="914400" y="274320"/>
-            <a:ext cx="7315200" cy="731520"/>
+            <a:off x="457200" y="91440"/>
+            <a:ext cx="11430000" cy="731520"/>
           </a:xfrm>
           <a:prstGeom prst="rect">
             <a:avLst/>
@@ -4426,8 +4426,8 @@
         </p:nvSpPr>
         <p:spPr>
           <a:xfrm>
-            <a:off x="914400" y="274320"/>
-            <a:ext cx="7315200" cy="731520"/>
+            <a:off x="457200" y="91440"/>
+            <a:ext cx="11430000" cy="731520"/>
           </a:xfrm>
           <a:prstGeom prst="rect">
             <a:avLst/>

</xml_diff>

<commit_message>
two, three chart layouts
</commit_message>
<xml_diff>
--- a/notebooks/demo.pptx
+++ b/notebooks/demo.pptx
@@ -4317,8 +4317,8 @@
           <p:nvPr/>
         </p:nvGraphicFramePr>
         <p:xfrm>
-          <a:off x="457200" y="1554480"/>
-          <a:ext cx="4114800" cy="3657600"/>
+          <a:off x="457200" y="1463040"/>
+          <a:ext cx="5715000" cy="4800600"/>
         </p:xfrm>
         <a:graphic>
           <a:graphicData uri="http://schemas.openxmlformats.org/drawingml/2006/chart">
@@ -4334,8 +4334,8 @@
         </p:nvSpPr>
         <p:spPr>
           <a:xfrm>
-            <a:off x="457200" y="1097280"/>
-            <a:ext cx="4114800" cy="365760"/>
+            <a:off x="457200" y="1005840"/>
+            <a:ext cx="5715000" cy="457200"/>
           </a:xfrm>
           <a:prstGeom prst="rect">
             <a:avLst/>
@@ -4363,8 +4363,8 @@
           <p:nvPr/>
         </p:nvGraphicFramePr>
         <p:xfrm>
-          <a:off x="4572000" y="1554480"/>
-          <a:ext cx="4114800" cy="3657600"/>
+          <a:off x="6172200" y="1463040"/>
+          <a:ext cx="5715000" cy="4800600"/>
         </p:xfrm>
         <a:graphic>
           <a:graphicData uri="http://schemas.openxmlformats.org/drawingml/2006/chart">
@@ -4380,8 +4380,8 @@
         </p:nvSpPr>
         <p:spPr>
           <a:xfrm>
-            <a:off x="4572000" y="1097280"/>
-            <a:ext cx="4114800" cy="365760"/>
+            <a:off x="6172200" y="1005840"/>
+            <a:ext cx="5715000" cy="457200"/>
           </a:xfrm>
           <a:prstGeom prst="rect">
             <a:avLst/>
@@ -4455,8 +4455,8 @@
           <p:nvPr/>
         </p:nvGraphicFramePr>
         <p:xfrm>
-          <a:off x="457200" y="1554480"/>
-          <a:ext cx="2743200" cy="3657600"/>
+          <a:off x="457200" y="1463040"/>
+          <a:ext cx="3813048" cy="4800600"/>
         </p:xfrm>
         <a:graphic>
           <a:graphicData uri="http://schemas.openxmlformats.org/drawingml/2006/chart">
@@ -4472,8 +4472,8 @@
         </p:nvSpPr>
         <p:spPr>
           <a:xfrm>
-            <a:off x="457200" y="1097280"/>
-            <a:ext cx="2743200" cy="365760"/>
+            <a:off x="457200" y="1005840"/>
+            <a:ext cx="3813048" cy="457200"/>
           </a:xfrm>
           <a:prstGeom prst="rect">
             <a:avLst/>
@@ -4501,8 +4501,8 @@
           <p:nvPr/>
         </p:nvGraphicFramePr>
         <p:xfrm>
-          <a:off x="3200400" y="1554480"/>
-          <a:ext cx="2743200" cy="3657600"/>
+          <a:off x="4270248" y="1463040"/>
+          <a:ext cx="3813048" cy="4800600"/>
         </p:xfrm>
         <a:graphic>
           <a:graphicData uri="http://schemas.openxmlformats.org/drawingml/2006/chart">
@@ -4518,8 +4518,8 @@
         </p:nvSpPr>
         <p:spPr>
           <a:xfrm>
-            <a:off x="3200400" y="1097280"/>
-            <a:ext cx="2743200" cy="365760"/>
+            <a:off x="4270248" y="1005840"/>
+            <a:ext cx="3813048" cy="457200"/>
           </a:xfrm>
           <a:prstGeom prst="rect">
             <a:avLst/>
@@ -4547,8 +4547,8 @@
           <p:nvPr/>
         </p:nvGraphicFramePr>
         <p:xfrm>
-          <a:off x="5943600" y="1554480"/>
-          <a:ext cx="2743200" cy="3657600"/>
+          <a:off x="8083296" y="1463040"/>
+          <a:ext cx="3813048" cy="4800600"/>
         </p:xfrm>
         <a:graphic>
           <a:graphicData uri="http://schemas.openxmlformats.org/drawingml/2006/chart">
@@ -4564,8 +4564,8 @@
         </p:nvSpPr>
         <p:spPr>
           <a:xfrm>
-            <a:off x="5943600" y="1097280"/>
-            <a:ext cx="2743200" cy="365760"/>
+            <a:off x="8083296" y="1005840"/>
+            <a:ext cx="3813048" cy="457200"/>
           </a:xfrm>
           <a:prstGeom prst="rect">
             <a:avLst/>

</xml_diff>

<commit_message>
explicitly set legend to visible
</commit_message>
<xml_diff>
--- a/notebooks/demo.pptx
+++ b/notebooks/demo.pptx
@@ -686,6 +686,19 @@
         <c:crosses val="autoZero"/>
       </c:valAx>
     </c:plotArea>
+    <c:legend>
+      <c:legendPos val="b"/>
+      <c:overlay val="0"/>
+      <c:txPr>
+        <a:bodyPr/>
+        <a:lstStyle/>
+        <a:p>
+          <a:pPr>
+            <a:defRPr sz="1000"/>
+          </a:pPr>
+        </a:p>
+      </c:txPr>
+    </c:legend>
     <c:dispBlanksAs val="gap"/>
   </c:chart>
   <c:txPr>
@@ -958,6 +971,19 @@
         <c:crosses val="autoZero"/>
       </c:valAx>
     </c:plotArea>
+    <c:legend>
+      <c:legendPos val="b"/>
+      <c:overlay val="0"/>
+      <c:txPr>
+        <a:bodyPr/>
+        <a:lstStyle/>
+        <a:p>
+          <a:pPr>
+            <a:defRPr sz="1000"/>
+          </a:pPr>
+        </a:p>
+      </c:txPr>
+    </c:legend>
     <c:dispBlanksAs val="gap"/>
   </c:chart>
   <c:txPr>

</xml_diff>

<commit_message>
category axis font size matches value axis
</commit_message>
<xml_diff>
--- a/notebooks/demo.pptx
+++ b/notebooks/demo.pptx
@@ -369,6 +369,15 @@
         <c:majorTickMark val="out"/>
         <c:minorTickMark val="none"/>
         <c:tickLblPos val="nextTo"/>
+        <c:txPr>
+          <a:bodyPr/>
+          <a:lstStyle/>
+          <a:p>
+            <a:pPr>
+              <a:defRPr sz="1400"/>
+            </a:pPr>
+          </a:p>
+        </c:txPr>
         <c:crossAx val="2140495176"/>
         <c:crosses val="autoZero"/>
         <c:auto val="1"/>
@@ -516,6 +525,15 @@
         <c:majorTickMark val="out"/>
         <c:minorTickMark val="none"/>
         <c:tickLblPos val="nextTo"/>
+        <c:txPr>
+          <a:bodyPr/>
+          <a:lstStyle/>
+          <a:p>
+            <a:pPr>
+              <a:defRPr sz="1200"/>
+            </a:pPr>
+          </a:p>
+        </c:txPr>
         <c:crossAx val="2140495176"/>
         <c:crosses val="autoZero"/>
         <c:auto val="1"/>
@@ -658,6 +676,15 @@
         <c:majorTickMark val="out"/>
         <c:minorTickMark val="none"/>
         <c:tickLblPos val="nextTo"/>
+        <c:txPr>
+          <a:bodyPr/>
+          <a:lstStyle/>
+          <a:p>
+            <a:pPr>
+              <a:defRPr sz="1200"/>
+            </a:pPr>
+          </a:p>
+        </c:txPr>
         <c:crossAx val="-2113994440"/>
         <c:crosses val="autoZero"/>
         <c:auto val="1"/>
@@ -802,6 +829,15 @@
         <c:majorTickMark val="out"/>
         <c:minorTickMark val="none"/>
         <c:tickLblPos val="nextTo"/>
+        <c:txPr>
+          <a:bodyPr/>
+          <a:lstStyle/>
+          <a:p>
+            <a:pPr>
+              <a:defRPr sz="1200"/>
+            </a:pPr>
+          </a:p>
+        </c:txPr>
         <c:crossAx val="2140495176"/>
         <c:crosses val="autoZero"/>
         <c:auto val="1"/>
@@ -944,6 +980,15 @@
         <c:majorTickMark val="out"/>
         <c:minorTickMark val="none"/>
         <c:tickLblPos val="nextTo"/>
+        <c:txPr>
+          <a:bodyPr/>
+          <a:lstStyle/>
+          <a:p>
+            <a:pPr>
+              <a:defRPr sz="1200"/>
+            </a:pPr>
+          </a:p>
+        </c:txPr>
         <c:crossAx val="-2113994440"/>
         <c:crosses val="autoZero"/>
         <c:auto val="1"/>
@@ -1088,6 +1133,15 @@
         <c:majorTickMark val="out"/>
         <c:minorTickMark val="none"/>
         <c:tickLblPos val="nextTo"/>
+        <c:txPr>
+          <a:bodyPr/>
+          <a:lstStyle/>
+          <a:p>
+            <a:pPr>
+              <a:defRPr sz="1200"/>
+            </a:pPr>
+          </a:p>
+        </c:txPr>
         <c:crossAx val="2140495176"/>
         <c:crosses val="autoZero"/>
         <c:auto val="1"/>

</xml_diff>

<commit_message>
toggle on/off chart titles
</commit_message>
<xml_diff>
--- a/notebooks/demo.pptx
+++ b/notebooks/demo.pptx
@@ -289,7 +289,7 @@
 <c:chartSpace xmlns:c="http://schemas.openxmlformats.org/drawingml/2006/chart" xmlns:a="http://schemas.openxmlformats.org/drawingml/2006/main" xmlns:r="http://schemas.openxmlformats.org/officeDocument/2006/relationships">
   <c:date1904 val="0"/>
   <c:chart>
-    <c:autoTitleDeleted val="0"/>
+    <c:autoTitleDeleted val="1"/>
     <c:plotArea>
       <c:lineChart>
         <c:grouping val="standard"/>
@@ -445,7 +445,7 @@
 <c:chartSpace xmlns:c="http://schemas.openxmlformats.org/drawingml/2006/chart" xmlns:a="http://schemas.openxmlformats.org/drawingml/2006/main" xmlns:r="http://schemas.openxmlformats.org/officeDocument/2006/relationships">
   <c:date1904 val="0"/>
   <c:chart>
-    <c:autoTitleDeleted val="0"/>
+    <c:autoTitleDeleted val="1"/>
     <c:plotArea>
       <c:lineChart>
         <c:grouping val="standard"/>
@@ -601,7 +601,7 @@
 <c:chartSpace xmlns:c="http://schemas.openxmlformats.org/drawingml/2006/chart" xmlns:a="http://schemas.openxmlformats.org/drawingml/2006/main" xmlns:r="http://schemas.openxmlformats.org/officeDocument/2006/relationships">
   <c:date1904 val="0"/>
   <c:chart>
-    <c:autoTitleDeleted val="0"/>
+    <c:autoTitleDeleted val="1"/>
     <c:plotArea>
       <c:barChart>
         <c:barDir val="col"/>
@@ -749,7 +749,7 @@
 <c:chartSpace xmlns:c="http://schemas.openxmlformats.org/drawingml/2006/chart" xmlns:a="http://schemas.openxmlformats.org/drawingml/2006/main" xmlns:r="http://schemas.openxmlformats.org/officeDocument/2006/relationships">
   <c:date1904 val="0"/>
   <c:chart>
-    <c:autoTitleDeleted val="0"/>
+    <c:autoTitleDeleted val="1"/>
     <c:plotArea>
       <c:lineChart>
         <c:grouping val="standard"/>
@@ -905,7 +905,7 @@
 <c:chartSpace xmlns:c="http://schemas.openxmlformats.org/drawingml/2006/chart" xmlns:a="http://schemas.openxmlformats.org/drawingml/2006/main" xmlns:r="http://schemas.openxmlformats.org/officeDocument/2006/relationships">
   <c:date1904 val="0"/>
   <c:chart>
-    <c:autoTitleDeleted val="0"/>
+    <c:autoTitleDeleted val="1"/>
     <c:plotArea>
       <c:barChart>
         <c:barDir val="col"/>
@@ -1053,7 +1053,7 @@
 <c:chartSpace xmlns:c="http://schemas.openxmlformats.org/drawingml/2006/chart" xmlns:a="http://schemas.openxmlformats.org/drawingml/2006/main" xmlns:r="http://schemas.openxmlformats.org/officeDocument/2006/relationships">
   <c:date1904 val="0"/>
   <c:chart>
-    <c:autoTitleDeleted val="0"/>
+    <c:autoTitleDeleted val="1"/>
     <c:plotArea>
       <c:lineChart>
         <c:grouping val="standard"/>

</xml_diff>

<commit_message>
update default legend font size
</commit_message>
<xml_diff>
--- a/notebooks/demo.pptx
+++ b/notebooks/demo.pptx
@@ -408,7 +408,7 @@
       </c:valAx>
     </c:plotArea>
     <c:legend>
-      <c:legendPos val="b"/>
+      <c:legendPos val="t"/>
       <c:layout/>
       <c:overlay val="0"/>
       <c:txPr>
@@ -416,7 +416,7 @@
         <a:lstStyle/>
         <a:p>
           <a:pPr>
-            <a:defRPr sz="1200"/>
+            <a:defRPr sz="1200" i="0"/>
           </a:pPr>
         </a:p>
       </c:txPr>
@@ -564,7 +564,7 @@
       </c:valAx>
     </c:plotArea>
     <c:legend>
-      <c:legendPos val="b"/>
+      <c:legendPos val="t"/>
       <c:layout/>
       <c:overlay val="0"/>
       <c:txPr>
@@ -572,7 +572,7 @@
         <a:lstStyle/>
         <a:p>
           <a:pPr>
-            <a:defRPr sz="1000"/>
+            <a:defRPr sz="1000" i="0"/>
           </a:pPr>
         </a:p>
       </c:txPr>
@@ -715,14 +715,14 @@
       </c:valAx>
     </c:plotArea>
     <c:legend>
-      <c:legendPos val="b"/>
+      <c:legendPos val="t"/>
       <c:overlay val="0"/>
       <c:txPr>
         <a:bodyPr/>
         <a:lstStyle/>
         <a:p>
           <a:pPr>
-            <a:defRPr sz="1000"/>
+            <a:defRPr sz="1000" i="0"/>
           </a:pPr>
         </a:p>
       </c:txPr>
@@ -868,7 +868,7 @@
       </c:valAx>
     </c:plotArea>
     <c:legend>
-      <c:legendPos val="b"/>
+      <c:legendPos val="t"/>
       <c:layout/>
       <c:overlay val="0"/>
       <c:txPr>
@@ -876,7 +876,7 @@
         <a:lstStyle/>
         <a:p>
           <a:pPr>
-            <a:defRPr sz="1000"/>
+            <a:defRPr sz="1000" i="0"/>
           </a:pPr>
         </a:p>
       </c:txPr>
@@ -1019,14 +1019,14 @@
       </c:valAx>
     </c:plotArea>
     <c:legend>
-      <c:legendPos val="b"/>
+      <c:legendPos val="t"/>
       <c:overlay val="0"/>
       <c:txPr>
         <a:bodyPr/>
         <a:lstStyle/>
         <a:p>
           <a:pPr>
-            <a:defRPr sz="1000"/>
+            <a:defRPr sz="1000" i="0"/>
           </a:pPr>
         </a:p>
       </c:txPr>
@@ -1172,7 +1172,7 @@
       </c:valAx>
     </c:plotArea>
     <c:legend>
-      <c:legendPos val="b"/>
+      <c:legendPos val="t"/>
       <c:layout/>
       <c:overlay val="0"/>
       <c:txPr>
@@ -1180,7 +1180,7 @@
         <a:lstStyle/>
         <a:p>
           <a:pPr>
-            <a:defRPr sz="1000"/>
+            <a:defRPr sz="1000" i="0"/>
           </a:pPr>
         </a:p>
       </c:txPr>

</xml_diff>

<commit_message>
consistent value axis range
</commit_message>
<xml_diff>
--- a/notebooks/demo.pptx
+++ b/notebooks/demo.pptx
@@ -13,6 +13,7 @@
     <p:sldId id="258" r:id="rId20"/>
     <p:sldId id="259" r:id="rId21"/>
     <p:sldId id="260" r:id="rId22"/>
+    <p:sldId id="261" r:id="rId23"/>
   </p:sldIdLst>
   <p:sldSz cx="12188825" cy="6858000"/>
   <p:notesSz cx="6858000" cy="9144000"/>
@@ -490,6 +491,837 @@
         <c:axId val="2140495176"/>
         <c:scaling>
           <c:max val="100.0"/>
+          <c:min val="0.0"/>
+        </c:scaling>
+        <c:delete val="0"/>
+        <c:axPos val="l"/>
+        <c:title>
+          <c:tx>
+            <c:rich>
+              <a:bodyPr/>
+              <a:lstStyle/>
+              <a:p>
+                <a:pPr>
+                  <a:defRPr sz="1400" b="1" i="0" u="none"/>
+                </a:pPr>
+                <a:r>
+                  <a:t>Month</a:t>
+                </a:r>
+              </a:p>
+            </c:rich>
+          </c:tx>
+          <c:layout/>
+          <c:overlay val="0"/>
+        </c:title>
+        <c:numFmt formatCode="$0.0" sourceLinked="0"/>
+        <c:majorTickMark val="out"/>
+        <c:minorTickMark val="none"/>
+        <c:tickLblPos val="nextTo"/>
+        <c:txPr>
+          <a:bodyPr/>
+          <a:lstStyle/>
+          <a:p>
+            <a:pPr>
+              <a:defRPr sz="1400"/>
+            </a:pPr>
+          </a:p>
+        </c:txPr>
+        <c:crossAx val="2118791784"/>
+        <c:crosses val="autoZero"/>
+      </c:valAx>
+    </c:plotArea>
+    <c:legend>
+      <c:legendPos val="b"/>
+      <c:layout/>
+      <c:overlay val="0"/>
+      <c:txPr>
+        <a:bodyPr/>
+        <a:lstStyle/>
+        <a:p>
+          <a:pPr>
+            <a:defRPr sz="1400"/>
+          </a:pPr>
+        </a:p>
+      </c:txPr>
+    </c:legend>
+    <c:plotVisOnly val="1"/>
+    <c:dispBlanksAs val="gap"/>
+    <c:showDLblsOverMax val="0"/>
+  </c:chart>
+  <c:txPr>
+    <a:bodyPr/>
+    <a:lstStyle/>
+    <a:p>
+      <a:pPr>
+        <a:defRPr sz="1800"/>
+      </a:pPr>
+      <a:endParaRPr lang="en-US"/>
+    </a:p>
+  </c:txPr>
+  <c:externalData r:id="rId1">
+    <c:autoUpdate val="0"/>
+  </c:externalData>
+</c:chartSpace>
+</file>
+
+<file path=ppt/charts/chart10.xml><?xml version="1.0" encoding="utf-8"?>
+<c:chartSpace xmlns:c="http://schemas.openxmlformats.org/drawingml/2006/chart" xmlns:a="http://schemas.openxmlformats.org/drawingml/2006/main" xmlns:r="http://schemas.openxmlformats.org/officeDocument/2006/relationships">
+  <c:date1904 val="0"/>
+  <c:chart>
+    <c:autoTitleDeleted val="1"/>
+    <c:plotArea>
+      <c:lineChart>
+        <c:grouping val="standard"/>
+        <c:varyColors val="0"/>
+        <c:ser>
+          <c:idx val="0"/>
+          <c:order val="0"/>
+          <c:tx>
+            <c:strRef>
+              <c:f>Sheet1!$B$1</c:f>
+              <c:strCache>
+                <c:ptCount val="1"/>
+                <c:pt idx="0">
+                  <c:v>Revenue!</c:v>
+                </c:pt>
+              </c:strCache>
+            </c:strRef>
+          </c:tx>
+          <c:spPr>
+            <a:solidFill>
+              <a:srgbClr val="4E79A7"/>
+            </a:solidFill>
+            <a:ln w="25400">
+              <a:solidFill>
+                <a:srgbClr val="4E79A7"/>
+              </a:solidFill>
+              <a:prstDash val="dash"/>
+            </a:ln>
+          </c:spPr>
+          <c:marker>
+            <c:symbol val="none"/>
+          </c:marker>
+          <c:cat>
+            <c:strRef>
+              <c:f>Sheet1!$A$2:$A$5</c:f>
+              <c:strCache>
+                <c:ptCount val="4"/>
+                <c:pt idx="0">
+                  <c:v>Jan</c:v>
+                </c:pt>
+                <c:pt idx="1">
+                  <c:v>Feb</c:v>
+                </c:pt>
+                <c:pt idx="2">
+                  <c:v>Mar</c:v>
+                </c:pt>
+                <c:pt idx="3">
+                  <c:v>Apr</c:v>
+                </c:pt>
+              </c:strCache>
+            </c:strRef>
+          </c:cat>
+          <c:val>
+            <c:numRef>
+              <c:f>Sheet1!$B$2:$B$5</c:f>
+              <c:numCache>
+                <c:formatCode>General</c:formatCode>
+                <c:ptCount val="4"/>
+                <c:pt idx="0">
+                  <c:v>10</c:v>
+                </c:pt>
+                <c:pt idx="1">
+                  <c:v>14</c:v>
+                </c:pt>
+                <c:pt idx="2">
+                  <c:v>9</c:v>
+                </c:pt>
+                <c:pt idx="3">
+                  <c:v>18</c:v>
+                </c:pt>
+              </c:numCache>
+            </c:numRef>
+          </c:val>
+          <c:smooth val="0"/>
+        </c:ser>
+        <c:ser>
+          <c:idx val="1"/>
+          <c:order val="1"/>
+          <c:tx>
+            <c:strRef>
+              <c:f>Sheet1!$C$1</c:f>
+              <c:strCache>
+                <c:ptCount val="1"/>
+                <c:pt idx="0">
+                  <c:v>Cost!</c:v>
+                </c:pt>
+              </c:strCache>
+            </c:strRef>
+          </c:tx>
+          <c:spPr>
+            <a:solidFill>
+              <a:srgbClr val="F28E2B"/>
+            </a:solidFill>
+            <a:ln w="25400">
+              <a:solidFill>
+                <a:srgbClr val="F28E2B"/>
+              </a:solidFill>
+              <a:prstDash val="dash"/>
+            </a:ln>
+          </c:spPr>
+          <c:marker>
+            <c:symbol val="none"/>
+          </c:marker>
+          <c:cat>
+            <c:strRef>
+              <c:f>Sheet1!$A$2:$A$5</c:f>
+              <c:strCache>
+                <c:ptCount val="4"/>
+                <c:pt idx="0">
+                  <c:v>Jan</c:v>
+                </c:pt>
+                <c:pt idx="1">
+                  <c:v>Feb</c:v>
+                </c:pt>
+                <c:pt idx="2">
+                  <c:v>Mar</c:v>
+                </c:pt>
+                <c:pt idx="3">
+                  <c:v>Apr</c:v>
+                </c:pt>
+              </c:strCache>
+            </c:strRef>
+          </c:cat>
+          <c:val>
+            <c:numRef>
+              <c:f>Sheet1!$C$2:$C$5</c:f>
+              <c:numCache>
+                <c:formatCode>General</c:formatCode>
+                <c:ptCount val="4"/>
+                <c:pt idx="0">
+                  <c:v>2</c:v>
+                </c:pt>
+                <c:pt idx="1">
+                  <c:v>4</c:v>
+                </c:pt>
+                <c:pt idx="2">
+                  <c:v>3</c:v>
+                </c:pt>
+                <c:pt idx="3">
+                  <c:v>1</c:v>
+                </c:pt>
+              </c:numCache>
+            </c:numRef>
+          </c:val>
+          <c:smooth val="0"/>
+        </c:ser>
+        <c:marker val="1"/>
+        <c:smooth val="0"/>
+        <c:axId val="2118791784"/>
+        <c:axId val="2140495176"/>
+      </c:lineChart>
+      <c:catAx>
+        <c:axId val="2118791784"/>
+        <c:scaling>
+          <c:orientation val="minMax"/>
+        </c:scaling>
+        <c:delete val="0"/>
+        <c:axPos val="b"/>
+        <c:title>
+          <c:tx>
+            <c:rich>
+              <a:bodyPr/>
+              <a:lstStyle/>
+              <a:p>
+                <a:pPr>
+                  <a:defRPr sz="1400" b="1" i="0" u="none"/>
+                </a:pPr>
+                <a:r>
+                  <a:t>Revenue</a:t>
+                </a:r>
+              </a:p>
+            </c:rich>
+          </c:tx>
+          <c:layout/>
+          <c:overlay val="0"/>
+        </c:title>
+        <c:majorTickMark val="out"/>
+        <c:minorTickMark val="none"/>
+        <c:tickLblPos val="low"/>
+        <c:txPr>
+          <a:bodyPr/>
+          <a:lstStyle/>
+          <a:p>
+            <a:pPr>
+              <a:defRPr sz="1400"/>
+            </a:pPr>
+          </a:p>
+        </c:txPr>
+        <c:crossAx val="2140495176"/>
+        <c:crosses val="autoZero"/>
+        <c:auto val="1"/>
+        <c:lblAlgn val="ctr"/>
+        <c:lblOffset val="100"/>
+        <c:noMultiLvlLbl val="0"/>
+      </c:catAx>
+      <c:valAx>
+        <c:axId val="2140495176"/>
+        <c:scaling>
+          <c:max val="20.0"/>
+          <c:min val="0.0"/>
+        </c:scaling>
+        <c:delete val="0"/>
+        <c:axPos val="l"/>
+        <c:title>
+          <c:tx>
+            <c:rich>
+              <a:bodyPr/>
+              <a:lstStyle/>
+              <a:p>
+                <a:pPr>
+                  <a:defRPr sz="1400" b="1" i="0" u="none"/>
+                </a:pPr>
+                <a:r>
+                  <a:t>Month</a:t>
+                </a:r>
+              </a:p>
+            </c:rich>
+          </c:tx>
+          <c:layout/>
+          <c:overlay val="0"/>
+        </c:title>
+        <c:numFmt formatCode="$0.0" sourceLinked="0"/>
+        <c:majorTickMark val="out"/>
+        <c:minorTickMark val="none"/>
+        <c:tickLblPos val="nextTo"/>
+        <c:txPr>
+          <a:bodyPr/>
+          <a:lstStyle/>
+          <a:p>
+            <a:pPr>
+              <a:defRPr sz="1400"/>
+            </a:pPr>
+          </a:p>
+        </c:txPr>
+        <c:crossAx val="2118791784"/>
+        <c:crosses val="autoZero"/>
+      </c:valAx>
+    </c:plotArea>
+    <c:legend>
+      <c:legendPos val="b"/>
+      <c:layout/>
+      <c:overlay val="0"/>
+      <c:txPr>
+        <a:bodyPr/>
+        <a:lstStyle/>
+        <a:p>
+          <a:pPr>
+            <a:defRPr sz="1400"/>
+          </a:pPr>
+        </a:p>
+      </c:txPr>
+    </c:legend>
+    <c:plotVisOnly val="1"/>
+    <c:dispBlanksAs val="gap"/>
+    <c:showDLblsOverMax val="0"/>
+  </c:chart>
+  <c:txPr>
+    <a:bodyPr/>
+    <a:lstStyle/>
+    <a:p>
+      <a:pPr>
+        <a:defRPr sz="1800"/>
+      </a:pPr>
+      <a:endParaRPr lang="en-US"/>
+    </a:p>
+  </c:txPr>
+  <c:externalData r:id="rId1">
+    <c:autoUpdate val="0"/>
+  </c:externalData>
+</c:chartSpace>
+</file>
+
+<file path=ppt/charts/chart11.xml><?xml version="1.0" encoding="utf-8"?>
+<c:chartSpace xmlns:c="http://schemas.openxmlformats.org/drawingml/2006/chart" xmlns:a="http://schemas.openxmlformats.org/drawingml/2006/main" xmlns:r="http://schemas.openxmlformats.org/officeDocument/2006/relationships">
+  <c:date1904 val="0"/>
+  <c:chart>
+    <c:autoTitleDeleted val="1"/>
+    <c:plotArea>
+      <c:lineChart>
+        <c:grouping val="standard"/>
+        <c:varyColors val="0"/>
+        <c:ser>
+          <c:idx val="0"/>
+          <c:order val="0"/>
+          <c:tx>
+            <c:strRef>
+              <c:f>Sheet1!$B$1</c:f>
+              <c:strCache>
+                <c:ptCount val="1"/>
+                <c:pt idx="0">
+                  <c:v>revenue</c:v>
+                </c:pt>
+              </c:strCache>
+            </c:strRef>
+          </c:tx>
+          <c:spPr>
+            <a:solidFill>
+              <a:srgbClr val="4E79A7"/>
+            </a:solidFill>
+            <a:ln w="25400">
+              <a:solidFill>
+                <a:srgbClr val="4E79A7"/>
+              </a:solidFill>
+              <a:prstDash val="dash"/>
+            </a:ln>
+          </c:spPr>
+          <c:marker>
+            <c:symbol val="none"/>
+          </c:marker>
+          <c:cat>
+            <c:strRef>
+              <c:f>Sheet1!$A$2:$A$5</c:f>
+              <c:strCache>
+                <c:ptCount val="4"/>
+                <c:pt idx="0">
+                  <c:v>Jan</c:v>
+                </c:pt>
+                <c:pt idx="1">
+                  <c:v>Feb</c:v>
+                </c:pt>
+                <c:pt idx="2">
+                  <c:v>Mar</c:v>
+                </c:pt>
+                <c:pt idx="3">
+                  <c:v>Apr</c:v>
+                </c:pt>
+              </c:strCache>
+            </c:strRef>
+          </c:cat>
+          <c:val>
+            <c:numRef>
+              <c:f>Sheet1!$B$2:$B$5</c:f>
+              <c:numCache>
+                <c:formatCode>General</c:formatCode>
+                <c:ptCount val="4"/>
+                <c:pt idx="0">
+                  <c:v>10</c:v>
+                </c:pt>
+                <c:pt idx="1">
+                  <c:v>14</c:v>
+                </c:pt>
+                <c:pt idx="2">
+                  <c:v>9</c:v>
+                </c:pt>
+                <c:pt idx="3">
+                  <c:v>18</c:v>
+                </c:pt>
+              </c:numCache>
+            </c:numRef>
+          </c:val>
+          <c:smooth val="0"/>
+        </c:ser>
+        <c:ser>
+          <c:idx val="1"/>
+          <c:order val="1"/>
+          <c:tx>
+            <c:strRef>
+              <c:f>Sheet1!$C$1</c:f>
+              <c:strCache>
+                <c:ptCount val="1"/>
+                <c:pt idx="0">
+                  <c:v>cost</c:v>
+                </c:pt>
+              </c:strCache>
+            </c:strRef>
+          </c:tx>
+          <c:spPr>
+            <a:solidFill>
+              <a:srgbClr val="F28E2B"/>
+            </a:solidFill>
+            <a:ln w="25400">
+              <a:solidFill>
+                <a:srgbClr val="F28E2B"/>
+              </a:solidFill>
+              <a:prstDash val="dash"/>
+            </a:ln>
+          </c:spPr>
+          <c:marker>
+            <c:symbol val="none"/>
+          </c:marker>
+          <c:cat>
+            <c:strRef>
+              <c:f>Sheet1!$A$2:$A$5</c:f>
+              <c:strCache>
+                <c:ptCount val="4"/>
+                <c:pt idx="0">
+                  <c:v>Jan</c:v>
+                </c:pt>
+                <c:pt idx="1">
+                  <c:v>Feb</c:v>
+                </c:pt>
+                <c:pt idx="2">
+                  <c:v>Mar</c:v>
+                </c:pt>
+                <c:pt idx="3">
+                  <c:v>Apr</c:v>
+                </c:pt>
+              </c:strCache>
+            </c:strRef>
+          </c:cat>
+          <c:val>
+            <c:numRef>
+              <c:f>Sheet1!$C$2:$C$5</c:f>
+              <c:numCache>
+                <c:formatCode>General</c:formatCode>
+                <c:ptCount val="4"/>
+                <c:pt idx="0">
+                  <c:v>2</c:v>
+                </c:pt>
+                <c:pt idx="1">
+                  <c:v>4</c:v>
+                </c:pt>
+                <c:pt idx="2">
+                  <c:v>3</c:v>
+                </c:pt>
+                <c:pt idx="3">
+                  <c:v>1</c:v>
+                </c:pt>
+              </c:numCache>
+            </c:numRef>
+          </c:val>
+          <c:smooth val="0"/>
+        </c:ser>
+        <c:marker val="1"/>
+        <c:smooth val="0"/>
+        <c:axId val="2118791784"/>
+        <c:axId val="2140495176"/>
+      </c:lineChart>
+      <c:catAx>
+        <c:axId val="2118791784"/>
+        <c:scaling>
+          <c:orientation val="minMax"/>
+        </c:scaling>
+        <c:delete val="0"/>
+        <c:axPos val="b"/>
+        <c:title>
+          <c:tx>
+            <c:rich>
+              <a:bodyPr/>
+              <a:lstStyle/>
+              <a:p>
+                <a:pPr>
+                  <a:defRPr sz="1400" b="1" i="0" u="none"/>
+                </a:pPr>
+                <a:r>
+                  <a:t>Revenue</a:t>
+                </a:r>
+              </a:p>
+            </c:rich>
+          </c:tx>
+          <c:layout/>
+          <c:overlay val="0"/>
+        </c:title>
+        <c:majorTickMark val="out"/>
+        <c:minorTickMark val="none"/>
+        <c:tickLblPos val="low"/>
+        <c:txPr>
+          <a:bodyPr/>
+          <a:lstStyle/>
+          <a:p>
+            <a:pPr>
+              <a:defRPr sz="1400"/>
+            </a:pPr>
+          </a:p>
+        </c:txPr>
+        <c:crossAx val="2140495176"/>
+        <c:crosses val="autoZero"/>
+        <c:auto val="1"/>
+        <c:lblAlgn val="ctr"/>
+        <c:lblOffset val="100"/>
+        <c:noMultiLvlLbl val="0"/>
+      </c:catAx>
+      <c:valAx>
+        <c:axId val="2140495176"/>
+        <c:scaling>
+          <c:max val="20.0"/>
+          <c:min val="0.0"/>
+        </c:scaling>
+        <c:delete val="0"/>
+        <c:axPos val="l"/>
+        <c:title>
+          <c:tx>
+            <c:rich>
+              <a:bodyPr/>
+              <a:lstStyle/>
+              <a:p>
+                <a:pPr>
+                  <a:defRPr sz="1400" b="1" i="0" u="none"/>
+                </a:pPr>
+                <a:r>
+                  <a:t>Month</a:t>
+                </a:r>
+              </a:p>
+            </c:rich>
+          </c:tx>
+          <c:layout/>
+          <c:overlay val="0"/>
+        </c:title>
+        <c:numFmt formatCode="$0.0" sourceLinked="0"/>
+        <c:majorTickMark val="out"/>
+        <c:minorTickMark val="none"/>
+        <c:tickLblPos val="nextTo"/>
+        <c:txPr>
+          <a:bodyPr/>
+          <a:lstStyle/>
+          <a:p>
+            <a:pPr>
+              <a:defRPr sz="1400"/>
+            </a:pPr>
+          </a:p>
+        </c:txPr>
+        <c:crossAx val="2118791784"/>
+        <c:crosses val="autoZero"/>
+      </c:valAx>
+    </c:plotArea>
+    <c:legend>
+      <c:legendPos val="b"/>
+      <c:layout/>
+      <c:overlay val="0"/>
+      <c:txPr>
+        <a:bodyPr/>
+        <a:lstStyle/>
+        <a:p>
+          <a:pPr>
+            <a:defRPr sz="1400"/>
+          </a:pPr>
+        </a:p>
+      </c:txPr>
+    </c:legend>
+    <c:plotVisOnly val="1"/>
+    <c:dispBlanksAs val="gap"/>
+    <c:showDLblsOverMax val="0"/>
+  </c:chart>
+  <c:txPr>
+    <a:bodyPr/>
+    <a:lstStyle/>
+    <a:p>
+      <a:pPr>
+        <a:defRPr sz="1800"/>
+      </a:pPr>
+      <a:endParaRPr lang="en-US"/>
+    </a:p>
+  </c:txPr>
+  <c:externalData r:id="rId1">
+    <c:autoUpdate val="0"/>
+  </c:externalData>
+</c:chartSpace>
+</file>
+
+<file path=ppt/charts/chart12.xml><?xml version="1.0" encoding="utf-8"?>
+<c:chartSpace xmlns:c="http://schemas.openxmlformats.org/drawingml/2006/chart" xmlns:a="http://schemas.openxmlformats.org/drawingml/2006/main" xmlns:r="http://schemas.openxmlformats.org/officeDocument/2006/relationships">
+  <c:date1904 val="0"/>
+  <c:chart>
+    <c:autoTitleDeleted val="1"/>
+    <c:plotArea>
+      <c:lineChart>
+        <c:grouping val="standard"/>
+        <c:varyColors val="0"/>
+        <c:ser>
+          <c:idx val="0"/>
+          <c:order val="0"/>
+          <c:tx>
+            <c:strRef>
+              <c:f>Sheet1!$B$1</c:f>
+              <c:strCache>
+                <c:ptCount val="1"/>
+                <c:pt idx="0">
+                  <c:v>Revenue!</c:v>
+                </c:pt>
+              </c:strCache>
+            </c:strRef>
+          </c:tx>
+          <c:spPr>
+            <a:solidFill>
+              <a:srgbClr val="4E79A7"/>
+            </a:solidFill>
+            <a:ln w="25400">
+              <a:solidFill>
+                <a:srgbClr val="4E79A7"/>
+              </a:solidFill>
+              <a:prstDash val="dash"/>
+            </a:ln>
+          </c:spPr>
+          <c:marker>
+            <c:symbol val="none"/>
+          </c:marker>
+          <c:cat>
+            <c:strRef>
+              <c:f>Sheet1!$A$2:$A$5</c:f>
+              <c:strCache>
+                <c:ptCount val="4"/>
+                <c:pt idx="0">
+                  <c:v>Jan</c:v>
+                </c:pt>
+                <c:pt idx="1">
+                  <c:v>Feb</c:v>
+                </c:pt>
+                <c:pt idx="2">
+                  <c:v>Mar</c:v>
+                </c:pt>
+                <c:pt idx="3">
+                  <c:v>Apr</c:v>
+                </c:pt>
+              </c:strCache>
+            </c:strRef>
+          </c:cat>
+          <c:val>
+            <c:numRef>
+              <c:f>Sheet1!$B$2:$B$5</c:f>
+              <c:numCache>
+                <c:formatCode>General</c:formatCode>
+                <c:ptCount val="4"/>
+                <c:pt idx="0">
+                  <c:v>10</c:v>
+                </c:pt>
+                <c:pt idx="1">
+                  <c:v>14</c:v>
+                </c:pt>
+                <c:pt idx="2">
+                  <c:v>9</c:v>
+                </c:pt>
+                <c:pt idx="3">
+                  <c:v>18</c:v>
+                </c:pt>
+              </c:numCache>
+            </c:numRef>
+          </c:val>
+          <c:smooth val="0"/>
+        </c:ser>
+        <c:ser>
+          <c:idx val="1"/>
+          <c:order val="1"/>
+          <c:tx>
+            <c:strRef>
+              <c:f>Sheet1!$C$1</c:f>
+              <c:strCache>
+                <c:ptCount val="1"/>
+                <c:pt idx="0">
+                  <c:v>Cost!</c:v>
+                </c:pt>
+              </c:strCache>
+            </c:strRef>
+          </c:tx>
+          <c:spPr>
+            <a:solidFill>
+              <a:srgbClr val="F28E2B"/>
+            </a:solidFill>
+            <a:ln w="25400">
+              <a:solidFill>
+                <a:srgbClr val="F28E2B"/>
+              </a:solidFill>
+              <a:prstDash val="dash"/>
+            </a:ln>
+          </c:spPr>
+          <c:marker>
+            <c:symbol val="none"/>
+          </c:marker>
+          <c:cat>
+            <c:strRef>
+              <c:f>Sheet1!$A$2:$A$5</c:f>
+              <c:strCache>
+                <c:ptCount val="4"/>
+                <c:pt idx="0">
+                  <c:v>Jan</c:v>
+                </c:pt>
+                <c:pt idx="1">
+                  <c:v>Feb</c:v>
+                </c:pt>
+                <c:pt idx="2">
+                  <c:v>Mar</c:v>
+                </c:pt>
+                <c:pt idx="3">
+                  <c:v>Apr</c:v>
+                </c:pt>
+              </c:strCache>
+            </c:strRef>
+          </c:cat>
+          <c:val>
+            <c:numRef>
+              <c:f>Sheet1!$C$2:$C$5</c:f>
+              <c:numCache>
+                <c:formatCode>General</c:formatCode>
+                <c:ptCount val="4"/>
+                <c:pt idx="0">
+                  <c:v>2</c:v>
+                </c:pt>
+                <c:pt idx="1">
+                  <c:v>4</c:v>
+                </c:pt>
+                <c:pt idx="2">
+                  <c:v>3</c:v>
+                </c:pt>
+                <c:pt idx="3">
+                  <c:v>1</c:v>
+                </c:pt>
+              </c:numCache>
+            </c:numRef>
+          </c:val>
+          <c:smooth val="0"/>
+        </c:ser>
+        <c:marker val="1"/>
+        <c:smooth val="0"/>
+        <c:axId val="2118791784"/>
+        <c:axId val="2140495176"/>
+      </c:lineChart>
+      <c:catAx>
+        <c:axId val="2118791784"/>
+        <c:scaling>
+          <c:orientation val="minMax"/>
+        </c:scaling>
+        <c:delete val="0"/>
+        <c:axPos val="b"/>
+        <c:title>
+          <c:tx>
+            <c:rich>
+              <a:bodyPr/>
+              <a:lstStyle/>
+              <a:p>
+                <a:pPr>
+                  <a:defRPr sz="1400" b="1" i="0" u="none"/>
+                </a:pPr>
+                <a:r>
+                  <a:t>Revenue</a:t>
+                </a:r>
+              </a:p>
+            </c:rich>
+          </c:tx>
+          <c:layout/>
+          <c:overlay val="0"/>
+        </c:title>
+        <c:majorTickMark val="out"/>
+        <c:minorTickMark val="none"/>
+        <c:tickLblPos val="low"/>
+        <c:txPr>
+          <a:bodyPr/>
+          <a:lstStyle/>
+          <a:p>
+            <a:pPr>
+              <a:defRPr sz="1400"/>
+            </a:pPr>
+          </a:p>
+        </c:txPr>
+        <c:crossAx val="2140495176"/>
+        <c:crosses val="autoZero"/>
+        <c:auto val="1"/>
+        <c:lblAlgn val="ctr"/>
+        <c:lblOffset val="100"/>
+        <c:noMultiLvlLbl val="0"/>
+      </c:catAx>
+      <c:valAx>
+        <c:axId val="2140495176"/>
+        <c:scaling>
+          <c:max val="20.0"/>
           <c:min val="0.0"/>
         </c:scaling>
         <c:delete val="0"/>
@@ -7156,6 +7988,275 @@
 </p:sld>
 </file>
 
+<file path=ppt/slides/slide6.xml><?xml version="1.0" encoding="utf-8"?>
+<p:sld xmlns:a="http://schemas.openxmlformats.org/drawingml/2006/main" xmlns:p="http://schemas.openxmlformats.org/presentationml/2006/main" xmlns:r="http://schemas.openxmlformats.org/officeDocument/2006/relationships">
+  <p:cSld>
+    <p:spTree>
+      <p:nvGrpSpPr>
+        <p:cNvPr id="1" name=""/>
+        <p:cNvGrpSpPr/>
+        <p:nvPr/>
+      </p:nvGrpSpPr>
+      <p:grpSpPr/>
+      <p:sp>
+        <p:nvSpPr>
+          <p:cNvPr id="2" name="TextBox 1"/>
+          <p:cNvSpPr txBox="1"/>
+          <p:nvPr/>
+        </p:nvSpPr>
+        <p:spPr>
+          <a:xfrm>
+            <a:off x="457200" y="91440"/>
+            <a:ext cx="11430000" cy="731520"/>
+          </a:xfrm>
+          <a:prstGeom prst="rect">
+            <a:avLst/>
+          </a:prstGeom>
+          <a:noFill/>
+        </p:spPr>
+        <p:txBody>
+          <a:bodyPr wrap="none" anchor="t">
+            <a:spAutoFit/>
+          </a:bodyPr>
+          <a:lstStyle/>
+          <a:p>
+            <a:pPr algn="l"/>
+            <a:r>
+              <a:rPr sz="2000" b="1" i="0" u="none">
+                <a:solidFill>
+                  <a:srgbClr val="7F7F7F"/>
+                </a:solidFill>
+              </a:rPr>
+              <a:t>These should all be the same (except for legend names)</a:t>
+            </a:r>
+          </a:p>
+        </p:txBody>
+      </p:sp>
+      <p:graphicFrame>
+        <p:nvGraphicFramePr>
+          <p:cNvPr id="3" name="chart_1"/>
+          <p:cNvGraphicFramePr>
+            <a:graphicFrameLocks noGrp="1"/>
+          </p:cNvGraphicFramePr>
+          <p:nvPr/>
+        </p:nvGraphicFramePr>
+        <p:xfrm>
+          <a:off x="457200" y="1463040"/>
+          <a:ext cx="3813048" cy="4800600"/>
+        </p:xfrm>
+        <a:graphic>
+          <a:graphicData uri="http://schemas.openxmlformats.org/drawingml/2006/chart">
+            <c:chart xmlns:c="http://schemas.openxmlformats.org/drawingml/2006/chart" r:id="rId2"/>
+          </a:graphicData>
+        </a:graphic>
+      </p:graphicFrame>
+      <p:sp>
+        <p:nvSpPr>
+          <p:cNvPr id="4" name="TextBox 3"/>
+          <p:cNvSpPr txBox="1"/>
+          <p:nvPr/>
+        </p:nvSpPr>
+        <p:spPr>
+          <a:xfrm>
+            <a:off x="457200" y="1005840"/>
+            <a:ext cx="3813048" cy="457200"/>
+          </a:xfrm>
+          <a:prstGeom prst="rect">
+            <a:avLst/>
+          </a:prstGeom>
+          <a:noFill/>
+        </p:spPr>
+        <p:txBody>
+          <a:bodyPr wrap="none" anchor="t">
+            <a:spAutoFit/>
+          </a:bodyPr>
+          <a:lstStyle/>
+          <a:p>
+            <a:pPr algn="ctr"/>
+            <a:r>
+              <a:rPr sz="1600" b="1" i="0" u="sng">
+                <a:solidFill>
+                  <a:srgbClr val="000000"/>
+                </a:solidFill>
+              </a:rPr>
+              <a:t>Revenue Trend (Line) - Chart Title
+</a:t>
+            </a:r>
+            <a:r>
+              <a:rPr sz="1400" b="0" i="1" u="none">
+                <a:solidFill>
+                  <a:srgbClr val="000000"/>
+                </a:solidFill>
+              </a:rPr>
+              <a:t>2024 Actuals</a:t>
+            </a:r>
+          </a:p>
+        </p:txBody>
+      </p:sp>
+      <p:graphicFrame>
+        <p:nvGraphicFramePr>
+          <p:cNvPr id="5" name="chart_2"/>
+          <p:cNvGraphicFramePr>
+            <a:graphicFrameLocks noGrp="1"/>
+          </p:cNvGraphicFramePr>
+          <p:nvPr/>
+        </p:nvGraphicFramePr>
+        <p:xfrm>
+          <a:off x="4270248" y="1463040"/>
+          <a:ext cx="3813048" cy="4800600"/>
+        </p:xfrm>
+        <a:graphic>
+          <a:graphicData uri="http://schemas.openxmlformats.org/drawingml/2006/chart">
+            <c:chart xmlns:c="http://schemas.openxmlformats.org/drawingml/2006/chart" r:id="rId3"/>
+          </a:graphicData>
+        </a:graphic>
+      </p:graphicFrame>
+      <p:sp>
+        <p:nvSpPr>
+          <p:cNvPr id="6" name="TextBox 5"/>
+          <p:cNvSpPr txBox="1"/>
+          <p:nvPr/>
+        </p:nvSpPr>
+        <p:spPr>
+          <a:xfrm>
+            <a:off x="4270248" y="1005840"/>
+            <a:ext cx="3813048" cy="457200"/>
+          </a:xfrm>
+          <a:prstGeom prst="rect">
+            <a:avLst/>
+          </a:prstGeom>
+          <a:noFill/>
+        </p:spPr>
+        <p:txBody>
+          <a:bodyPr wrap="none" anchor="t">
+            <a:spAutoFit/>
+          </a:bodyPr>
+          <a:lstStyle/>
+          <a:p>
+            <a:pPr algn="ctr"/>
+            <a:r>
+              <a:rPr sz="1600" b="1" i="0" u="sng">
+                <a:solidFill>
+                  <a:srgbClr val="000000"/>
+                </a:solidFill>
+              </a:rPr>
+              <a:t>Revenue Trend (Line) - Chart Title
+</a:t>
+            </a:r>
+            <a:r>
+              <a:rPr sz="1400" b="0" i="1" u="none">
+                <a:solidFill>
+                  <a:srgbClr val="000000"/>
+                </a:solidFill>
+              </a:rPr>
+              <a:t>2024 Actuals</a:t>
+            </a:r>
+          </a:p>
+        </p:txBody>
+      </p:sp>
+      <p:graphicFrame>
+        <p:nvGraphicFramePr>
+          <p:cNvPr id="7" name="chart_3"/>
+          <p:cNvGraphicFramePr>
+            <a:graphicFrameLocks noGrp="1"/>
+          </p:cNvGraphicFramePr>
+          <p:nvPr/>
+        </p:nvGraphicFramePr>
+        <p:xfrm>
+          <a:off x="8083296" y="1463040"/>
+          <a:ext cx="3813048" cy="4800600"/>
+        </p:xfrm>
+        <a:graphic>
+          <a:graphicData uri="http://schemas.openxmlformats.org/drawingml/2006/chart">
+            <c:chart xmlns:c="http://schemas.openxmlformats.org/drawingml/2006/chart" r:id="rId4"/>
+          </a:graphicData>
+        </a:graphic>
+      </p:graphicFrame>
+      <p:sp>
+        <p:nvSpPr>
+          <p:cNvPr id="8" name="TextBox 7"/>
+          <p:cNvSpPr txBox="1"/>
+          <p:nvPr/>
+        </p:nvSpPr>
+        <p:spPr>
+          <a:xfrm>
+            <a:off x="8083296" y="1005840"/>
+            <a:ext cx="3813048" cy="457200"/>
+          </a:xfrm>
+          <a:prstGeom prst="rect">
+            <a:avLst/>
+          </a:prstGeom>
+          <a:noFill/>
+        </p:spPr>
+        <p:txBody>
+          <a:bodyPr wrap="none" anchor="t">
+            <a:spAutoFit/>
+          </a:bodyPr>
+          <a:lstStyle/>
+          <a:p>
+            <a:pPr algn="ctr"/>
+            <a:r>
+              <a:rPr sz="1600" b="1" i="0" u="sng">
+                <a:solidFill>
+                  <a:srgbClr val="000000"/>
+                </a:solidFill>
+              </a:rPr>
+              <a:t>Revenue Trend (Line) - Chart Title
+</a:t>
+            </a:r>
+            <a:r>
+              <a:rPr sz="1400" b="0" i="1" u="none">
+                <a:solidFill>
+                  <a:srgbClr val="000000"/>
+                </a:solidFill>
+              </a:rPr>
+              <a:t>2024 Actuals</a:t>
+            </a:r>
+          </a:p>
+        </p:txBody>
+      </p:sp>
+      <p:sp>
+        <p:nvSpPr>
+          <p:cNvPr id="9" name="TextBox 8"/>
+          <p:cNvSpPr txBox="1"/>
+          <p:nvPr/>
+        </p:nvSpPr>
+        <p:spPr>
+          <a:xfrm>
+            <a:off x="457200" y="6263640"/>
+            <a:ext cx="11430000" cy="365760"/>
+          </a:xfrm>
+          <a:prstGeom prst="rect">
+            <a:avLst/>
+          </a:prstGeom>
+          <a:noFill/>
+        </p:spPr>
+        <p:txBody>
+          <a:bodyPr wrap="none" anchor="t">
+            <a:spAutoFit/>
+          </a:bodyPr>
+          <a:lstStyle/>
+          <a:p>
+            <a:pPr algn="l"/>
+            <a:r>
+              <a:rPr sz="1000" b="0" i="0" u="none">
+                <a:solidFill>
+                  <a:srgbClr val="000000"/>
+                </a:solidFill>
+              </a:rPr>
+              <a:t>Notes: Adjusted for recent acquisitions.</a:t>
+            </a:r>
+          </a:p>
+        </p:txBody>
+      </p:sp>
+    </p:spTree>
+  </p:cSld>
+  <p:clrMapOvr>
+    <a:masterClrMapping/>
+  </p:clrMapOvr>
+</p:sld>
+</file>
+
 <file path=ppt/theme/theme1.xml><?xml version="1.0" encoding="utf-8"?>
 <a:theme xmlns:a="http://schemas.openxmlformats.org/drawingml/2006/main" name="Simple Light">
   <a:themeElements>

</xml_diff>

<commit_message>
rename and avoid mutating ChartSpec
</commit_message>
<xml_diff>
--- a/notebooks/demo.pptx
+++ b/notebooks/demo.pptx
@@ -14,6 +14,7 @@
     <p:sldId id="259" r:id="rId21"/>
     <p:sldId id="260" r:id="rId22"/>
     <p:sldId id="261" r:id="rId23"/>
+    <p:sldId id="262" r:id="rId24"/>
   </p:sldIdLst>
   <p:sldSz cx="12188825" cy="6858000"/>
   <p:notesSz cx="6858000" cy="9144000"/>
@@ -1322,6 +1323,837 @@
         <c:axId val="2140495176"/>
         <c:scaling>
           <c:max val="20.0"/>
+          <c:min val="0.0"/>
+        </c:scaling>
+        <c:delete val="0"/>
+        <c:axPos val="l"/>
+        <c:title>
+          <c:tx>
+            <c:rich>
+              <a:bodyPr/>
+              <a:lstStyle/>
+              <a:p>
+                <a:pPr>
+                  <a:defRPr sz="1400" b="1" i="0" u="none"/>
+                </a:pPr>
+                <a:r>
+                  <a:t>Month</a:t>
+                </a:r>
+              </a:p>
+            </c:rich>
+          </c:tx>
+          <c:layout/>
+          <c:overlay val="0"/>
+        </c:title>
+        <c:numFmt formatCode="$0.0" sourceLinked="0"/>
+        <c:majorTickMark val="out"/>
+        <c:minorTickMark val="none"/>
+        <c:tickLblPos val="nextTo"/>
+        <c:txPr>
+          <a:bodyPr/>
+          <a:lstStyle/>
+          <a:p>
+            <a:pPr>
+              <a:defRPr sz="1400"/>
+            </a:pPr>
+          </a:p>
+        </c:txPr>
+        <c:crossAx val="2118791784"/>
+        <c:crosses val="autoZero"/>
+      </c:valAx>
+    </c:plotArea>
+    <c:legend>
+      <c:legendPos val="b"/>
+      <c:layout/>
+      <c:overlay val="0"/>
+      <c:txPr>
+        <a:bodyPr/>
+        <a:lstStyle/>
+        <a:p>
+          <a:pPr>
+            <a:defRPr sz="1400"/>
+          </a:pPr>
+        </a:p>
+      </c:txPr>
+    </c:legend>
+    <c:plotVisOnly val="1"/>
+    <c:dispBlanksAs val="gap"/>
+    <c:showDLblsOverMax val="0"/>
+  </c:chart>
+  <c:txPr>
+    <a:bodyPr/>
+    <a:lstStyle/>
+    <a:p>
+      <a:pPr>
+        <a:defRPr sz="1800"/>
+      </a:pPr>
+      <a:endParaRPr lang="en-US"/>
+    </a:p>
+  </c:txPr>
+  <c:externalData r:id="rId1">
+    <c:autoUpdate val="0"/>
+  </c:externalData>
+</c:chartSpace>
+</file>
+
+<file path=ppt/charts/chart13.xml><?xml version="1.0" encoding="utf-8"?>
+<c:chartSpace xmlns:c="http://schemas.openxmlformats.org/drawingml/2006/chart" xmlns:a="http://schemas.openxmlformats.org/drawingml/2006/main" xmlns:r="http://schemas.openxmlformats.org/officeDocument/2006/relationships">
+  <c:date1904 val="0"/>
+  <c:chart>
+    <c:autoTitleDeleted val="1"/>
+    <c:plotArea>
+      <c:lineChart>
+        <c:grouping val="standard"/>
+        <c:varyColors val="0"/>
+        <c:ser>
+          <c:idx val="0"/>
+          <c:order val="0"/>
+          <c:tx>
+            <c:strRef>
+              <c:f>Sheet1!$B$1</c:f>
+              <c:strCache>
+                <c:ptCount val="1"/>
+                <c:pt idx="0">
+                  <c:v>Revenue!</c:v>
+                </c:pt>
+              </c:strCache>
+            </c:strRef>
+          </c:tx>
+          <c:spPr>
+            <a:solidFill>
+              <a:srgbClr val="4E79A7"/>
+            </a:solidFill>
+            <a:ln w="25400">
+              <a:solidFill>
+                <a:srgbClr val="4E79A7"/>
+              </a:solidFill>
+              <a:prstDash val="dash"/>
+            </a:ln>
+          </c:spPr>
+          <c:marker>
+            <c:symbol val="none"/>
+          </c:marker>
+          <c:cat>
+            <c:strRef>
+              <c:f>Sheet1!$A$2:$A$5</c:f>
+              <c:strCache>
+                <c:ptCount val="4"/>
+                <c:pt idx="0">
+                  <c:v>Jan</c:v>
+                </c:pt>
+                <c:pt idx="1">
+                  <c:v>Feb</c:v>
+                </c:pt>
+                <c:pt idx="2">
+                  <c:v>Mar</c:v>
+                </c:pt>
+                <c:pt idx="3">
+                  <c:v>Apr</c:v>
+                </c:pt>
+              </c:strCache>
+            </c:strRef>
+          </c:cat>
+          <c:val>
+            <c:numRef>
+              <c:f>Sheet1!$B$2:$B$5</c:f>
+              <c:numCache>
+                <c:formatCode>General</c:formatCode>
+                <c:ptCount val="4"/>
+                <c:pt idx="0">
+                  <c:v>10</c:v>
+                </c:pt>
+                <c:pt idx="1">
+                  <c:v>14</c:v>
+                </c:pt>
+                <c:pt idx="2">
+                  <c:v>9</c:v>
+                </c:pt>
+                <c:pt idx="3">
+                  <c:v>18</c:v>
+                </c:pt>
+              </c:numCache>
+            </c:numRef>
+          </c:val>
+          <c:smooth val="0"/>
+        </c:ser>
+        <c:ser>
+          <c:idx val="1"/>
+          <c:order val="1"/>
+          <c:tx>
+            <c:strRef>
+              <c:f>Sheet1!$C$1</c:f>
+              <c:strCache>
+                <c:ptCount val="1"/>
+                <c:pt idx="0">
+                  <c:v>Cost!</c:v>
+                </c:pt>
+              </c:strCache>
+            </c:strRef>
+          </c:tx>
+          <c:spPr>
+            <a:solidFill>
+              <a:srgbClr val="F28E2B"/>
+            </a:solidFill>
+            <a:ln w="25400">
+              <a:solidFill>
+                <a:srgbClr val="F28E2B"/>
+              </a:solidFill>
+              <a:prstDash val="dash"/>
+            </a:ln>
+          </c:spPr>
+          <c:marker>
+            <c:symbol val="none"/>
+          </c:marker>
+          <c:cat>
+            <c:strRef>
+              <c:f>Sheet1!$A$2:$A$5</c:f>
+              <c:strCache>
+                <c:ptCount val="4"/>
+                <c:pt idx="0">
+                  <c:v>Jan</c:v>
+                </c:pt>
+                <c:pt idx="1">
+                  <c:v>Feb</c:v>
+                </c:pt>
+                <c:pt idx="2">
+                  <c:v>Mar</c:v>
+                </c:pt>
+                <c:pt idx="3">
+                  <c:v>Apr</c:v>
+                </c:pt>
+              </c:strCache>
+            </c:strRef>
+          </c:cat>
+          <c:val>
+            <c:numRef>
+              <c:f>Sheet1!$C$2:$C$5</c:f>
+              <c:numCache>
+                <c:formatCode>General</c:formatCode>
+                <c:ptCount val="4"/>
+                <c:pt idx="0">
+                  <c:v>2</c:v>
+                </c:pt>
+                <c:pt idx="1">
+                  <c:v>4</c:v>
+                </c:pt>
+                <c:pt idx="2">
+                  <c:v>3</c:v>
+                </c:pt>
+                <c:pt idx="3">
+                  <c:v>1</c:v>
+                </c:pt>
+              </c:numCache>
+            </c:numRef>
+          </c:val>
+          <c:smooth val="0"/>
+        </c:ser>
+        <c:marker val="1"/>
+        <c:smooth val="0"/>
+        <c:axId val="2118791784"/>
+        <c:axId val="2140495176"/>
+      </c:lineChart>
+      <c:catAx>
+        <c:axId val="2118791784"/>
+        <c:scaling>
+          <c:orientation val="minMax"/>
+        </c:scaling>
+        <c:delete val="0"/>
+        <c:axPos val="b"/>
+        <c:title>
+          <c:tx>
+            <c:rich>
+              <a:bodyPr/>
+              <a:lstStyle/>
+              <a:p>
+                <a:pPr>
+                  <a:defRPr sz="1400" b="1" i="0" u="none"/>
+                </a:pPr>
+                <a:r>
+                  <a:t>Revenue</a:t>
+                </a:r>
+              </a:p>
+            </c:rich>
+          </c:tx>
+          <c:layout/>
+          <c:overlay val="0"/>
+        </c:title>
+        <c:majorTickMark val="out"/>
+        <c:minorTickMark val="none"/>
+        <c:tickLblPos val="low"/>
+        <c:txPr>
+          <a:bodyPr/>
+          <a:lstStyle/>
+          <a:p>
+            <a:pPr>
+              <a:defRPr sz="1400"/>
+            </a:pPr>
+          </a:p>
+        </c:txPr>
+        <c:crossAx val="2140495176"/>
+        <c:crosses val="autoZero"/>
+        <c:auto val="1"/>
+        <c:lblAlgn val="ctr"/>
+        <c:lblOffset val="100"/>
+        <c:noMultiLvlLbl val="0"/>
+      </c:catAx>
+      <c:valAx>
+        <c:axId val="2140495176"/>
+        <c:scaling>
+          <c:max val="30.0"/>
+          <c:min val="0.0"/>
+        </c:scaling>
+        <c:delete val="0"/>
+        <c:axPos val="l"/>
+        <c:title>
+          <c:tx>
+            <c:rich>
+              <a:bodyPr/>
+              <a:lstStyle/>
+              <a:p>
+                <a:pPr>
+                  <a:defRPr sz="1400" b="1" i="0" u="none"/>
+                </a:pPr>
+                <a:r>
+                  <a:t>Month</a:t>
+                </a:r>
+              </a:p>
+            </c:rich>
+          </c:tx>
+          <c:layout/>
+          <c:overlay val="0"/>
+        </c:title>
+        <c:numFmt formatCode="$0.0" sourceLinked="0"/>
+        <c:majorTickMark val="out"/>
+        <c:minorTickMark val="none"/>
+        <c:tickLblPos val="nextTo"/>
+        <c:txPr>
+          <a:bodyPr/>
+          <a:lstStyle/>
+          <a:p>
+            <a:pPr>
+              <a:defRPr sz="1400"/>
+            </a:pPr>
+          </a:p>
+        </c:txPr>
+        <c:crossAx val="2118791784"/>
+        <c:crosses val="autoZero"/>
+      </c:valAx>
+    </c:plotArea>
+    <c:legend>
+      <c:legendPos val="b"/>
+      <c:layout/>
+      <c:overlay val="0"/>
+      <c:txPr>
+        <a:bodyPr/>
+        <a:lstStyle/>
+        <a:p>
+          <a:pPr>
+            <a:defRPr sz="1400"/>
+          </a:pPr>
+        </a:p>
+      </c:txPr>
+    </c:legend>
+    <c:plotVisOnly val="1"/>
+    <c:dispBlanksAs val="gap"/>
+    <c:showDLblsOverMax val="0"/>
+  </c:chart>
+  <c:txPr>
+    <a:bodyPr/>
+    <a:lstStyle/>
+    <a:p>
+      <a:pPr>
+        <a:defRPr sz="1800"/>
+      </a:pPr>
+      <a:endParaRPr lang="en-US"/>
+    </a:p>
+  </c:txPr>
+  <c:externalData r:id="rId1">
+    <c:autoUpdate val="0"/>
+  </c:externalData>
+</c:chartSpace>
+</file>
+
+<file path=ppt/charts/chart14.xml><?xml version="1.0" encoding="utf-8"?>
+<c:chartSpace xmlns:c="http://schemas.openxmlformats.org/drawingml/2006/chart" xmlns:a="http://schemas.openxmlformats.org/drawingml/2006/main" xmlns:r="http://schemas.openxmlformats.org/officeDocument/2006/relationships">
+  <c:date1904 val="0"/>
+  <c:chart>
+    <c:autoTitleDeleted val="1"/>
+    <c:plotArea>
+      <c:lineChart>
+        <c:grouping val="standard"/>
+        <c:varyColors val="0"/>
+        <c:ser>
+          <c:idx val="0"/>
+          <c:order val="0"/>
+          <c:tx>
+            <c:strRef>
+              <c:f>Sheet1!$B$1</c:f>
+              <c:strCache>
+                <c:ptCount val="1"/>
+                <c:pt idx="0">
+                  <c:v>revenue</c:v>
+                </c:pt>
+              </c:strCache>
+            </c:strRef>
+          </c:tx>
+          <c:spPr>
+            <a:solidFill>
+              <a:srgbClr val="4E79A7"/>
+            </a:solidFill>
+            <a:ln w="25400">
+              <a:solidFill>
+                <a:srgbClr val="4E79A7"/>
+              </a:solidFill>
+              <a:prstDash val="dash"/>
+            </a:ln>
+          </c:spPr>
+          <c:marker>
+            <c:symbol val="none"/>
+          </c:marker>
+          <c:cat>
+            <c:strRef>
+              <c:f>Sheet1!$A$2:$A$5</c:f>
+              <c:strCache>
+                <c:ptCount val="4"/>
+                <c:pt idx="0">
+                  <c:v>Jan</c:v>
+                </c:pt>
+                <c:pt idx="1">
+                  <c:v>Feb</c:v>
+                </c:pt>
+                <c:pt idx="2">
+                  <c:v>Mar</c:v>
+                </c:pt>
+                <c:pt idx="3">
+                  <c:v>Apr</c:v>
+                </c:pt>
+              </c:strCache>
+            </c:strRef>
+          </c:cat>
+          <c:val>
+            <c:numRef>
+              <c:f>Sheet1!$B$2:$B$5</c:f>
+              <c:numCache>
+                <c:formatCode>General</c:formatCode>
+                <c:ptCount val="4"/>
+                <c:pt idx="0">
+                  <c:v>10</c:v>
+                </c:pt>
+                <c:pt idx="1">
+                  <c:v>14</c:v>
+                </c:pt>
+                <c:pt idx="2">
+                  <c:v>9</c:v>
+                </c:pt>
+                <c:pt idx="3">
+                  <c:v>18</c:v>
+                </c:pt>
+              </c:numCache>
+            </c:numRef>
+          </c:val>
+          <c:smooth val="0"/>
+        </c:ser>
+        <c:ser>
+          <c:idx val="1"/>
+          <c:order val="1"/>
+          <c:tx>
+            <c:strRef>
+              <c:f>Sheet1!$C$1</c:f>
+              <c:strCache>
+                <c:ptCount val="1"/>
+                <c:pt idx="0">
+                  <c:v>cost</c:v>
+                </c:pt>
+              </c:strCache>
+            </c:strRef>
+          </c:tx>
+          <c:spPr>
+            <a:solidFill>
+              <a:srgbClr val="F28E2B"/>
+            </a:solidFill>
+            <a:ln w="25400">
+              <a:solidFill>
+                <a:srgbClr val="F28E2B"/>
+              </a:solidFill>
+              <a:prstDash val="dash"/>
+            </a:ln>
+          </c:spPr>
+          <c:marker>
+            <c:symbol val="none"/>
+          </c:marker>
+          <c:cat>
+            <c:strRef>
+              <c:f>Sheet1!$A$2:$A$5</c:f>
+              <c:strCache>
+                <c:ptCount val="4"/>
+                <c:pt idx="0">
+                  <c:v>Jan</c:v>
+                </c:pt>
+                <c:pt idx="1">
+                  <c:v>Feb</c:v>
+                </c:pt>
+                <c:pt idx="2">
+                  <c:v>Mar</c:v>
+                </c:pt>
+                <c:pt idx="3">
+                  <c:v>Apr</c:v>
+                </c:pt>
+              </c:strCache>
+            </c:strRef>
+          </c:cat>
+          <c:val>
+            <c:numRef>
+              <c:f>Sheet1!$C$2:$C$5</c:f>
+              <c:numCache>
+                <c:formatCode>General</c:formatCode>
+                <c:ptCount val="4"/>
+                <c:pt idx="0">
+                  <c:v>2</c:v>
+                </c:pt>
+                <c:pt idx="1">
+                  <c:v>4</c:v>
+                </c:pt>
+                <c:pt idx="2">
+                  <c:v>3</c:v>
+                </c:pt>
+                <c:pt idx="3">
+                  <c:v>1</c:v>
+                </c:pt>
+              </c:numCache>
+            </c:numRef>
+          </c:val>
+          <c:smooth val="0"/>
+        </c:ser>
+        <c:marker val="1"/>
+        <c:smooth val="0"/>
+        <c:axId val="2118791784"/>
+        <c:axId val="2140495176"/>
+      </c:lineChart>
+      <c:catAx>
+        <c:axId val="2118791784"/>
+        <c:scaling>
+          <c:orientation val="minMax"/>
+        </c:scaling>
+        <c:delete val="0"/>
+        <c:axPos val="b"/>
+        <c:title>
+          <c:tx>
+            <c:rich>
+              <a:bodyPr/>
+              <a:lstStyle/>
+              <a:p>
+                <a:pPr>
+                  <a:defRPr sz="1400" b="1" i="0" u="none"/>
+                </a:pPr>
+                <a:r>
+                  <a:t>Revenue</a:t>
+                </a:r>
+              </a:p>
+            </c:rich>
+          </c:tx>
+          <c:layout/>
+          <c:overlay val="0"/>
+        </c:title>
+        <c:majorTickMark val="out"/>
+        <c:minorTickMark val="none"/>
+        <c:tickLblPos val="low"/>
+        <c:txPr>
+          <a:bodyPr/>
+          <a:lstStyle/>
+          <a:p>
+            <a:pPr>
+              <a:defRPr sz="1400"/>
+            </a:pPr>
+          </a:p>
+        </c:txPr>
+        <c:crossAx val="2140495176"/>
+        <c:crosses val="autoZero"/>
+        <c:auto val="1"/>
+        <c:lblAlgn val="ctr"/>
+        <c:lblOffset val="100"/>
+        <c:noMultiLvlLbl val="0"/>
+      </c:catAx>
+      <c:valAx>
+        <c:axId val="2140495176"/>
+        <c:scaling>
+          <c:max val="30.0"/>
+          <c:min val="0.0"/>
+        </c:scaling>
+        <c:delete val="0"/>
+        <c:axPos val="l"/>
+        <c:title>
+          <c:tx>
+            <c:rich>
+              <a:bodyPr/>
+              <a:lstStyle/>
+              <a:p>
+                <a:pPr>
+                  <a:defRPr sz="1400" b="1" i="0" u="none"/>
+                </a:pPr>
+                <a:r>
+                  <a:t>Month</a:t>
+                </a:r>
+              </a:p>
+            </c:rich>
+          </c:tx>
+          <c:layout/>
+          <c:overlay val="0"/>
+        </c:title>
+        <c:numFmt formatCode="$0.0" sourceLinked="0"/>
+        <c:majorTickMark val="out"/>
+        <c:minorTickMark val="none"/>
+        <c:tickLblPos val="nextTo"/>
+        <c:txPr>
+          <a:bodyPr/>
+          <a:lstStyle/>
+          <a:p>
+            <a:pPr>
+              <a:defRPr sz="1400"/>
+            </a:pPr>
+          </a:p>
+        </c:txPr>
+        <c:crossAx val="2118791784"/>
+        <c:crosses val="autoZero"/>
+      </c:valAx>
+    </c:plotArea>
+    <c:legend>
+      <c:legendPos val="b"/>
+      <c:layout/>
+      <c:overlay val="0"/>
+      <c:txPr>
+        <a:bodyPr/>
+        <a:lstStyle/>
+        <a:p>
+          <a:pPr>
+            <a:defRPr sz="1400"/>
+          </a:pPr>
+        </a:p>
+      </c:txPr>
+    </c:legend>
+    <c:plotVisOnly val="1"/>
+    <c:dispBlanksAs val="gap"/>
+    <c:showDLblsOverMax val="0"/>
+  </c:chart>
+  <c:txPr>
+    <a:bodyPr/>
+    <a:lstStyle/>
+    <a:p>
+      <a:pPr>
+        <a:defRPr sz="1800"/>
+      </a:pPr>
+      <a:endParaRPr lang="en-US"/>
+    </a:p>
+  </c:txPr>
+  <c:externalData r:id="rId1">
+    <c:autoUpdate val="0"/>
+  </c:externalData>
+</c:chartSpace>
+</file>
+
+<file path=ppt/charts/chart15.xml><?xml version="1.0" encoding="utf-8"?>
+<c:chartSpace xmlns:c="http://schemas.openxmlformats.org/drawingml/2006/chart" xmlns:a="http://schemas.openxmlformats.org/drawingml/2006/main" xmlns:r="http://schemas.openxmlformats.org/officeDocument/2006/relationships">
+  <c:date1904 val="0"/>
+  <c:chart>
+    <c:autoTitleDeleted val="1"/>
+    <c:plotArea>
+      <c:lineChart>
+        <c:grouping val="standard"/>
+        <c:varyColors val="0"/>
+        <c:ser>
+          <c:idx val="0"/>
+          <c:order val="0"/>
+          <c:tx>
+            <c:strRef>
+              <c:f>Sheet1!$B$1</c:f>
+              <c:strCache>
+                <c:ptCount val="1"/>
+                <c:pt idx="0">
+                  <c:v>Revenue!</c:v>
+                </c:pt>
+              </c:strCache>
+            </c:strRef>
+          </c:tx>
+          <c:spPr>
+            <a:solidFill>
+              <a:srgbClr val="4E79A7"/>
+            </a:solidFill>
+            <a:ln w="25400">
+              <a:solidFill>
+                <a:srgbClr val="4E79A7"/>
+              </a:solidFill>
+              <a:prstDash val="dash"/>
+            </a:ln>
+          </c:spPr>
+          <c:marker>
+            <c:symbol val="none"/>
+          </c:marker>
+          <c:cat>
+            <c:strRef>
+              <c:f>Sheet1!$A$2:$A$5</c:f>
+              <c:strCache>
+                <c:ptCount val="4"/>
+                <c:pt idx="0">
+                  <c:v>Jan</c:v>
+                </c:pt>
+                <c:pt idx="1">
+                  <c:v>Feb</c:v>
+                </c:pt>
+                <c:pt idx="2">
+                  <c:v>Mar</c:v>
+                </c:pt>
+                <c:pt idx="3">
+                  <c:v>Apr</c:v>
+                </c:pt>
+              </c:strCache>
+            </c:strRef>
+          </c:cat>
+          <c:val>
+            <c:numRef>
+              <c:f>Sheet1!$B$2:$B$5</c:f>
+              <c:numCache>
+                <c:formatCode>General</c:formatCode>
+                <c:ptCount val="4"/>
+                <c:pt idx="0">
+                  <c:v>10</c:v>
+                </c:pt>
+                <c:pt idx="1">
+                  <c:v>14</c:v>
+                </c:pt>
+                <c:pt idx="2">
+                  <c:v>9</c:v>
+                </c:pt>
+                <c:pt idx="3">
+                  <c:v>18</c:v>
+                </c:pt>
+              </c:numCache>
+            </c:numRef>
+          </c:val>
+          <c:smooth val="0"/>
+        </c:ser>
+        <c:ser>
+          <c:idx val="1"/>
+          <c:order val="1"/>
+          <c:tx>
+            <c:strRef>
+              <c:f>Sheet1!$C$1</c:f>
+              <c:strCache>
+                <c:ptCount val="1"/>
+                <c:pt idx="0">
+                  <c:v>Cost!</c:v>
+                </c:pt>
+              </c:strCache>
+            </c:strRef>
+          </c:tx>
+          <c:spPr>
+            <a:solidFill>
+              <a:srgbClr val="F28E2B"/>
+            </a:solidFill>
+            <a:ln w="25400">
+              <a:solidFill>
+                <a:srgbClr val="F28E2B"/>
+              </a:solidFill>
+              <a:prstDash val="dash"/>
+            </a:ln>
+          </c:spPr>
+          <c:marker>
+            <c:symbol val="none"/>
+          </c:marker>
+          <c:cat>
+            <c:strRef>
+              <c:f>Sheet1!$A$2:$A$5</c:f>
+              <c:strCache>
+                <c:ptCount val="4"/>
+                <c:pt idx="0">
+                  <c:v>Jan</c:v>
+                </c:pt>
+                <c:pt idx="1">
+                  <c:v>Feb</c:v>
+                </c:pt>
+                <c:pt idx="2">
+                  <c:v>Mar</c:v>
+                </c:pt>
+                <c:pt idx="3">
+                  <c:v>Apr</c:v>
+                </c:pt>
+              </c:strCache>
+            </c:strRef>
+          </c:cat>
+          <c:val>
+            <c:numRef>
+              <c:f>Sheet1!$C$2:$C$5</c:f>
+              <c:numCache>
+                <c:formatCode>General</c:formatCode>
+                <c:ptCount val="4"/>
+                <c:pt idx="0">
+                  <c:v>2</c:v>
+                </c:pt>
+                <c:pt idx="1">
+                  <c:v>4</c:v>
+                </c:pt>
+                <c:pt idx="2">
+                  <c:v>3</c:v>
+                </c:pt>
+                <c:pt idx="3">
+                  <c:v>1</c:v>
+                </c:pt>
+              </c:numCache>
+            </c:numRef>
+          </c:val>
+          <c:smooth val="0"/>
+        </c:ser>
+        <c:marker val="1"/>
+        <c:smooth val="0"/>
+        <c:axId val="2118791784"/>
+        <c:axId val="2140495176"/>
+      </c:lineChart>
+      <c:catAx>
+        <c:axId val="2118791784"/>
+        <c:scaling>
+          <c:orientation val="minMax"/>
+        </c:scaling>
+        <c:delete val="0"/>
+        <c:axPos val="b"/>
+        <c:title>
+          <c:tx>
+            <c:rich>
+              <a:bodyPr/>
+              <a:lstStyle/>
+              <a:p>
+                <a:pPr>
+                  <a:defRPr sz="1400" b="1" i="0" u="none"/>
+                </a:pPr>
+                <a:r>
+                  <a:t>Revenue</a:t>
+                </a:r>
+              </a:p>
+            </c:rich>
+          </c:tx>
+          <c:layout/>
+          <c:overlay val="0"/>
+        </c:title>
+        <c:majorTickMark val="out"/>
+        <c:minorTickMark val="none"/>
+        <c:tickLblPos val="low"/>
+        <c:txPr>
+          <a:bodyPr/>
+          <a:lstStyle/>
+          <a:p>
+            <a:pPr>
+              <a:defRPr sz="1400"/>
+            </a:pPr>
+          </a:p>
+        </c:txPr>
+        <c:crossAx val="2140495176"/>
+        <c:crosses val="autoZero"/>
+        <c:auto val="1"/>
+        <c:lblAlgn val="ctr"/>
+        <c:lblOffset val="100"/>
+        <c:noMultiLvlLbl val="0"/>
+      </c:catAx>
+      <c:valAx>
+        <c:axId val="2140495176"/>
+        <c:scaling>
+          <c:max val="30.0"/>
           <c:min val="0.0"/>
         </c:scaling>
         <c:delete val="0"/>
@@ -8257,6 +9089,275 @@
 </p:sld>
 </file>
 
+<file path=ppt/slides/slide7.xml><?xml version="1.0" encoding="utf-8"?>
+<p:sld xmlns:a="http://schemas.openxmlformats.org/drawingml/2006/main" xmlns:p="http://schemas.openxmlformats.org/presentationml/2006/main" xmlns:r="http://schemas.openxmlformats.org/officeDocument/2006/relationships">
+  <p:cSld>
+    <p:spTree>
+      <p:nvGrpSpPr>
+        <p:cNvPr id="1" name=""/>
+        <p:cNvGrpSpPr/>
+        <p:nvPr/>
+      </p:nvGrpSpPr>
+      <p:grpSpPr/>
+      <p:sp>
+        <p:nvSpPr>
+          <p:cNvPr id="2" name="TextBox 1"/>
+          <p:cNvSpPr txBox="1"/>
+          <p:nvPr/>
+        </p:nvSpPr>
+        <p:spPr>
+          <a:xfrm>
+            <a:off x="457200" y="91440"/>
+            <a:ext cx="11430000" cy="731520"/>
+          </a:xfrm>
+          <a:prstGeom prst="rect">
+            <a:avLst/>
+          </a:prstGeom>
+          <a:noFill/>
+        </p:spPr>
+        <p:txBody>
+          <a:bodyPr wrap="none" anchor="t">
+            <a:spAutoFit/>
+          </a:bodyPr>
+          <a:lstStyle/>
+          <a:p>
+            <a:pPr algn="l"/>
+            <a:r>
+              <a:rPr sz="2000" b="1" i="0" u="none">
+                <a:solidFill>
+                  <a:srgbClr val="7F7F7F"/>
+                </a:solidFill>
+              </a:rPr>
+              <a:t>These should all be the same (except for legend names)</a:t>
+            </a:r>
+          </a:p>
+        </p:txBody>
+      </p:sp>
+      <p:graphicFrame>
+        <p:nvGraphicFramePr>
+          <p:cNvPr id="3" name="chart_1"/>
+          <p:cNvGraphicFramePr>
+            <a:graphicFrameLocks noGrp="1"/>
+          </p:cNvGraphicFramePr>
+          <p:nvPr/>
+        </p:nvGraphicFramePr>
+        <p:xfrm>
+          <a:off x="457200" y="1463040"/>
+          <a:ext cx="3813048" cy="4800600"/>
+        </p:xfrm>
+        <a:graphic>
+          <a:graphicData uri="http://schemas.openxmlformats.org/drawingml/2006/chart">
+            <c:chart xmlns:c="http://schemas.openxmlformats.org/drawingml/2006/chart" r:id="rId2"/>
+          </a:graphicData>
+        </a:graphic>
+      </p:graphicFrame>
+      <p:sp>
+        <p:nvSpPr>
+          <p:cNvPr id="4" name="TextBox 3"/>
+          <p:cNvSpPr txBox="1"/>
+          <p:nvPr/>
+        </p:nvSpPr>
+        <p:spPr>
+          <a:xfrm>
+            <a:off x="457200" y="1005840"/>
+            <a:ext cx="3813048" cy="457200"/>
+          </a:xfrm>
+          <a:prstGeom prst="rect">
+            <a:avLst/>
+          </a:prstGeom>
+          <a:noFill/>
+        </p:spPr>
+        <p:txBody>
+          <a:bodyPr wrap="none" anchor="t">
+            <a:spAutoFit/>
+          </a:bodyPr>
+          <a:lstStyle/>
+          <a:p>
+            <a:pPr algn="ctr"/>
+            <a:r>
+              <a:rPr sz="1600" b="1" i="0" u="sng">
+                <a:solidFill>
+                  <a:srgbClr val="000000"/>
+                </a:solidFill>
+              </a:rPr>
+              <a:t>Revenue Trend (Line) - Chart Title
+</a:t>
+            </a:r>
+            <a:r>
+              <a:rPr sz="1400" b="0" i="1" u="none">
+                <a:solidFill>
+                  <a:srgbClr val="000000"/>
+                </a:solidFill>
+              </a:rPr>
+              <a:t>2024 Actuals</a:t>
+            </a:r>
+          </a:p>
+        </p:txBody>
+      </p:sp>
+      <p:graphicFrame>
+        <p:nvGraphicFramePr>
+          <p:cNvPr id="5" name="chart_2"/>
+          <p:cNvGraphicFramePr>
+            <a:graphicFrameLocks noGrp="1"/>
+          </p:cNvGraphicFramePr>
+          <p:nvPr/>
+        </p:nvGraphicFramePr>
+        <p:xfrm>
+          <a:off x="4270248" y="1463040"/>
+          <a:ext cx="3813048" cy="4800600"/>
+        </p:xfrm>
+        <a:graphic>
+          <a:graphicData uri="http://schemas.openxmlformats.org/drawingml/2006/chart">
+            <c:chart xmlns:c="http://schemas.openxmlformats.org/drawingml/2006/chart" r:id="rId3"/>
+          </a:graphicData>
+        </a:graphic>
+      </p:graphicFrame>
+      <p:sp>
+        <p:nvSpPr>
+          <p:cNvPr id="6" name="TextBox 5"/>
+          <p:cNvSpPr txBox="1"/>
+          <p:nvPr/>
+        </p:nvSpPr>
+        <p:spPr>
+          <a:xfrm>
+            <a:off x="4270248" y="1005840"/>
+            <a:ext cx="3813048" cy="457200"/>
+          </a:xfrm>
+          <a:prstGeom prst="rect">
+            <a:avLst/>
+          </a:prstGeom>
+          <a:noFill/>
+        </p:spPr>
+        <p:txBody>
+          <a:bodyPr wrap="none" anchor="t">
+            <a:spAutoFit/>
+          </a:bodyPr>
+          <a:lstStyle/>
+          <a:p>
+            <a:pPr algn="ctr"/>
+            <a:r>
+              <a:rPr sz="1600" b="1" i="0" u="sng">
+                <a:solidFill>
+                  <a:srgbClr val="000000"/>
+                </a:solidFill>
+              </a:rPr>
+              <a:t>Revenue Trend (Line) - Chart Title
+</a:t>
+            </a:r>
+            <a:r>
+              <a:rPr sz="1400" b="0" i="1" u="none">
+                <a:solidFill>
+                  <a:srgbClr val="000000"/>
+                </a:solidFill>
+              </a:rPr>
+              <a:t>2024 Actuals</a:t>
+            </a:r>
+          </a:p>
+        </p:txBody>
+      </p:sp>
+      <p:graphicFrame>
+        <p:nvGraphicFramePr>
+          <p:cNvPr id="7" name="chart_3"/>
+          <p:cNvGraphicFramePr>
+            <a:graphicFrameLocks noGrp="1"/>
+          </p:cNvGraphicFramePr>
+          <p:nvPr/>
+        </p:nvGraphicFramePr>
+        <p:xfrm>
+          <a:off x="8083296" y="1463040"/>
+          <a:ext cx="3813048" cy="4800600"/>
+        </p:xfrm>
+        <a:graphic>
+          <a:graphicData uri="http://schemas.openxmlformats.org/drawingml/2006/chart">
+            <c:chart xmlns:c="http://schemas.openxmlformats.org/drawingml/2006/chart" r:id="rId4"/>
+          </a:graphicData>
+        </a:graphic>
+      </p:graphicFrame>
+      <p:sp>
+        <p:nvSpPr>
+          <p:cNvPr id="8" name="TextBox 7"/>
+          <p:cNvSpPr txBox="1"/>
+          <p:nvPr/>
+        </p:nvSpPr>
+        <p:spPr>
+          <a:xfrm>
+            <a:off x="8083296" y="1005840"/>
+            <a:ext cx="3813048" cy="457200"/>
+          </a:xfrm>
+          <a:prstGeom prst="rect">
+            <a:avLst/>
+          </a:prstGeom>
+          <a:noFill/>
+        </p:spPr>
+        <p:txBody>
+          <a:bodyPr wrap="none" anchor="t">
+            <a:spAutoFit/>
+          </a:bodyPr>
+          <a:lstStyle/>
+          <a:p>
+            <a:pPr algn="ctr"/>
+            <a:r>
+              <a:rPr sz="1600" b="1" i="0" u="sng">
+                <a:solidFill>
+                  <a:srgbClr val="000000"/>
+                </a:solidFill>
+              </a:rPr>
+              <a:t>Revenue Trend (Line) - Chart Title
+</a:t>
+            </a:r>
+            <a:r>
+              <a:rPr sz="1400" b="0" i="1" u="none">
+                <a:solidFill>
+                  <a:srgbClr val="000000"/>
+                </a:solidFill>
+              </a:rPr>
+              <a:t>2024 Actuals</a:t>
+            </a:r>
+          </a:p>
+        </p:txBody>
+      </p:sp>
+      <p:sp>
+        <p:nvSpPr>
+          <p:cNvPr id="9" name="TextBox 8"/>
+          <p:cNvSpPr txBox="1"/>
+          <p:nvPr/>
+        </p:nvSpPr>
+        <p:spPr>
+          <a:xfrm>
+            <a:off x="457200" y="6263640"/>
+            <a:ext cx="11430000" cy="365760"/>
+          </a:xfrm>
+          <a:prstGeom prst="rect">
+            <a:avLst/>
+          </a:prstGeom>
+          <a:noFill/>
+        </p:spPr>
+        <p:txBody>
+          <a:bodyPr wrap="none" anchor="t">
+            <a:spAutoFit/>
+          </a:bodyPr>
+          <a:lstStyle/>
+          <a:p>
+            <a:pPr algn="l"/>
+            <a:r>
+              <a:rPr sz="1000" b="0" i="0" u="none">
+                <a:solidFill>
+                  <a:srgbClr val="000000"/>
+                </a:solidFill>
+              </a:rPr>
+              <a:t>Notes: Adjusted for recent acquisitions.</a:t>
+            </a:r>
+          </a:p>
+        </p:txBody>
+      </p:sp>
+    </p:spTree>
+  </p:cSld>
+  <p:clrMapOvr>
+    <a:masterClrMapping/>
+  </p:clrMapOvr>
+</p:sld>
+</file>
+
 <file path=ppt/theme/theme1.xml><?xml version="1.0" encoding="utf-8"?>
 <a:theme xmlns:a="http://schemas.openxmlformats.org/drawingml/2006/main" name="Simple Light">
   <a:themeElements>

</xml_diff>

<commit_message>
resolve chart text styling
</commit_message>
<xml_diff>
--- a/notebooks/demo.pptx
+++ b/notebooks/demo.pptx
@@ -15,6 +15,7 @@
     <p:sldId id="260" r:id="rId22"/>
     <p:sldId id="261" r:id="rId23"/>
     <p:sldId id="262" r:id="rId24"/>
+    <p:sldId id="263" r:id="rId25"/>
   </p:sldIdLst>
   <p:sldSz cx="12188825" cy="6858000"/>
   <p:notesSz cx="6858000" cy="9144000"/>
@@ -1951,6 +1952,1114 @@
 </file>
 
 <file path=ppt/charts/chart15.xml><?xml version="1.0" encoding="utf-8"?>
+<c:chartSpace xmlns:c="http://schemas.openxmlformats.org/drawingml/2006/chart" xmlns:a="http://schemas.openxmlformats.org/drawingml/2006/main" xmlns:r="http://schemas.openxmlformats.org/officeDocument/2006/relationships">
+  <c:date1904 val="0"/>
+  <c:chart>
+    <c:autoTitleDeleted val="1"/>
+    <c:plotArea>
+      <c:lineChart>
+        <c:grouping val="standard"/>
+        <c:varyColors val="0"/>
+        <c:ser>
+          <c:idx val="0"/>
+          <c:order val="0"/>
+          <c:tx>
+            <c:strRef>
+              <c:f>Sheet1!$B$1</c:f>
+              <c:strCache>
+                <c:ptCount val="1"/>
+                <c:pt idx="0">
+                  <c:v>Revenue!</c:v>
+                </c:pt>
+              </c:strCache>
+            </c:strRef>
+          </c:tx>
+          <c:spPr>
+            <a:solidFill>
+              <a:srgbClr val="4E79A7"/>
+            </a:solidFill>
+            <a:ln w="25400">
+              <a:solidFill>
+                <a:srgbClr val="4E79A7"/>
+              </a:solidFill>
+              <a:prstDash val="dash"/>
+            </a:ln>
+          </c:spPr>
+          <c:marker>
+            <c:symbol val="none"/>
+          </c:marker>
+          <c:cat>
+            <c:strRef>
+              <c:f>Sheet1!$A$2:$A$5</c:f>
+              <c:strCache>
+                <c:ptCount val="4"/>
+                <c:pt idx="0">
+                  <c:v>Jan</c:v>
+                </c:pt>
+                <c:pt idx="1">
+                  <c:v>Feb</c:v>
+                </c:pt>
+                <c:pt idx="2">
+                  <c:v>Mar</c:v>
+                </c:pt>
+                <c:pt idx="3">
+                  <c:v>Apr</c:v>
+                </c:pt>
+              </c:strCache>
+            </c:strRef>
+          </c:cat>
+          <c:val>
+            <c:numRef>
+              <c:f>Sheet1!$B$2:$B$5</c:f>
+              <c:numCache>
+                <c:formatCode>General</c:formatCode>
+                <c:ptCount val="4"/>
+                <c:pt idx="0">
+                  <c:v>10</c:v>
+                </c:pt>
+                <c:pt idx="1">
+                  <c:v>14</c:v>
+                </c:pt>
+                <c:pt idx="2">
+                  <c:v>9</c:v>
+                </c:pt>
+                <c:pt idx="3">
+                  <c:v>18</c:v>
+                </c:pt>
+              </c:numCache>
+            </c:numRef>
+          </c:val>
+          <c:smooth val="0"/>
+        </c:ser>
+        <c:ser>
+          <c:idx val="1"/>
+          <c:order val="1"/>
+          <c:tx>
+            <c:strRef>
+              <c:f>Sheet1!$C$1</c:f>
+              <c:strCache>
+                <c:ptCount val="1"/>
+                <c:pt idx="0">
+                  <c:v>Cost!</c:v>
+                </c:pt>
+              </c:strCache>
+            </c:strRef>
+          </c:tx>
+          <c:spPr>
+            <a:solidFill>
+              <a:srgbClr val="F28E2B"/>
+            </a:solidFill>
+            <a:ln w="25400">
+              <a:solidFill>
+                <a:srgbClr val="F28E2B"/>
+              </a:solidFill>
+              <a:prstDash val="dash"/>
+            </a:ln>
+          </c:spPr>
+          <c:marker>
+            <c:symbol val="none"/>
+          </c:marker>
+          <c:cat>
+            <c:strRef>
+              <c:f>Sheet1!$A$2:$A$5</c:f>
+              <c:strCache>
+                <c:ptCount val="4"/>
+                <c:pt idx="0">
+                  <c:v>Jan</c:v>
+                </c:pt>
+                <c:pt idx="1">
+                  <c:v>Feb</c:v>
+                </c:pt>
+                <c:pt idx="2">
+                  <c:v>Mar</c:v>
+                </c:pt>
+                <c:pt idx="3">
+                  <c:v>Apr</c:v>
+                </c:pt>
+              </c:strCache>
+            </c:strRef>
+          </c:cat>
+          <c:val>
+            <c:numRef>
+              <c:f>Sheet1!$C$2:$C$5</c:f>
+              <c:numCache>
+                <c:formatCode>General</c:formatCode>
+                <c:ptCount val="4"/>
+                <c:pt idx="0">
+                  <c:v>2</c:v>
+                </c:pt>
+                <c:pt idx="1">
+                  <c:v>4</c:v>
+                </c:pt>
+                <c:pt idx="2">
+                  <c:v>3</c:v>
+                </c:pt>
+                <c:pt idx="3">
+                  <c:v>1</c:v>
+                </c:pt>
+              </c:numCache>
+            </c:numRef>
+          </c:val>
+          <c:smooth val="0"/>
+        </c:ser>
+        <c:marker val="1"/>
+        <c:smooth val="0"/>
+        <c:axId val="2118791784"/>
+        <c:axId val="2140495176"/>
+      </c:lineChart>
+      <c:catAx>
+        <c:axId val="2118791784"/>
+        <c:scaling>
+          <c:orientation val="minMax"/>
+        </c:scaling>
+        <c:delete val="0"/>
+        <c:axPos val="b"/>
+        <c:title>
+          <c:tx>
+            <c:rich>
+              <a:bodyPr/>
+              <a:lstStyle/>
+              <a:p>
+                <a:pPr>
+                  <a:defRPr sz="1400" b="1" i="0" u="none"/>
+                </a:pPr>
+                <a:r>
+                  <a:t>Revenue</a:t>
+                </a:r>
+              </a:p>
+            </c:rich>
+          </c:tx>
+          <c:layout/>
+          <c:overlay val="0"/>
+        </c:title>
+        <c:majorTickMark val="out"/>
+        <c:minorTickMark val="none"/>
+        <c:tickLblPos val="low"/>
+        <c:txPr>
+          <a:bodyPr/>
+          <a:lstStyle/>
+          <a:p>
+            <a:pPr>
+              <a:defRPr sz="1400"/>
+            </a:pPr>
+          </a:p>
+        </c:txPr>
+        <c:crossAx val="2140495176"/>
+        <c:crosses val="autoZero"/>
+        <c:auto val="1"/>
+        <c:lblAlgn val="ctr"/>
+        <c:lblOffset val="100"/>
+        <c:noMultiLvlLbl val="0"/>
+      </c:catAx>
+      <c:valAx>
+        <c:axId val="2140495176"/>
+        <c:scaling>
+          <c:max val="30.0"/>
+          <c:min val="0.0"/>
+        </c:scaling>
+        <c:delete val="0"/>
+        <c:axPos val="l"/>
+        <c:title>
+          <c:tx>
+            <c:rich>
+              <a:bodyPr/>
+              <a:lstStyle/>
+              <a:p>
+                <a:pPr>
+                  <a:defRPr sz="1400" b="1" i="0" u="none"/>
+                </a:pPr>
+                <a:r>
+                  <a:t>Month</a:t>
+                </a:r>
+              </a:p>
+            </c:rich>
+          </c:tx>
+          <c:layout/>
+          <c:overlay val="0"/>
+        </c:title>
+        <c:numFmt formatCode="$0.0" sourceLinked="0"/>
+        <c:majorTickMark val="out"/>
+        <c:minorTickMark val="none"/>
+        <c:tickLblPos val="nextTo"/>
+        <c:txPr>
+          <a:bodyPr/>
+          <a:lstStyle/>
+          <a:p>
+            <a:pPr>
+              <a:defRPr sz="1400"/>
+            </a:pPr>
+          </a:p>
+        </c:txPr>
+        <c:crossAx val="2118791784"/>
+        <c:crosses val="autoZero"/>
+      </c:valAx>
+    </c:plotArea>
+    <c:legend>
+      <c:legendPos val="b"/>
+      <c:layout/>
+      <c:overlay val="0"/>
+      <c:txPr>
+        <a:bodyPr/>
+        <a:lstStyle/>
+        <a:p>
+          <a:pPr>
+            <a:defRPr sz="1400"/>
+          </a:pPr>
+        </a:p>
+      </c:txPr>
+    </c:legend>
+    <c:plotVisOnly val="1"/>
+    <c:dispBlanksAs val="gap"/>
+    <c:showDLblsOverMax val="0"/>
+  </c:chart>
+  <c:txPr>
+    <a:bodyPr/>
+    <a:lstStyle/>
+    <a:p>
+      <a:pPr>
+        <a:defRPr sz="1800"/>
+      </a:pPr>
+      <a:endParaRPr lang="en-US"/>
+    </a:p>
+  </c:txPr>
+  <c:externalData r:id="rId1">
+    <c:autoUpdate val="0"/>
+  </c:externalData>
+</c:chartSpace>
+</file>
+
+<file path=ppt/charts/chart16.xml><?xml version="1.0" encoding="utf-8"?>
+<c:chartSpace xmlns:c="http://schemas.openxmlformats.org/drawingml/2006/chart" xmlns:a="http://schemas.openxmlformats.org/drawingml/2006/main" xmlns:r="http://schemas.openxmlformats.org/officeDocument/2006/relationships">
+  <c:date1904 val="0"/>
+  <c:chart>
+    <c:autoTitleDeleted val="1"/>
+    <c:plotArea>
+      <c:lineChart>
+        <c:grouping val="standard"/>
+        <c:varyColors val="0"/>
+        <c:ser>
+          <c:idx val="0"/>
+          <c:order val="0"/>
+          <c:tx>
+            <c:strRef>
+              <c:f>Sheet1!$B$1</c:f>
+              <c:strCache>
+                <c:ptCount val="1"/>
+                <c:pt idx="0">
+                  <c:v>Revenue!</c:v>
+                </c:pt>
+              </c:strCache>
+            </c:strRef>
+          </c:tx>
+          <c:spPr>
+            <a:solidFill>
+              <a:srgbClr val="4E79A7"/>
+            </a:solidFill>
+            <a:ln w="25400">
+              <a:solidFill>
+                <a:srgbClr val="4E79A7"/>
+              </a:solidFill>
+              <a:prstDash val="dash"/>
+            </a:ln>
+          </c:spPr>
+          <c:marker>
+            <c:symbol val="none"/>
+          </c:marker>
+          <c:cat>
+            <c:strRef>
+              <c:f>Sheet1!$A$2:$A$5</c:f>
+              <c:strCache>
+                <c:ptCount val="4"/>
+                <c:pt idx="0">
+                  <c:v>Jan</c:v>
+                </c:pt>
+                <c:pt idx="1">
+                  <c:v>Feb</c:v>
+                </c:pt>
+                <c:pt idx="2">
+                  <c:v>Mar</c:v>
+                </c:pt>
+                <c:pt idx="3">
+                  <c:v>Apr</c:v>
+                </c:pt>
+              </c:strCache>
+            </c:strRef>
+          </c:cat>
+          <c:val>
+            <c:numRef>
+              <c:f>Sheet1!$B$2:$B$5</c:f>
+              <c:numCache>
+                <c:formatCode>General</c:formatCode>
+                <c:ptCount val="4"/>
+                <c:pt idx="0">
+                  <c:v>10</c:v>
+                </c:pt>
+                <c:pt idx="1">
+                  <c:v>14</c:v>
+                </c:pt>
+                <c:pt idx="2">
+                  <c:v>9</c:v>
+                </c:pt>
+                <c:pt idx="3">
+                  <c:v>18</c:v>
+                </c:pt>
+              </c:numCache>
+            </c:numRef>
+          </c:val>
+          <c:smooth val="0"/>
+        </c:ser>
+        <c:ser>
+          <c:idx val="1"/>
+          <c:order val="1"/>
+          <c:tx>
+            <c:strRef>
+              <c:f>Sheet1!$C$1</c:f>
+              <c:strCache>
+                <c:ptCount val="1"/>
+                <c:pt idx="0">
+                  <c:v>Cost!</c:v>
+                </c:pt>
+              </c:strCache>
+            </c:strRef>
+          </c:tx>
+          <c:spPr>
+            <a:solidFill>
+              <a:srgbClr val="F28E2B"/>
+            </a:solidFill>
+            <a:ln w="25400">
+              <a:solidFill>
+                <a:srgbClr val="F28E2B"/>
+              </a:solidFill>
+              <a:prstDash val="dash"/>
+            </a:ln>
+          </c:spPr>
+          <c:marker>
+            <c:symbol val="none"/>
+          </c:marker>
+          <c:cat>
+            <c:strRef>
+              <c:f>Sheet1!$A$2:$A$5</c:f>
+              <c:strCache>
+                <c:ptCount val="4"/>
+                <c:pt idx="0">
+                  <c:v>Jan</c:v>
+                </c:pt>
+                <c:pt idx="1">
+                  <c:v>Feb</c:v>
+                </c:pt>
+                <c:pt idx="2">
+                  <c:v>Mar</c:v>
+                </c:pt>
+                <c:pt idx="3">
+                  <c:v>Apr</c:v>
+                </c:pt>
+              </c:strCache>
+            </c:strRef>
+          </c:cat>
+          <c:val>
+            <c:numRef>
+              <c:f>Sheet1!$C$2:$C$5</c:f>
+              <c:numCache>
+                <c:formatCode>General</c:formatCode>
+                <c:ptCount val="4"/>
+                <c:pt idx="0">
+                  <c:v>2</c:v>
+                </c:pt>
+                <c:pt idx="1">
+                  <c:v>4</c:v>
+                </c:pt>
+                <c:pt idx="2">
+                  <c:v>3</c:v>
+                </c:pt>
+                <c:pt idx="3">
+                  <c:v>1</c:v>
+                </c:pt>
+              </c:numCache>
+            </c:numRef>
+          </c:val>
+          <c:smooth val="0"/>
+        </c:ser>
+        <c:marker val="1"/>
+        <c:smooth val="0"/>
+        <c:axId val="2118791784"/>
+        <c:axId val="2140495176"/>
+      </c:lineChart>
+      <c:catAx>
+        <c:axId val="2118791784"/>
+        <c:scaling>
+          <c:orientation val="minMax"/>
+        </c:scaling>
+        <c:delete val="0"/>
+        <c:axPos val="b"/>
+        <c:title>
+          <c:tx>
+            <c:rich>
+              <a:bodyPr/>
+              <a:lstStyle/>
+              <a:p>
+                <a:pPr>
+                  <a:defRPr sz="1400" b="1" i="0" u="none"/>
+                </a:pPr>
+                <a:r>
+                  <a:t>Revenue</a:t>
+                </a:r>
+              </a:p>
+            </c:rich>
+          </c:tx>
+          <c:layout/>
+          <c:overlay val="0"/>
+        </c:title>
+        <c:majorTickMark val="out"/>
+        <c:minorTickMark val="none"/>
+        <c:tickLblPos val="low"/>
+        <c:txPr>
+          <a:bodyPr/>
+          <a:lstStyle/>
+          <a:p>
+            <a:pPr>
+              <a:defRPr sz="1400"/>
+            </a:pPr>
+          </a:p>
+        </c:txPr>
+        <c:crossAx val="2140495176"/>
+        <c:crosses val="autoZero"/>
+        <c:auto val="1"/>
+        <c:lblAlgn val="ctr"/>
+        <c:lblOffset val="100"/>
+        <c:noMultiLvlLbl val="0"/>
+      </c:catAx>
+      <c:valAx>
+        <c:axId val="2140495176"/>
+        <c:scaling>
+          <c:max val="30.0"/>
+          <c:min val="0.0"/>
+        </c:scaling>
+        <c:delete val="0"/>
+        <c:axPos val="l"/>
+        <c:title>
+          <c:tx>
+            <c:rich>
+              <a:bodyPr/>
+              <a:lstStyle/>
+              <a:p>
+                <a:pPr>
+                  <a:defRPr sz="1400" b="1" i="0" u="none"/>
+                </a:pPr>
+                <a:r>
+                  <a:t>Month</a:t>
+                </a:r>
+              </a:p>
+            </c:rich>
+          </c:tx>
+          <c:layout/>
+          <c:overlay val="0"/>
+        </c:title>
+        <c:numFmt formatCode="$0.0" sourceLinked="0"/>
+        <c:majorTickMark val="out"/>
+        <c:minorTickMark val="none"/>
+        <c:tickLblPos val="nextTo"/>
+        <c:txPr>
+          <a:bodyPr/>
+          <a:lstStyle/>
+          <a:p>
+            <a:pPr>
+              <a:defRPr sz="1400"/>
+            </a:pPr>
+          </a:p>
+        </c:txPr>
+        <c:crossAx val="2118791784"/>
+        <c:crosses val="autoZero"/>
+      </c:valAx>
+    </c:plotArea>
+    <c:legend>
+      <c:legendPos val="b"/>
+      <c:layout/>
+      <c:overlay val="0"/>
+      <c:txPr>
+        <a:bodyPr/>
+        <a:lstStyle/>
+        <a:p>
+          <a:pPr>
+            <a:defRPr sz="1400"/>
+          </a:pPr>
+        </a:p>
+      </c:txPr>
+    </c:legend>
+    <c:plotVisOnly val="1"/>
+    <c:dispBlanksAs val="gap"/>
+    <c:showDLblsOverMax val="0"/>
+  </c:chart>
+  <c:txPr>
+    <a:bodyPr/>
+    <a:lstStyle/>
+    <a:p>
+      <a:pPr>
+        <a:defRPr sz="1800"/>
+      </a:pPr>
+      <a:endParaRPr lang="en-US"/>
+    </a:p>
+  </c:txPr>
+  <c:externalData r:id="rId1">
+    <c:autoUpdate val="0"/>
+  </c:externalData>
+</c:chartSpace>
+</file>
+
+<file path=ppt/charts/chart17.xml><?xml version="1.0" encoding="utf-8"?>
+<c:chartSpace xmlns:c="http://schemas.openxmlformats.org/drawingml/2006/chart" xmlns:a="http://schemas.openxmlformats.org/drawingml/2006/main" xmlns:r="http://schemas.openxmlformats.org/officeDocument/2006/relationships">
+  <c:date1904 val="0"/>
+  <c:chart>
+    <c:autoTitleDeleted val="1"/>
+    <c:plotArea>
+      <c:lineChart>
+        <c:grouping val="standard"/>
+        <c:varyColors val="0"/>
+        <c:ser>
+          <c:idx val="0"/>
+          <c:order val="0"/>
+          <c:tx>
+            <c:strRef>
+              <c:f>Sheet1!$B$1</c:f>
+              <c:strCache>
+                <c:ptCount val="1"/>
+                <c:pt idx="0">
+                  <c:v>revenue</c:v>
+                </c:pt>
+              </c:strCache>
+            </c:strRef>
+          </c:tx>
+          <c:spPr>
+            <a:solidFill>
+              <a:srgbClr val="4E79A7"/>
+            </a:solidFill>
+            <a:ln w="25400">
+              <a:solidFill>
+                <a:srgbClr val="4E79A7"/>
+              </a:solidFill>
+              <a:prstDash val="dash"/>
+            </a:ln>
+          </c:spPr>
+          <c:marker>
+            <c:symbol val="none"/>
+          </c:marker>
+          <c:cat>
+            <c:strRef>
+              <c:f>Sheet1!$A$2:$A$5</c:f>
+              <c:strCache>
+                <c:ptCount val="4"/>
+                <c:pt idx="0">
+                  <c:v>Jan</c:v>
+                </c:pt>
+                <c:pt idx="1">
+                  <c:v>Feb</c:v>
+                </c:pt>
+                <c:pt idx="2">
+                  <c:v>Mar</c:v>
+                </c:pt>
+                <c:pt idx="3">
+                  <c:v>Apr</c:v>
+                </c:pt>
+              </c:strCache>
+            </c:strRef>
+          </c:cat>
+          <c:val>
+            <c:numRef>
+              <c:f>Sheet1!$B$2:$B$5</c:f>
+              <c:numCache>
+                <c:formatCode>General</c:formatCode>
+                <c:ptCount val="4"/>
+                <c:pt idx="0">
+                  <c:v>10</c:v>
+                </c:pt>
+                <c:pt idx="1">
+                  <c:v>14</c:v>
+                </c:pt>
+                <c:pt idx="2">
+                  <c:v>9</c:v>
+                </c:pt>
+                <c:pt idx="3">
+                  <c:v>18</c:v>
+                </c:pt>
+              </c:numCache>
+            </c:numRef>
+          </c:val>
+          <c:smooth val="0"/>
+        </c:ser>
+        <c:ser>
+          <c:idx val="1"/>
+          <c:order val="1"/>
+          <c:tx>
+            <c:strRef>
+              <c:f>Sheet1!$C$1</c:f>
+              <c:strCache>
+                <c:ptCount val="1"/>
+                <c:pt idx="0">
+                  <c:v>cost</c:v>
+                </c:pt>
+              </c:strCache>
+            </c:strRef>
+          </c:tx>
+          <c:spPr>
+            <a:solidFill>
+              <a:srgbClr val="F28E2B"/>
+            </a:solidFill>
+            <a:ln w="25400">
+              <a:solidFill>
+                <a:srgbClr val="F28E2B"/>
+              </a:solidFill>
+              <a:prstDash val="dash"/>
+            </a:ln>
+          </c:spPr>
+          <c:marker>
+            <c:symbol val="none"/>
+          </c:marker>
+          <c:cat>
+            <c:strRef>
+              <c:f>Sheet1!$A$2:$A$5</c:f>
+              <c:strCache>
+                <c:ptCount val="4"/>
+                <c:pt idx="0">
+                  <c:v>Jan</c:v>
+                </c:pt>
+                <c:pt idx="1">
+                  <c:v>Feb</c:v>
+                </c:pt>
+                <c:pt idx="2">
+                  <c:v>Mar</c:v>
+                </c:pt>
+                <c:pt idx="3">
+                  <c:v>Apr</c:v>
+                </c:pt>
+              </c:strCache>
+            </c:strRef>
+          </c:cat>
+          <c:val>
+            <c:numRef>
+              <c:f>Sheet1!$C$2:$C$5</c:f>
+              <c:numCache>
+                <c:formatCode>General</c:formatCode>
+                <c:ptCount val="4"/>
+                <c:pt idx="0">
+                  <c:v>2</c:v>
+                </c:pt>
+                <c:pt idx="1">
+                  <c:v>4</c:v>
+                </c:pt>
+                <c:pt idx="2">
+                  <c:v>3</c:v>
+                </c:pt>
+                <c:pt idx="3">
+                  <c:v>1</c:v>
+                </c:pt>
+              </c:numCache>
+            </c:numRef>
+          </c:val>
+          <c:smooth val="0"/>
+        </c:ser>
+        <c:marker val="1"/>
+        <c:smooth val="0"/>
+        <c:axId val="2118791784"/>
+        <c:axId val="2140495176"/>
+      </c:lineChart>
+      <c:catAx>
+        <c:axId val="2118791784"/>
+        <c:scaling>
+          <c:orientation val="minMax"/>
+        </c:scaling>
+        <c:delete val="0"/>
+        <c:axPos val="b"/>
+        <c:title>
+          <c:tx>
+            <c:rich>
+              <a:bodyPr/>
+              <a:lstStyle/>
+              <a:p>
+                <a:pPr>
+                  <a:defRPr sz="1400" b="1" i="0" u="none"/>
+                </a:pPr>
+                <a:r>
+                  <a:t>Revenue</a:t>
+                </a:r>
+              </a:p>
+            </c:rich>
+          </c:tx>
+          <c:layout/>
+          <c:overlay val="0"/>
+        </c:title>
+        <c:majorTickMark val="out"/>
+        <c:minorTickMark val="none"/>
+        <c:tickLblPos val="low"/>
+        <c:txPr>
+          <a:bodyPr/>
+          <a:lstStyle/>
+          <a:p>
+            <a:pPr>
+              <a:defRPr sz="1400"/>
+            </a:pPr>
+          </a:p>
+        </c:txPr>
+        <c:crossAx val="2140495176"/>
+        <c:crosses val="autoZero"/>
+        <c:auto val="1"/>
+        <c:lblAlgn val="ctr"/>
+        <c:lblOffset val="100"/>
+        <c:noMultiLvlLbl val="0"/>
+      </c:catAx>
+      <c:valAx>
+        <c:axId val="2140495176"/>
+        <c:scaling>
+          <c:max val="30.0"/>
+          <c:min val="0.0"/>
+        </c:scaling>
+        <c:delete val="0"/>
+        <c:axPos val="l"/>
+        <c:title>
+          <c:tx>
+            <c:rich>
+              <a:bodyPr/>
+              <a:lstStyle/>
+              <a:p>
+                <a:pPr>
+                  <a:defRPr sz="1400" b="1" i="0" u="none"/>
+                </a:pPr>
+                <a:r>
+                  <a:t>Month</a:t>
+                </a:r>
+              </a:p>
+            </c:rich>
+          </c:tx>
+          <c:layout/>
+          <c:overlay val="0"/>
+        </c:title>
+        <c:numFmt formatCode="$0.0" sourceLinked="0"/>
+        <c:majorTickMark val="out"/>
+        <c:minorTickMark val="none"/>
+        <c:tickLblPos val="nextTo"/>
+        <c:txPr>
+          <a:bodyPr/>
+          <a:lstStyle/>
+          <a:p>
+            <a:pPr>
+              <a:defRPr sz="1400"/>
+            </a:pPr>
+          </a:p>
+        </c:txPr>
+        <c:crossAx val="2118791784"/>
+        <c:crosses val="autoZero"/>
+      </c:valAx>
+    </c:plotArea>
+    <c:legend>
+      <c:legendPos val="b"/>
+      <c:layout/>
+      <c:overlay val="0"/>
+      <c:txPr>
+        <a:bodyPr/>
+        <a:lstStyle/>
+        <a:p>
+          <a:pPr>
+            <a:defRPr sz="1400"/>
+          </a:pPr>
+        </a:p>
+      </c:txPr>
+    </c:legend>
+    <c:plotVisOnly val="1"/>
+    <c:dispBlanksAs val="gap"/>
+    <c:showDLblsOverMax val="0"/>
+  </c:chart>
+  <c:txPr>
+    <a:bodyPr/>
+    <a:lstStyle/>
+    <a:p>
+      <a:pPr>
+        <a:defRPr sz="1800"/>
+      </a:pPr>
+      <a:endParaRPr lang="en-US"/>
+    </a:p>
+  </c:txPr>
+  <c:externalData r:id="rId1">
+    <c:autoUpdate val="0"/>
+  </c:externalData>
+</c:chartSpace>
+</file>
+
+<file path=ppt/charts/chart18.xml><?xml version="1.0" encoding="utf-8"?>
+<c:chartSpace xmlns:c="http://schemas.openxmlformats.org/drawingml/2006/chart" xmlns:a="http://schemas.openxmlformats.org/drawingml/2006/main" xmlns:r="http://schemas.openxmlformats.org/officeDocument/2006/relationships">
+  <c:date1904 val="0"/>
+  <c:chart>
+    <c:autoTitleDeleted val="1"/>
+    <c:plotArea>
+      <c:lineChart>
+        <c:grouping val="standard"/>
+        <c:varyColors val="0"/>
+        <c:ser>
+          <c:idx val="0"/>
+          <c:order val="0"/>
+          <c:tx>
+            <c:strRef>
+              <c:f>Sheet1!$B$1</c:f>
+              <c:strCache>
+                <c:ptCount val="1"/>
+                <c:pt idx="0">
+                  <c:v>Revenue!</c:v>
+                </c:pt>
+              </c:strCache>
+            </c:strRef>
+          </c:tx>
+          <c:spPr>
+            <a:solidFill>
+              <a:srgbClr val="4E79A7"/>
+            </a:solidFill>
+            <a:ln w="25400">
+              <a:solidFill>
+                <a:srgbClr val="4E79A7"/>
+              </a:solidFill>
+              <a:prstDash val="dash"/>
+            </a:ln>
+          </c:spPr>
+          <c:marker>
+            <c:symbol val="none"/>
+          </c:marker>
+          <c:cat>
+            <c:strRef>
+              <c:f>Sheet1!$A$2:$A$5</c:f>
+              <c:strCache>
+                <c:ptCount val="4"/>
+                <c:pt idx="0">
+                  <c:v>Jan</c:v>
+                </c:pt>
+                <c:pt idx="1">
+                  <c:v>Feb</c:v>
+                </c:pt>
+                <c:pt idx="2">
+                  <c:v>Mar</c:v>
+                </c:pt>
+                <c:pt idx="3">
+                  <c:v>Apr</c:v>
+                </c:pt>
+              </c:strCache>
+            </c:strRef>
+          </c:cat>
+          <c:val>
+            <c:numRef>
+              <c:f>Sheet1!$B$2:$B$5</c:f>
+              <c:numCache>
+                <c:formatCode>General</c:formatCode>
+                <c:ptCount val="4"/>
+                <c:pt idx="0">
+                  <c:v>10</c:v>
+                </c:pt>
+                <c:pt idx="1">
+                  <c:v>14</c:v>
+                </c:pt>
+                <c:pt idx="2">
+                  <c:v>9</c:v>
+                </c:pt>
+                <c:pt idx="3">
+                  <c:v>18</c:v>
+                </c:pt>
+              </c:numCache>
+            </c:numRef>
+          </c:val>
+          <c:smooth val="0"/>
+        </c:ser>
+        <c:ser>
+          <c:idx val="1"/>
+          <c:order val="1"/>
+          <c:tx>
+            <c:strRef>
+              <c:f>Sheet1!$C$1</c:f>
+              <c:strCache>
+                <c:ptCount val="1"/>
+                <c:pt idx="0">
+                  <c:v>Cost!</c:v>
+                </c:pt>
+              </c:strCache>
+            </c:strRef>
+          </c:tx>
+          <c:spPr>
+            <a:solidFill>
+              <a:srgbClr val="F28E2B"/>
+            </a:solidFill>
+            <a:ln w="25400">
+              <a:solidFill>
+                <a:srgbClr val="F28E2B"/>
+              </a:solidFill>
+              <a:prstDash val="dash"/>
+            </a:ln>
+          </c:spPr>
+          <c:marker>
+            <c:symbol val="none"/>
+          </c:marker>
+          <c:cat>
+            <c:strRef>
+              <c:f>Sheet1!$A$2:$A$5</c:f>
+              <c:strCache>
+                <c:ptCount val="4"/>
+                <c:pt idx="0">
+                  <c:v>Jan</c:v>
+                </c:pt>
+                <c:pt idx="1">
+                  <c:v>Feb</c:v>
+                </c:pt>
+                <c:pt idx="2">
+                  <c:v>Mar</c:v>
+                </c:pt>
+                <c:pt idx="3">
+                  <c:v>Apr</c:v>
+                </c:pt>
+              </c:strCache>
+            </c:strRef>
+          </c:cat>
+          <c:val>
+            <c:numRef>
+              <c:f>Sheet1!$C$2:$C$5</c:f>
+              <c:numCache>
+                <c:formatCode>General</c:formatCode>
+                <c:ptCount val="4"/>
+                <c:pt idx="0">
+                  <c:v>2</c:v>
+                </c:pt>
+                <c:pt idx="1">
+                  <c:v>4</c:v>
+                </c:pt>
+                <c:pt idx="2">
+                  <c:v>3</c:v>
+                </c:pt>
+                <c:pt idx="3">
+                  <c:v>1</c:v>
+                </c:pt>
+              </c:numCache>
+            </c:numRef>
+          </c:val>
+          <c:smooth val="0"/>
+        </c:ser>
+        <c:marker val="1"/>
+        <c:smooth val="0"/>
+        <c:axId val="2118791784"/>
+        <c:axId val="2140495176"/>
+      </c:lineChart>
+      <c:catAx>
+        <c:axId val="2118791784"/>
+        <c:scaling>
+          <c:orientation val="minMax"/>
+        </c:scaling>
+        <c:delete val="0"/>
+        <c:axPos val="b"/>
+        <c:title>
+          <c:tx>
+            <c:rich>
+              <a:bodyPr/>
+              <a:lstStyle/>
+              <a:p>
+                <a:pPr>
+                  <a:defRPr sz="1400" b="1" i="0" u="none"/>
+                </a:pPr>
+                <a:r>
+                  <a:t>Revenue</a:t>
+                </a:r>
+              </a:p>
+            </c:rich>
+          </c:tx>
+          <c:layout/>
+          <c:overlay val="0"/>
+        </c:title>
+        <c:majorTickMark val="out"/>
+        <c:minorTickMark val="none"/>
+        <c:tickLblPos val="low"/>
+        <c:txPr>
+          <a:bodyPr/>
+          <a:lstStyle/>
+          <a:p>
+            <a:pPr>
+              <a:defRPr sz="1400"/>
+            </a:pPr>
+          </a:p>
+        </c:txPr>
+        <c:crossAx val="2140495176"/>
+        <c:crosses val="autoZero"/>
+        <c:auto val="1"/>
+        <c:lblAlgn val="ctr"/>
+        <c:lblOffset val="100"/>
+        <c:noMultiLvlLbl val="0"/>
+      </c:catAx>
+      <c:valAx>
+        <c:axId val="2140495176"/>
+        <c:scaling>
+          <c:max val="30.0"/>
+          <c:min val="0.0"/>
+        </c:scaling>
+        <c:delete val="0"/>
+        <c:axPos val="l"/>
+        <c:title>
+          <c:tx>
+            <c:rich>
+              <a:bodyPr/>
+              <a:lstStyle/>
+              <a:p>
+                <a:pPr>
+                  <a:defRPr sz="1400" b="1" i="0" u="none"/>
+                </a:pPr>
+                <a:r>
+                  <a:t>Month</a:t>
+                </a:r>
+              </a:p>
+            </c:rich>
+          </c:tx>
+          <c:layout/>
+          <c:overlay val="0"/>
+        </c:title>
+        <c:numFmt formatCode="$0.0" sourceLinked="0"/>
+        <c:majorTickMark val="out"/>
+        <c:minorTickMark val="none"/>
+        <c:tickLblPos val="nextTo"/>
+        <c:txPr>
+          <a:bodyPr/>
+          <a:lstStyle/>
+          <a:p>
+            <a:pPr>
+              <a:defRPr sz="1400"/>
+            </a:pPr>
+          </a:p>
+        </c:txPr>
+        <c:crossAx val="2118791784"/>
+        <c:crosses val="autoZero"/>
+      </c:valAx>
+    </c:plotArea>
+    <c:legend>
+      <c:legendPos val="b"/>
+      <c:layout/>
+      <c:overlay val="0"/>
+      <c:txPr>
+        <a:bodyPr/>
+        <a:lstStyle/>
+        <a:p>
+          <a:pPr>
+            <a:defRPr sz="1400"/>
+          </a:pPr>
+        </a:p>
+      </c:txPr>
+    </c:legend>
+    <c:plotVisOnly val="1"/>
+    <c:dispBlanksAs val="gap"/>
+    <c:showDLblsOverMax val="0"/>
+  </c:chart>
+  <c:txPr>
+    <a:bodyPr/>
+    <a:lstStyle/>
+    <a:p>
+      <a:pPr>
+        <a:defRPr sz="1800"/>
+      </a:pPr>
+      <a:endParaRPr lang="en-US"/>
+    </a:p>
+  </c:txPr>
+  <c:externalData r:id="rId1">
+    <c:autoUpdate val="0"/>
+  </c:externalData>
+</c:chartSpace>
+</file>
+
+<file path=ppt/charts/chart19.xml><?xml version="1.0" encoding="utf-8"?>
 <c:chartSpace xmlns:c="http://schemas.openxmlformats.org/drawingml/2006/chart" xmlns:a="http://schemas.openxmlformats.org/drawingml/2006/main" xmlns:r="http://schemas.openxmlformats.org/officeDocument/2006/relationships">
   <c:date1904 val="0"/>
   <c:chart>
@@ -7535,7 +8644,7 @@
           <a:p>
             <a:pPr algn="l"/>
             <a:r>
-              <a:rPr sz="3200" b="1" i="0" u="none">
+              <a:rPr sz="4400" b="1" i="0" u="none">
                 <a:solidFill>
                   <a:srgbClr val="7F7F7F"/>
                 </a:solidFill>
@@ -7673,7 +8782,7 @@
           <a:p>
             <a:pPr algn="ctr"/>
             <a:r>
-              <a:rPr sz="1600" b="1" i="0" u="sng">
+              <a:rPr sz="1400" b="1" i="0" u="sng">
                 <a:solidFill>
                   <a:srgbClr val="000000"/>
                 </a:solidFill>
@@ -7682,7 +8791,7 @@
 </a:t>
             </a:r>
             <a:r>
-              <a:rPr sz="1400" b="0" i="1" u="none">
+              <a:rPr sz="1200" b="0" i="1" u="none">
                 <a:solidFill>
                   <a:srgbClr val="000000"/>
                 </a:solidFill>
@@ -8273,7 +9382,7 @@
           <a:p>
             <a:pPr algn="ctr"/>
             <a:r>
-              <a:rPr sz="1600" b="1" i="0" u="sng">
+              <a:rPr sz="1400" b="1" i="0" u="sng">
                 <a:solidFill>
                   <a:srgbClr val="000000"/>
                 </a:solidFill>
@@ -8325,7 +9434,7 @@
           <a:p>
             <a:pPr algn="ctr"/>
             <a:r>
-              <a:rPr sz="1600" b="1" i="0" u="sng">
+              <a:rPr sz="1400" b="1" i="0" u="sng">
                 <a:solidFill>
                   <a:srgbClr val="000000"/>
                 </a:solidFill>
@@ -8429,7 +9538,7 @@
           <a:p>
             <a:pPr algn="ctr"/>
             <a:r>
-              <a:rPr sz="1600" b="1" i="0" u="sng">
+              <a:rPr sz="1400" b="1" i="0" u="sng">
                 <a:solidFill>
                   <a:srgbClr val="000000"/>
                 </a:solidFill>
@@ -8481,7 +9590,7 @@
           <a:p>
             <a:pPr algn="ctr"/>
             <a:r>
-              <a:rPr sz="1600" b="1" i="0" u="sng">
+              <a:rPr sz="1400" b="1" i="0" u="sng">
                 <a:solidFill>
                   <a:srgbClr val="000000"/>
                 </a:solidFill>
@@ -8533,7 +9642,7 @@
           <a:p>
             <a:pPr algn="ctr"/>
             <a:r>
-              <a:rPr sz="1600" b="1" i="0" u="sng">
+              <a:rPr sz="1400" b="1" i="0" u="sng">
                 <a:solidFill>
                   <a:srgbClr val="000000"/>
                 </a:solidFill>
@@ -8637,7 +9746,7 @@
           <a:p>
             <a:pPr algn="ctr"/>
             <a:r>
-              <a:rPr sz="1600" b="1" i="0" u="sng">
+              <a:rPr sz="1400" b="1" i="0" u="sng">
                 <a:solidFill>
                   <a:srgbClr val="000000"/>
                 </a:solidFill>
@@ -8646,7 +9755,7 @@
 </a:t>
             </a:r>
             <a:r>
-              <a:rPr sz="1400" b="0" i="1" u="none">
+              <a:rPr sz="1200" b="0" i="1" u="none">
                 <a:solidFill>
                   <a:srgbClr val="000000"/>
                 </a:solidFill>
@@ -8698,7 +9807,7 @@
           <a:p>
             <a:pPr algn="ctr"/>
             <a:r>
-              <a:rPr sz="1600" b="1" i="0" u="sng">
+              <a:rPr sz="1400" b="1" i="0" u="sng">
                 <a:solidFill>
                   <a:srgbClr val="000000"/>
                 </a:solidFill>
@@ -8707,7 +9816,7 @@
 </a:t>
             </a:r>
             <a:r>
-              <a:rPr sz="1400" b="0" i="1" u="none">
+              <a:rPr sz="1200" b="0" i="1" u="none">
                 <a:solidFill>
                   <a:srgbClr val="000000"/>
                 </a:solidFill>
@@ -8759,7 +9868,7 @@
           <a:p>
             <a:pPr algn="ctr"/>
             <a:r>
-              <a:rPr sz="1600" b="1" i="0" u="sng">
+              <a:rPr sz="1400" b="1" i="0" u="sng">
                 <a:solidFill>
                   <a:srgbClr val="000000"/>
                 </a:solidFill>
@@ -8768,7 +9877,7 @@
 </a:t>
             </a:r>
             <a:r>
-              <a:rPr sz="1400" b="0" i="1" u="none">
+              <a:rPr sz="1200" b="0" i="1" u="none">
                 <a:solidFill>
                   <a:srgbClr val="000000"/>
                 </a:solidFill>
@@ -8906,7 +10015,7 @@
           <a:p>
             <a:pPr algn="ctr"/>
             <a:r>
-              <a:rPr sz="1600" b="1" i="0" u="sng">
+              <a:rPr sz="1400" b="1" i="0" u="sng">
                 <a:solidFill>
                   <a:srgbClr val="000000"/>
                 </a:solidFill>
@@ -8915,7 +10024,7 @@
 </a:t>
             </a:r>
             <a:r>
-              <a:rPr sz="1400" b="0" i="1" u="none">
+              <a:rPr sz="1200" b="0" i="1" u="none">
                 <a:solidFill>
                   <a:srgbClr val="000000"/>
                 </a:solidFill>
@@ -8967,7 +10076,7 @@
           <a:p>
             <a:pPr algn="ctr"/>
             <a:r>
-              <a:rPr sz="1600" b="1" i="0" u="sng">
+              <a:rPr sz="1400" b="1" i="0" u="sng">
                 <a:solidFill>
                   <a:srgbClr val="000000"/>
                 </a:solidFill>
@@ -8976,7 +10085,7 @@
 </a:t>
             </a:r>
             <a:r>
-              <a:rPr sz="1400" b="0" i="1" u="none">
+              <a:rPr sz="1200" b="0" i="1" u="none">
                 <a:solidFill>
                   <a:srgbClr val="000000"/>
                 </a:solidFill>
@@ -9028,7 +10137,7 @@
           <a:p>
             <a:pPr algn="ctr"/>
             <a:r>
-              <a:rPr sz="1600" b="1" i="0" u="sng">
+              <a:rPr sz="1400" b="1" i="0" u="sng">
                 <a:solidFill>
                   <a:srgbClr val="000000"/>
                 </a:solidFill>
@@ -9037,7 +10146,7 @@
 </a:t>
             </a:r>
             <a:r>
-              <a:rPr sz="1400" b="0" i="1" u="none">
+              <a:rPr sz="1200" b="0" i="1" u="none">
                 <a:solidFill>
                   <a:srgbClr val="000000"/>
                 </a:solidFill>
@@ -9175,7 +10284,7 @@
           <a:p>
             <a:pPr algn="ctr"/>
             <a:r>
-              <a:rPr sz="1600" b="1" i="0" u="sng">
+              <a:rPr sz="1400" b="1" i="0" u="sng">
                 <a:solidFill>
                   <a:srgbClr val="000000"/>
                 </a:solidFill>
@@ -9184,7 +10293,7 @@
 </a:t>
             </a:r>
             <a:r>
-              <a:rPr sz="1400" b="0" i="1" u="none">
+              <a:rPr sz="1200" b="0" i="1" u="none">
                 <a:solidFill>
                   <a:srgbClr val="000000"/>
                 </a:solidFill>
@@ -9236,7 +10345,7 @@
           <a:p>
             <a:pPr algn="ctr"/>
             <a:r>
-              <a:rPr sz="1600" b="1" i="0" u="sng">
+              <a:rPr sz="1400" b="1" i="0" u="sng">
                 <a:solidFill>
                   <a:srgbClr val="000000"/>
                 </a:solidFill>
@@ -9245,7 +10354,7 @@
 </a:t>
             </a:r>
             <a:r>
-              <a:rPr sz="1400" b="0" i="1" u="none">
+              <a:rPr sz="1200" b="0" i="1" u="none">
                 <a:solidFill>
                   <a:srgbClr val="000000"/>
                 </a:solidFill>
@@ -9297,7 +10406,7 @@
           <a:p>
             <a:pPr algn="ctr"/>
             <a:r>
-              <a:rPr sz="1600" b="1" i="0" u="sng">
+              <a:rPr sz="1400" b="1" i="0" u="sng">
                 <a:solidFill>
                   <a:srgbClr val="000000"/>
                 </a:solidFill>
@@ -9306,7 +10415,7 @@
 </a:t>
             </a:r>
             <a:r>
-              <a:rPr sz="1400" b="0" i="1" u="none">
+              <a:rPr sz="1200" b="0" i="1" u="none">
                 <a:solidFill>
                   <a:srgbClr val="000000"/>
                 </a:solidFill>
@@ -9319,6 +10428,336 @@
       <p:sp>
         <p:nvSpPr>
           <p:cNvPr id="9" name="TextBox 8"/>
+          <p:cNvSpPr txBox="1"/>
+          <p:nvPr/>
+        </p:nvSpPr>
+        <p:spPr>
+          <a:xfrm>
+            <a:off x="457200" y="6263640"/>
+            <a:ext cx="11430000" cy="365760"/>
+          </a:xfrm>
+          <a:prstGeom prst="rect">
+            <a:avLst/>
+          </a:prstGeom>
+          <a:noFill/>
+        </p:spPr>
+        <p:txBody>
+          <a:bodyPr wrap="none" anchor="t">
+            <a:spAutoFit/>
+          </a:bodyPr>
+          <a:lstStyle/>
+          <a:p>
+            <a:pPr algn="l"/>
+            <a:r>
+              <a:rPr sz="1000" b="0" i="0" u="none">
+                <a:solidFill>
+                  <a:srgbClr val="000000"/>
+                </a:solidFill>
+              </a:rPr>
+              <a:t>Notes: Adjusted for recent acquisitions.</a:t>
+            </a:r>
+          </a:p>
+        </p:txBody>
+      </p:sp>
+    </p:spTree>
+  </p:cSld>
+  <p:clrMapOvr>
+    <a:masterClrMapping/>
+  </p:clrMapOvr>
+</p:sld>
+</file>
+
+<file path=ppt/slides/slide8.xml><?xml version="1.0" encoding="utf-8"?>
+<p:sld xmlns:a="http://schemas.openxmlformats.org/drawingml/2006/main" xmlns:p="http://schemas.openxmlformats.org/presentationml/2006/main" xmlns:r="http://schemas.openxmlformats.org/officeDocument/2006/relationships">
+  <p:cSld>
+    <p:spTree>
+      <p:nvGrpSpPr>
+        <p:cNvPr id="1" name=""/>
+        <p:cNvGrpSpPr/>
+        <p:nvPr/>
+      </p:nvGrpSpPr>
+      <p:grpSpPr/>
+      <p:sp>
+        <p:nvSpPr>
+          <p:cNvPr id="2" name="TextBox 1"/>
+          <p:cNvSpPr txBox="1"/>
+          <p:nvPr/>
+        </p:nvSpPr>
+        <p:spPr>
+          <a:xfrm>
+            <a:off x="457200" y="91440"/>
+            <a:ext cx="11430000" cy="731520"/>
+          </a:xfrm>
+          <a:prstGeom prst="rect">
+            <a:avLst/>
+          </a:prstGeom>
+          <a:noFill/>
+        </p:spPr>
+        <p:txBody>
+          <a:bodyPr wrap="none" anchor="t">
+            <a:spAutoFit/>
+          </a:bodyPr>
+          <a:lstStyle/>
+          <a:p>
+            <a:pPr algn="l"/>
+            <a:r>
+              <a:rPr sz="2000" b="1" i="0" u="none">
+                <a:solidFill>
+                  <a:srgbClr val="7F7F7F"/>
+                </a:solidFill>
+              </a:rPr>
+              <a:t>These should all be the same (except for legend names)</a:t>
+            </a:r>
+          </a:p>
+        </p:txBody>
+      </p:sp>
+      <p:graphicFrame>
+        <p:nvGraphicFramePr>
+          <p:cNvPr id="3" name="chart_1"/>
+          <p:cNvGraphicFramePr>
+            <a:graphicFrameLocks noGrp="1"/>
+          </p:cNvGraphicFramePr>
+          <p:nvPr/>
+        </p:nvGraphicFramePr>
+        <p:xfrm>
+          <a:off x="457200" y="1463040"/>
+          <a:ext cx="2862072" cy="4800600"/>
+        </p:xfrm>
+        <a:graphic>
+          <a:graphicData uri="http://schemas.openxmlformats.org/drawingml/2006/chart">
+            <c:chart xmlns:c="http://schemas.openxmlformats.org/drawingml/2006/chart" r:id="rId2"/>
+          </a:graphicData>
+        </a:graphic>
+      </p:graphicFrame>
+      <p:sp>
+        <p:nvSpPr>
+          <p:cNvPr id="4" name="TextBox 3"/>
+          <p:cNvSpPr txBox="1"/>
+          <p:nvPr/>
+        </p:nvSpPr>
+        <p:spPr>
+          <a:xfrm>
+            <a:off x="457200" y="1005840"/>
+            <a:ext cx="2862072" cy="457200"/>
+          </a:xfrm>
+          <a:prstGeom prst="rect">
+            <a:avLst/>
+          </a:prstGeom>
+          <a:noFill/>
+        </p:spPr>
+        <p:txBody>
+          <a:bodyPr wrap="none" anchor="t">
+            <a:spAutoFit/>
+          </a:bodyPr>
+          <a:lstStyle/>
+          <a:p>
+            <a:pPr algn="ctr"/>
+            <a:r>
+              <a:rPr sz="1200" b="1" i="0" u="sng">
+                <a:solidFill>
+                  <a:srgbClr val="000000"/>
+                </a:solidFill>
+              </a:rPr>
+              <a:t>Revenue Trend (Line) - Chart Title
+</a:t>
+            </a:r>
+            <a:r>
+              <a:rPr sz="1000" b="0" i="1" u="none">
+                <a:solidFill>
+                  <a:srgbClr val="000000"/>
+                </a:solidFill>
+              </a:rPr>
+              <a:t>2024 Actuals</a:t>
+            </a:r>
+          </a:p>
+        </p:txBody>
+      </p:sp>
+      <p:graphicFrame>
+        <p:nvGraphicFramePr>
+          <p:cNvPr id="5" name="chart_2"/>
+          <p:cNvGraphicFramePr>
+            <a:graphicFrameLocks noGrp="1"/>
+          </p:cNvGraphicFramePr>
+          <p:nvPr/>
+        </p:nvGraphicFramePr>
+        <p:xfrm>
+          <a:off x="3319272" y="1463040"/>
+          <a:ext cx="2862072" cy="4800600"/>
+        </p:xfrm>
+        <a:graphic>
+          <a:graphicData uri="http://schemas.openxmlformats.org/drawingml/2006/chart">
+            <c:chart xmlns:c="http://schemas.openxmlformats.org/drawingml/2006/chart" r:id="rId3"/>
+          </a:graphicData>
+        </a:graphic>
+      </p:graphicFrame>
+      <p:sp>
+        <p:nvSpPr>
+          <p:cNvPr id="6" name="TextBox 5"/>
+          <p:cNvSpPr txBox="1"/>
+          <p:nvPr/>
+        </p:nvSpPr>
+        <p:spPr>
+          <a:xfrm>
+            <a:off x="3319272" y="1005840"/>
+            <a:ext cx="2862072" cy="457200"/>
+          </a:xfrm>
+          <a:prstGeom prst="rect">
+            <a:avLst/>
+          </a:prstGeom>
+          <a:noFill/>
+        </p:spPr>
+        <p:txBody>
+          <a:bodyPr wrap="none" anchor="t">
+            <a:spAutoFit/>
+          </a:bodyPr>
+          <a:lstStyle/>
+          <a:p>
+            <a:pPr algn="ctr"/>
+            <a:r>
+              <a:rPr sz="1200" b="1" i="0" u="sng">
+                <a:solidFill>
+                  <a:srgbClr val="000000"/>
+                </a:solidFill>
+              </a:rPr>
+              <a:t>Revenue Trend (Line) - Chart Title
+</a:t>
+            </a:r>
+            <a:r>
+              <a:rPr sz="1000" b="0" i="1" u="none">
+                <a:solidFill>
+                  <a:srgbClr val="000000"/>
+                </a:solidFill>
+              </a:rPr>
+              <a:t>2024 Actuals</a:t>
+            </a:r>
+          </a:p>
+        </p:txBody>
+      </p:sp>
+      <p:graphicFrame>
+        <p:nvGraphicFramePr>
+          <p:cNvPr id="7" name="chart_3"/>
+          <p:cNvGraphicFramePr>
+            <a:graphicFrameLocks noGrp="1"/>
+          </p:cNvGraphicFramePr>
+          <p:nvPr/>
+        </p:nvGraphicFramePr>
+        <p:xfrm>
+          <a:off x="6181344" y="1463040"/>
+          <a:ext cx="2862072" cy="4800600"/>
+        </p:xfrm>
+        <a:graphic>
+          <a:graphicData uri="http://schemas.openxmlformats.org/drawingml/2006/chart">
+            <c:chart xmlns:c="http://schemas.openxmlformats.org/drawingml/2006/chart" r:id="rId4"/>
+          </a:graphicData>
+        </a:graphic>
+      </p:graphicFrame>
+      <p:sp>
+        <p:nvSpPr>
+          <p:cNvPr id="8" name="TextBox 7"/>
+          <p:cNvSpPr txBox="1"/>
+          <p:nvPr/>
+        </p:nvSpPr>
+        <p:spPr>
+          <a:xfrm>
+            <a:off x="6181344" y="1005840"/>
+            <a:ext cx="2862072" cy="457200"/>
+          </a:xfrm>
+          <a:prstGeom prst="rect">
+            <a:avLst/>
+          </a:prstGeom>
+          <a:noFill/>
+        </p:spPr>
+        <p:txBody>
+          <a:bodyPr wrap="none" anchor="t">
+            <a:spAutoFit/>
+          </a:bodyPr>
+          <a:lstStyle/>
+          <a:p>
+            <a:pPr algn="ctr"/>
+            <a:r>
+              <a:rPr sz="1200" b="1" i="0" u="sng">
+                <a:solidFill>
+                  <a:srgbClr val="000000"/>
+                </a:solidFill>
+              </a:rPr>
+              <a:t>Revenue Trend (Line) - Chart Title
+</a:t>
+            </a:r>
+            <a:r>
+              <a:rPr sz="1000" b="0" i="1" u="none">
+                <a:solidFill>
+                  <a:srgbClr val="000000"/>
+                </a:solidFill>
+              </a:rPr>
+              <a:t>2024 Actuals</a:t>
+            </a:r>
+          </a:p>
+        </p:txBody>
+      </p:sp>
+      <p:graphicFrame>
+        <p:nvGraphicFramePr>
+          <p:cNvPr id="9" name="chart_4"/>
+          <p:cNvGraphicFramePr>
+            <a:graphicFrameLocks noGrp="1"/>
+          </p:cNvGraphicFramePr>
+          <p:nvPr/>
+        </p:nvGraphicFramePr>
+        <p:xfrm>
+          <a:off x="9043416" y="1463040"/>
+          <a:ext cx="2862072" cy="4800600"/>
+        </p:xfrm>
+        <a:graphic>
+          <a:graphicData uri="http://schemas.openxmlformats.org/drawingml/2006/chart">
+            <c:chart xmlns:c="http://schemas.openxmlformats.org/drawingml/2006/chart" r:id="rId5"/>
+          </a:graphicData>
+        </a:graphic>
+      </p:graphicFrame>
+      <p:sp>
+        <p:nvSpPr>
+          <p:cNvPr id="10" name="TextBox 9"/>
+          <p:cNvSpPr txBox="1"/>
+          <p:nvPr/>
+        </p:nvSpPr>
+        <p:spPr>
+          <a:xfrm>
+            <a:off x="9043416" y="1005840"/>
+            <a:ext cx="2862072" cy="457200"/>
+          </a:xfrm>
+          <a:prstGeom prst="rect">
+            <a:avLst/>
+          </a:prstGeom>
+          <a:noFill/>
+        </p:spPr>
+        <p:txBody>
+          <a:bodyPr wrap="none" anchor="t">
+            <a:spAutoFit/>
+          </a:bodyPr>
+          <a:lstStyle/>
+          <a:p>
+            <a:pPr algn="ctr"/>
+            <a:r>
+              <a:rPr sz="1200" b="1" i="0" u="sng">
+                <a:solidFill>
+                  <a:srgbClr val="000000"/>
+                </a:solidFill>
+              </a:rPr>
+              <a:t>Revenue Trend (Line) - Chart Title
+</a:t>
+            </a:r>
+            <a:r>
+              <a:rPr sz="1000" b="0" i="1" u="none">
+                <a:solidFill>
+                  <a:srgbClr val="000000"/>
+                </a:solidFill>
+              </a:rPr>
+              <a:t>2024 Actuals</a:t>
+            </a:r>
+          </a:p>
+        </p:txBody>
+      </p:sp>
+      <p:sp>
+        <p:nvSpPr>
+          <p:cNvPr id="11" name="TextBox 10"/>
           <p:cNvSpPr txBox="1"/>
           <p:nvPr/>
         </p:nvSpPr>

</xml_diff>

<commit_message>
demo all chart types
</commit_message>
<xml_diff>
--- a/notebooks/demo.pptx
+++ b/notebooks/demo.pptx
@@ -16,6 +16,8 @@
     <p:sldId id="261" r:id="rId23"/>
     <p:sldId id="262" r:id="rId24"/>
     <p:sldId id="263" r:id="rId25"/>
+    <p:sldId id="264" r:id="rId26"/>
+    <p:sldId id="265" r:id="rId27"/>
   </p:sldIdLst>
   <p:sldSz cx="12188825" cy="6858000"/>
   <p:notesSz cx="6858000" cy="9144000"/>
@@ -3577,6 +3579,1202 @@
         </c:txPr>
         <c:crossAx val="2118791784"/>
         <c:crosses val="autoZero"/>
+      </c:valAx>
+    </c:plotArea>
+    <c:legend>
+      <c:legendPos val="b"/>
+      <c:layout/>
+      <c:overlay val="0"/>
+      <c:txPr>
+        <a:bodyPr/>
+        <a:lstStyle/>
+        <a:p>
+          <a:pPr>
+            <a:defRPr sz="1400"/>
+          </a:pPr>
+        </a:p>
+      </c:txPr>
+    </c:legend>
+    <c:plotVisOnly val="1"/>
+    <c:dispBlanksAs val="gap"/>
+    <c:showDLblsOverMax val="0"/>
+  </c:chart>
+  <c:txPr>
+    <a:bodyPr/>
+    <a:lstStyle/>
+    <a:p>
+      <a:pPr>
+        <a:defRPr sz="1800"/>
+      </a:pPr>
+      <a:endParaRPr lang="en-US"/>
+    </a:p>
+  </c:txPr>
+  <c:externalData r:id="rId1">
+    <c:autoUpdate val="0"/>
+  </c:externalData>
+</c:chartSpace>
+</file>
+
+<file path=ppt/charts/chart20.xml><?xml version="1.0" encoding="utf-8"?>
+<c:chartSpace xmlns:c="http://schemas.openxmlformats.org/drawingml/2006/chart" xmlns:a="http://schemas.openxmlformats.org/drawingml/2006/main" xmlns:r="http://schemas.openxmlformats.org/officeDocument/2006/relationships">
+  <c:date1904 val="0"/>
+  <c:roundedCorners val="0"/>
+  <c:chart>
+    <c:autoTitleDeleted val="1"/>
+    <c:plotArea>
+      <c:layout/>
+      <c:areaChart>
+        <c:grouping val="stacked"/>
+        <c:varyColors val="0"/>
+        <c:ser>
+          <c:idx val="0"/>
+          <c:order val="0"/>
+          <c:tx>
+            <c:strRef>
+              <c:f>Sheet1!$B$1</c:f>
+              <c:strCache>
+                <c:ptCount val="1"/>
+                <c:pt idx="0">
+                  <c:v>Revenue!</c:v>
+                </c:pt>
+              </c:strCache>
+            </c:strRef>
+          </c:tx>
+          <c:spPr>
+            <a:solidFill>
+              <a:srgbClr val="C00000"/>
+            </a:solidFill>
+            <a:ln>
+              <a:solidFill>
+                <a:srgbClr val="C00000"/>
+              </a:solidFill>
+            </a:ln>
+          </c:spPr>
+          <c:cat>
+            <c:strRef>
+              <c:f>Sheet1!$A$2:$A$5</c:f>
+              <c:strCache>
+                <c:ptCount val="4"/>
+                <c:pt idx="0">
+                  <c:v>Jan</c:v>
+                </c:pt>
+                <c:pt idx="1">
+                  <c:v>Feb</c:v>
+                </c:pt>
+                <c:pt idx="2">
+                  <c:v>Mar</c:v>
+                </c:pt>
+                <c:pt idx="3">
+                  <c:v>Apr</c:v>
+                </c:pt>
+              </c:strCache>
+            </c:strRef>
+          </c:cat>
+          <c:val>
+            <c:numRef>
+              <c:f>Sheet1!$B$2:$B$5</c:f>
+              <c:numCache>
+                <c:formatCode>General</c:formatCode>
+                <c:ptCount val="4"/>
+                <c:pt idx="0">
+                  <c:v>10</c:v>
+                </c:pt>
+                <c:pt idx="1">
+                  <c:v>14</c:v>
+                </c:pt>
+                <c:pt idx="2">
+                  <c:v>9</c:v>
+                </c:pt>
+                <c:pt idx="3">
+                  <c:v>18</c:v>
+                </c:pt>
+              </c:numCache>
+            </c:numRef>
+          </c:val>
+        </c:ser>
+        <c:ser>
+          <c:idx val="1"/>
+          <c:order val="1"/>
+          <c:tx>
+            <c:strRef>
+              <c:f>Sheet1!$C$1</c:f>
+              <c:strCache>
+                <c:ptCount val="1"/>
+                <c:pt idx="0">
+                  <c:v>Cost!</c:v>
+                </c:pt>
+              </c:strCache>
+            </c:strRef>
+          </c:tx>
+          <c:spPr>
+            <a:solidFill>
+              <a:srgbClr val="7030A0"/>
+            </a:solidFill>
+            <a:ln>
+              <a:solidFill>
+                <a:srgbClr val="7030A0"/>
+              </a:solidFill>
+            </a:ln>
+          </c:spPr>
+          <c:cat>
+            <c:strRef>
+              <c:f>Sheet1!$A$2:$A$5</c:f>
+              <c:strCache>
+                <c:ptCount val="4"/>
+                <c:pt idx="0">
+                  <c:v>Jan</c:v>
+                </c:pt>
+                <c:pt idx="1">
+                  <c:v>Feb</c:v>
+                </c:pt>
+                <c:pt idx="2">
+                  <c:v>Mar</c:v>
+                </c:pt>
+                <c:pt idx="3">
+                  <c:v>Apr</c:v>
+                </c:pt>
+              </c:strCache>
+            </c:strRef>
+          </c:cat>
+          <c:val>
+            <c:numRef>
+              <c:f>Sheet1!$C$2:$C$5</c:f>
+              <c:numCache>
+                <c:formatCode>General</c:formatCode>
+                <c:ptCount val="4"/>
+                <c:pt idx="0">
+                  <c:v>2</c:v>
+                </c:pt>
+                <c:pt idx="1">
+                  <c:v>4</c:v>
+                </c:pt>
+                <c:pt idx="2">
+                  <c:v>3</c:v>
+                </c:pt>
+                <c:pt idx="3">
+                  <c:v>1</c:v>
+                </c:pt>
+              </c:numCache>
+            </c:numRef>
+          </c:val>
+        </c:ser>
+        <c:dLbls>
+          <c:showLegendKey val="0"/>
+          <c:showVal val="0"/>
+          <c:showCatName val="0"/>
+          <c:showSerName val="0"/>
+          <c:showPercent val="0"/>
+          <c:showBubbleSize val="0"/>
+        </c:dLbls>
+        <c:axId val="-2101159928"/>
+        <c:axId val="-2100718248"/>
+      </c:areaChart>
+      <c:catAx>
+        <c:axId val="-2101159928"/>
+        <c:scaling>
+          <c:orientation val="minMax"/>
+        </c:scaling>
+        <c:delete val="0"/>
+        <c:axPos val="b"/>
+        <c:numFmt formatCode="General" sourceLinked="1"/>
+        <c:majorTickMark val="out"/>
+        <c:minorTickMark val="none"/>
+        <c:tickLblPos val="low"/>
+        <c:txPr>
+          <a:bodyPr/>
+          <a:lstStyle/>
+          <a:p>
+            <a:pPr>
+              <a:defRPr sz="1400"/>
+            </a:pPr>
+          </a:p>
+        </c:txPr>
+        <c:crossAx val="-2100718248"/>
+        <c:crosses val="autoZero"/>
+        <c:auto val="1"/>
+        <c:lblAlgn val="ctr"/>
+        <c:lblOffset val="100"/>
+        <c:noMultiLvlLbl val="0"/>
+      </c:catAx>
+      <c:valAx>
+        <c:axId val="-2100718248"/>
+        <c:scaling>
+          <c:orientation val="minMax"/>
+          <c:max val="100.0"/>
+          <c:min val="0.0"/>
+        </c:scaling>
+        <c:delete val="0"/>
+        <c:axPos val="l"/>
+        <c:numFmt formatCode="$0.0" sourceLinked="0"/>
+        <c:majorTickMark val="out"/>
+        <c:minorTickMark val="none"/>
+        <c:tickLblPos val="nextTo"/>
+        <c:txPr>
+          <a:bodyPr/>
+          <a:lstStyle/>
+          <a:p>
+            <a:pPr>
+              <a:defRPr sz="1400"/>
+            </a:pPr>
+          </a:p>
+        </c:txPr>
+        <c:crossAx val="-2101159928"/>
+        <c:crosses val="autoZero"/>
+        <c:crossBetween val="midCat"/>
+      </c:valAx>
+    </c:plotArea>
+    <c:legend>
+      <c:legendPos val="b"/>
+      <c:layout/>
+      <c:overlay val="0"/>
+      <c:txPr>
+        <a:bodyPr/>
+        <a:lstStyle/>
+        <a:p>
+          <a:pPr>
+            <a:defRPr sz="1400"/>
+          </a:pPr>
+        </a:p>
+      </c:txPr>
+    </c:legend>
+    <c:plotVisOnly val="1"/>
+    <c:dispBlanksAs val="zero"/>
+    <c:showDLblsOverMax val="0"/>
+  </c:chart>
+  <c:txPr>
+    <a:bodyPr/>
+    <a:lstStyle/>
+    <a:p>
+      <a:pPr>
+        <a:defRPr sz="1800"/>
+      </a:pPr>
+      <a:endParaRPr/>
+    </a:p>
+  </c:txPr>
+  <c:externalData r:id="rId1">
+    <c:autoUpdate val="0"/>
+  </c:externalData>
+</c:chartSpace>
+</file>
+
+<file path=ppt/charts/chart21.xml><?xml version="1.0" encoding="utf-8"?>
+<c:chartSpace xmlns:c="http://schemas.openxmlformats.org/drawingml/2006/chart" xmlns:a="http://schemas.openxmlformats.org/drawingml/2006/main" xmlns:r="http://schemas.openxmlformats.org/officeDocument/2006/relationships">
+  <c:date1904 val="0"/>
+  <c:roundedCorners val="0"/>
+  <c:chart>
+    <c:autoTitleDeleted val="1"/>
+    <c:plotArea>
+      <c:layout/>
+      <c:areaChart>
+        <c:grouping val="percentStacked"/>
+        <c:varyColors val="0"/>
+        <c:ser>
+          <c:idx val="0"/>
+          <c:order val="0"/>
+          <c:tx>
+            <c:strRef>
+              <c:f>Sheet1!$B$1</c:f>
+              <c:strCache>
+                <c:ptCount val="1"/>
+                <c:pt idx="0">
+                  <c:v>Revenue!</c:v>
+                </c:pt>
+              </c:strCache>
+            </c:strRef>
+          </c:tx>
+          <c:spPr>
+            <a:solidFill>
+              <a:srgbClr val="C00000"/>
+            </a:solidFill>
+            <a:ln>
+              <a:solidFill>
+                <a:srgbClr val="C00000"/>
+              </a:solidFill>
+            </a:ln>
+          </c:spPr>
+          <c:cat>
+            <c:strRef>
+              <c:f>Sheet1!$A$2:$A$5</c:f>
+              <c:strCache>
+                <c:ptCount val="4"/>
+                <c:pt idx="0">
+                  <c:v>Jan</c:v>
+                </c:pt>
+                <c:pt idx="1">
+                  <c:v>Feb</c:v>
+                </c:pt>
+                <c:pt idx="2">
+                  <c:v>Mar</c:v>
+                </c:pt>
+                <c:pt idx="3">
+                  <c:v>Apr</c:v>
+                </c:pt>
+              </c:strCache>
+            </c:strRef>
+          </c:cat>
+          <c:val>
+            <c:numRef>
+              <c:f>Sheet1!$B$2:$B$5</c:f>
+              <c:numCache>
+                <c:formatCode>General</c:formatCode>
+                <c:ptCount val="4"/>
+                <c:pt idx="0">
+                  <c:v>10</c:v>
+                </c:pt>
+                <c:pt idx="1">
+                  <c:v>14</c:v>
+                </c:pt>
+                <c:pt idx="2">
+                  <c:v>9</c:v>
+                </c:pt>
+                <c:pt idx="3">
+                  <c:v>18</c:v>
+                </c:pt>
+              </c:numCache>
+            </c:numRef>
+          </c:val>
+        </c:ser>
+        <c:ser>
+          <c:idx val="1"/>
+          <c:order val="1"/>
+          <c:tx>
+            <c:strRef>
+              <c:f>Sheet1!$C$1</c:f>
+              <c:strCache>
+                <c:ptCount val="1"/>
+                <c:pt idx="0">
+                  <c:v>Cost!</c:v>
+                </c:pt>
+              </c:strCache>
+            </c:strRef>
+          </c:tx>
+          <c:spPr>
+            <a:solidFill>
+              <a:srgbClr val="7030A0"/>
+            </a:solidFill>
+            <a:ln>
+              <a:solidFill>
+                <a:srgbClr val="7030A0"/>
+              </a:solidFill>
+            </a:ln>
+          </c:spPr>
+          <c:cat>
+            <c:strRef>
+              <c:f>Sheet1!$A$2:$A$5</c:f>
+              <c:strCache>
+                <c:ptCount val="4"/>
+                <c:pt idx="0">
+                  <c:v>Jan</c:v>
+                </c:pt>
+                <c:pt idx="1">
+                  <c:v>Feb</c:v>
+                </c:pt>
+                <c:pt idx="2">
+                  <c:v>Mar</c:v>
+                </c:pt>
+                <c:pt idx="3">
+                  <c:v>Apr</c:v>
+                </c:pt>
+              </c:strCache>
+            </c:strRef>
+          </c:cat>
+          <c:val>
+            <c:numRef>
+              <c:f>Sheet1!$C$2:$C$5</c:f>
+              <c:numCache>
+                <c:formatCode>General</c:formatCode>
+                <c:ptCount val="4"/>
+                <c:pt idx="0">
+                  <c:v>2</c:v>
+                </c:pt>
+                <c:pt idx="1">
+                  <c:v>4</c:v>
+                </c:pt>
+                <c:pt idx="2">
+                  <c:v>3</c:v>
+                </c:pt>
+                <c:pt idx="3">
+                  <c:v>1</c:v>
+                </c:pt>
+              </c:numCache>
+            </c:numRef>
+          </c:val>
+        </c:ser>
+        <c:dLbls>
+          <c:showLegendKey val="0"/>
+          <c:showVal val="0"/>
+          <c:showCatName val="0"/>
+          <c:showSerName val="0"/>
+          <c:showPercent val="0"/>
+          <c:showBubbleSize val="0"/>
+        </c:dLbls>
+        <c:axId val="-2101159928"/>
+        <c:axId val="-2100718248"/>
+      </c:areaChart>
+      <c:catAx>
+        <c:axId val="-2101159928"/>
+        <c:scaling>
+          <c:orientation val="minMax"/>
+        </c:scaling>
+        <c:delete val="0"/>
+        <c:axPos val="b"/>
+        <c:numFmt formatCode="General" sourceLinked="1"/>
+        <c:majorTickMark val="out"/>
+        <c:minorTickMark val="none"/>
+        <c:tickLblPos val="low"/>
+        <c:txPr>
+          <a:bodyPr/>
+          <a:lstStyle/>
+          <a:p>
+            <a:pPr>
+              <a:defRPr sz="1400"/>
+            </a:pPr>
+          </a:p>
+        </c:txPr>
+        <c:crossAx val="-2100718248"/>
+        <c:crosses val="autoZero"/>
+        <c:auto val="1"/>
+        <c:lblAlgn val="ctr"/>
+        <c:lblOffset val="100"/>
+        <c:noMultiLvlLbl val="0"/>
+      </c:catAx>
+      <c:valAx>
+        <c:axId val="-2100718248"/>
+        <c:scaling>
+          <c:orientation val="minMax"/>
+          <c:max val="1.0"/>
+          <c:min val="0.0"/>
+        </c:scaling>
+        <c:delete val="0"/>
+        <c:axPos val="l"/>
+        <c:numFmt formatCode="0%" sourceLinked="0"/>
+        <c:majorTickMark val="out"/>
+        <c:minorTickMark val="none"/>
+        <c:tickLblPos val="nextTo"/>
+        <c:txPr>
+          <a:bodyPr/>
+          <a:lstStyle/>
+          <a:p>
+            <a:pPr>
+              <a:defRPr sz="1400"/>
+            </a:pPr>
+          </a:p>
+        </c:txPr>
+        <c:crossAx val="-2101159928"/>
+        <c:crosses val="autoZero"/>
+        <c:crossBetween val="midCat"/>
+      </c:valAx>
+    </c:plotArea>
+    <c:legend>
+      <c:legendPos val="b"/>
+      <c:layout/>
+      <c:overlay val="0"/>
+      <c:txPr>
+        <a:bodyPr/>
+        <a:lstStyle/>
+        <a:p>
+          <a:pPr>
+            <a:defRPr sz="1400"/>
+          </a:pPr>
+        </a:p>
+      </c:txPr>
+    </c:legend>
+    <c:plotVisOnly val="1"/>
+    <c:dispBlanksAs val="zero"/>
+    <c:showDLblsOverMax val="0"/>
+  </c:chart>
+  <c:txPr>
+    <a:bodyPr/>
+    <a:lstStyle/>
+    <a:p>
+      <a:pPr>
+        <a:defRPr sz="1800"/>
+      </a:pPr>
+      <a:endParaRPr/>
+    </a:p>
+  </c:txPr>
+  <c:externalData r:id="rId1">
+    <c:autoUpdate val="0"/>
+  </c:externalData>
+</c:chartSpace>
+</file>
+
+<file path=ppt/charts/chart22.xml><?xml version="1.0" encoding="utf-8"?>
+<c:chartSpace xmlns:c="http://schemas.openxmlformats.org/drawingml/2006/chart" xmlns:a="http://schemas.openxmlformats.org/drawingml/2006/main" xmlns:r="http://schemas.openxmlformats.org/officeDocument/2006/relationships">
+  <c:date1904 val="0"/>
+  <c:chart>
+    <c:autoTitleDeleted val="1"/>
+    <c:plotArea>
+      <c:barChart>
+        <c:barDir val="bar"/>
+        <c:grouping val="stacked"/>
+        <c:ser>
+          <c:idx val="0"/>
+          <c:order val="0"/>
+          <c:tx>
+            <c:strRef>
+              <c:f>Sheet1!$B$1</c:f>
+              <c:strCache>
+                <c:ptCount val="1"/>
+                <c:pt idx="0">
+                  <c:v>Revenue!</c:v>
+                </c:pt>
+              </c:strCache>
+            </c:strRef>
+          </c:tx>
+          <c:spPr>
+            <a:solidFill>
+              <a:srgbClr val="C00000"/>
+            </a:solidFill>
+            <a:ln>
+              <a:solidFill>
+                <a:srgbClr val="C00000"/>
+              </a:solidFill>
+            </a:ln>
+          </c:spPr>
+          <c:invertIfNegative val="0"/>
+          <c:cat>
+            <c:strRef>
+              <c:f>Sheet1!$A$2:$A$5</c:f>
+              <c:strCache>
+                <c:ptCount val="4"/>
+                <c:pt idx="0">
+                  <c:v>Jan</c:v>
+                </c:pt>
+                <c:pt idx="1">
+                  <c:v>Feb</c:v>
+                </c:pt>
+                <c:pt idx="2">
+                  <c:v>Mar</c:v>
+                </c:pt>
+                <c:pt idx="3">
+                  <c:v>Apr</c:v>
+                </c:pt>
+              </c:strCache>
+            </c:strRef>
+          </c:cat>
+          <c:val>
+            <c:numRef>
+              <c:f>Sheet1!$B$2:$B$5</c:f>
+              <c:numCache>
+                <c:formatCode>General</c:formatCode>
+                <c:ptCount val="4"/>
+                <c:pt idx="0">
+                  <c:v>10</c:v>
+                </c:pt>
+                <c:pt idx="1">
+                  <c:v>14</c:v>
+                </c:pt>
+                <c:pt idx="2">
+                  <c:v>9</c:v>
+                </c:pt>
+                <c:pt idx="3">
+                  <c:v>18</c:v>
+                </c:pt>
+              </c:numCache>
+            </c:numRef>
+          </c:val>
+        </c:ser>
+        <c:ser>
+          <c:idx val="1"/>
+          <c:order val="1"/>
+          <c:tx>
+            <c:strRef>
+              <c:f>Sheet1!$C$1</c:f>
+              <c:strCache>
+                <c:ptCount val="1"/>
+                <c:pt idx="0">
+                  <c:v>Cost!</c:v>
+                </c:pt>
+              </c:strCache>
+            </c:strRef>
+          </c:tx>
+          <c:spPr>
+            <a:solidFill>
+              <a:srgbClr val="7030A0"/>
+            </a:solidFill>
+            <a:ln>
+              <a:solidFill>
+                <a:srgbClr val="7030A0"/>
+              </a:solidFill>
+            </a:ln>
+          </c:spPr>
+          <c:invertIfNegative val="0"/>
+          <c:cat>
+            <c:strRef>
+              <c:f>Sheet1!$A$2:$A$5</c:f>
+              <c:strCache>
+                <c:ptCount val="4"/>
+                <c:pt idx="0">
+                  <c:v>Jan</c:v>
+                </c:pt>
+                <c:pt idx="1">
+                  <c:v>Feb</c:v>
+                </c:pt>
+                <c:pt idx="2">
+                  <c:v>Mar</c:v>
+                </c:pt>
+                <c:pt idx="3">
+                  <c:v>Apr</c:v>
+                </c:pt>
+              </c:strCache>
+            </c:strRef>
+          </c:cat>
+          <c:val>
+            <c:numRef>
+              <c:f>Sheet1!$C$2:$C$5</c:f>
+              <c:numCache>
+                <c:formatCode>General</c:formatCode>
+                <c:ptCount val="4"/>
+                <c:pt idx="0">
+                  <c:v>2</c:v>
+                </c:pt>
+                <c:pt idx="1">
+                  <c:v>4</c:v>
+                </c:pt>
+                <c:pt idx="2">
+                  <c:v>3</c:v>
+                </c:pt>
+                <c:pt idx="3">
+                  <c:v>1</c:v>
+                </c:pt>
+              </c:numCache>
+            </c:numRef>
+          </c:val>
+        </c:ser>
+        <c:overlap val="100"/>
+        <c:axId val="-2068027336"/>
+        <c:axId val="-2113994440"/>
+      </c:barChart>
+      <c:catAx>
+        <c:axId val="-2068027336"/>
+        <c:scaling>
+          <c:orientation val="minMax"/>
+        </c:scaling>
+        <c:delete val="0"/>
+        <c:axPos val="l"/>
+        <c:majorTickMark val="out"/>
+        <c:minorTickMark val="none"/>
+        <c:tickLblPos val="low"/>
+        <c:txPr>
+          <a:bodyPr/>
+          <a:lstStyle/>
+          <a:p>
+            <a:pPr>
+              <a:defRPr sz="1400"/>
+            </a:pPr>
+          </a:p>
+        </c:txPr>
+        <c:crossAx val="-2113994440"/>
+        <c:crosses val="autoZero"/>
+        <c:auto val="1"/>
+        <c:lblAlgn val="ctr"/>
+        <c:lblOffset val="100"/>
+        <c:noMultiLvlLbl val="0"/>
+      </c:catAx>
+      <c:valAx>
+        <c:axId val="-2113994440"/>
+        <c:scaling>
+          <c:max val="100.0"/>
+          <c:min val="0.0"/>
+        </c:scaling>
+        <c:delete val="0"/>
+        <c:axPos val="b"/>
+        <c:numFmt formatCode="$0.0" sourceLinked="0"/>
+        <c:majorTickMark val="out"/>
+        <c:minorTickMark val="none"/>
+        <c:tickLblPos val="nextTo"/>
+        <c:txPr>
+          <a:bodyPr/>
+          <a:lstStyle/>
+          <a:p>
+            <a:pPr>
+              <a:defRPr sz="1400"/>
+            </a:pPr>
+          </a:p>
+        </c:txPr>
+        <c:crossAx val="-2068027336"/>
+        <c:crosses val="autoZero"/>
+      </c:valAx>
+    </c:plotArea>
+    <c:legend>
+      <c:legendPos val="b"/>
+      <c:overlay val="0"/>
+      <c:txPr>
+        <a:bodyPr/>
+        <a:lstStyle/>
+        <a:p>
+          <a:pPr>
+            <a:defRPr sz="1400"/>
+          </a:pPr>
+        </a:p>
+      </c:txPr>
+    </c:legend>
+    <c:dispBlanksAs val="gap"/>
+  </c:chart>
+  <c:txPr>
+    <a:bodyPr/>
+    <a:lstStyle/>
+    <a:p>
+      <a:pPr>
+        <a:defRPr sz="1800"/>
+      </a:pPr>
+      <a:endParaRPr lang="en-US"/>
+    </a:p>
+  </c:txPr>
+  <c:externalData r:id="rId1">
+    <c:autoUpdate val="0"/>
+  </c:externalData>
+</c:chartSpace>
+</file>
+
+<file path=ppt/charts/chart23.xml><?xml version="1.0" encoding="utf-8"?>
+<c:chartSpace xmlns:c="http://schemas.openxmlformats.org/drawingml/2006/chart" xmlns:a="http://schemas.openxmlformats.org/drawingml/2006/main" xmlns:r="http://schemas.openxmlformats.org/officeDocument/2006/relationships">
+  <c:date1904 val="0"/>
+  <c:chart>
+    <c:autoTitleDeleted val="1"/>
+    <c:plotArea>
+      <c:barChart>
+        <c:barDir val="col"/>
+        <c:grouping val="stacked"/>
+        <c:ser>
+          <c:idx val="0"/>
+          <c:order val="0"/>
+          <c:tx>
+            <c:strRef>
+              <c:f>Sheet1!$B$1</c:f>
+              <c:strCache>
+                <c:ptCount val="1"/>
+                <c:pt idx="0">
+                  <c:v>Revenue!</c:v>
+                </c:pt>
+              </c:strCache>
+            </c:strRef>
+          </c:tx>
+          <c:spPr>
+            <a:solidFill>
+              <a:srgbClr val="C00000"/>
+            </a:solidFill>
+            <a:ln>
+              <a:solidFill>
+                <a:srgbClr val="C00000"/>
+              </a:solidFill>
+            </a:ln>
+          </c:spPr>
+          <c:invertIfNegative val="0"/>
+          <c:cat>
+            <c:strRef>
+              <c:f>Sheet1!$A$2:$A$5</c:f>
+              <c:strCache>
+                <c:ptCount val="4"/>
+                <c:pt idx="0">
+                  <c:v>Jan</c:v>
+                </c:pt>
+                <c:pt idx="1">
+                  <c:v>Feb</c:v>
+                </c:pt>
+                <c:pt idx="2">
+                  <c:v>Mar</c:v>
+                </c:pt>
+                <c:pt idx="3">
+                  <c:v>Apr</c:v>
+                </c:pt>
+              </c:strCache>
+            </c:strRef>
+          </c:cat>
+          <c:val>
+            <c:numRef>
+              <c:f>Sheet1!$B$2:$B$5</c:f>
+              <c:numCache>
+                <c:formatCode>General</c:formatCode>
+                <c:ptCount val="4"/>
+                <c:pt idx="0">
+                  <c:v>10</c:v>
+                </c:pt>
+                <c:pt idx="1">
+                  <c:v>14</c:v>
+                </c:pt>
+                <c:pt idx="2">
+                  <c:v>9</c:v>
+                </c:pt>
+                <c:pt idx="3">
+                  <c:v>18</c:v>
+                </c:pt>
+              </c:numCache>
+            </c:numRef>
+          </c:val>
+        </c:ser>
+        <c:ser>
+          <c:idx val="1"/>
+          <c:order val="1"/>
+          <c:tx>
+            <c:strRef>
+              <c:f>Sheet1!$C$1</c:f>
+              <c:strCache>
+                <c:ptCount val="1"/>
+                <c:pt idx="0">
+                  <c:v>Cost!</c:v>
+                </c:pt>
+              </c:strCache>
+            </c:strRef>
+          </c:tx>
+          <c:spPr>
+            <a:solidFill>
+              <a:srgbClr val="7030A0"/>
+            </a:solidFill>
+            <a:ln>
+              <a:solidFill>
+                <a:srgbClr val="7030A0"/>
+              </a:solidFill>
+            </a:ln>
+          </c:spPr>
+          <c:invertIfNegative val="0"/>
+          <c:cat>
+            <c:strRef>
+              <c:f>Sheet1!$A$2:$A$5</c:f>
+              <c:strCache>
+                <c:ptCount val="4"/>
+                <c:pt idx="0">
+                  <c:v>Jan</c:v>
+                </c:pt>
+                <c:pt idx="1">
+                  <c:v>Feb</c:v>
+                </c:pt>
+                <c:pt idx="2">
+                  <c:v>Mar</c:v>
+                </c:pt>
+                <c:pt idx="3">
+                  <c:v>Apr</c:v>
+                </c:pt>
+              </c:strCache>
+            </c:strRef>
+          </c:cat>
+          <c:val>
+            <c:numRef>
+              <c:f>Sheet1!$C$2:$C$5</c:f>
+              <c:numCache>
+                <c:formatCode>General</c:formatCode>
+                <c:ptCount val="4"/>
+                <c:pt idx="0">
+                  <c:v>2</c:v>
+                </c:pt>
+                <c:pt idx="1">
+                  <c:v>4</c:v>
+                </c:pt>
+                <c:pt idx="2">
+                  <c:v>3</c:v>
+                </c:pt>
+                <c:pt idx="3">
+                  <c:v>1</c:v>
+                </c:pt>
+              </c:numCache>
+            </c:numRef>
+          </c:val>
+        </c:ser>
+        <c:overlap val="100"/>
+        <c:axId val="-2068027336"/>
+        <c:axId val="-2113994440"/>
+      </c:barChart>
+      <c:catAx>
+        <c:axId val="-2068027336"/>
+        <c:scaling>
+          <c:orientation val="minMax"/>
+        </c:scaling>
+        <c:delete val="0"/>
+        <c:axPos val="b"/>
+        <c:majorTickMark val="out"/>
+        <c:minorTickMark val="none"/>
+        <c:tickLblPos val="low"/>
+        <c:txPr>
+          <a:bodyPr/>
+          <a:lstStyle/>
+          <a:p>
+            <a:pPr>
+              <a:defRPr sz="1400"/>
+            </a:pPr>
+          </a:p>
+        </c:txPr>
+        <c:crossAx val="-2113994440"/>
+        <c:crosses val="autoZero"/>
+        <c:auto val="1"/>
+        <c:lblAlgn val="ctr"/>
+        <c:lblOffset val="100"/>
+        <c:noMultiLvlLbl val="0"/>
+      </c:catAx>
+      <c:valAx>
+        <c:axId val="-2113994440"/>
+        <c:scaling>
+          <c:max val="100.0"/>
+          <c:min val="0.0"/>
+        </c:scaling>
+        <c:delete val="0"/>
+        <c:axPos val="l"/>
+        <c:numFmt formatCode="$0.0" sourceLinked="0"/>
+        <c:majorTickMark val="out"/>
+        <c:minorTickMark val="none"/>
+        <c:tickLblPos val="nextTo"/>
+        <c:txPr>
+          <a:bodyPr/>
+          <a:lstStyle/>
+          <a:p>
+            <a:pPr>
+              <a:defRPr sz="1400"/>
+            </a:pPr>
+          </a:p>
+        </c:txPr>
+        <c:crossAx val="-2068027336"/>
+        <c:crosses val="autoZero"/>
+      </c:valAx>
+    </c:plotArea>
+    <c:legend>
+      <c:legendPos val="b"/>
+      <c:overlay val="0"/>
+      <c:txPr>
+        <a:bodyPr/>
+        <a:lstStyle/>
+        <a:p>
+          <a:pPr>
+            <a:defRPr sz="1400"/>
+          </a:pPr>
+        </a:p>
+      </c:txPr>
+    </c:legend>
+    <c:dispBlanksAs val="gap"/>
+  </c:chart>
+  <c:txPr>
+    <a:bodyPr/>
+    <a:lstStyle/>
+    <a:p>
+      <a:pPr>
+        <a:defRPr sz="1800"/>
+      </a:pPr>
+      <a:endParaRPr lang="en-US"/>
+    </a:p>
+  </c:txPr>
+  <c:externalData r:id="rId1">
+    <c:autoUpdate val="0"/>
+  </c:externalData>
+</c:chartSpace>
+</file>
+
+<file path=ppt/charts/chart24.xml><?xml version="1.0" encoding="utf-8"?>
+<c:chartSpace xmlns:c="http://schemas.openxmlformats.org/drawingml/2006/chart" xmlns:a="http://schemas.openxmlformats.org/drawingml/2006/main" xmlns:r="http://schemas.openxmlformats.org/officeDocument/2006/relationships">
+  <c:chart>
+    <c:autoTitleDeleted val="1"/>
+    <c:plotArea>
+      <c:scatterChart>
+        <c:scatterStyle val="smoothMarker"/>
+        <c:varyColors val="0"/>
+        <c:ser>
+          <c:idx val="0"/>
+          <c:order val="0"/>
+          <c:tx>
+            <c:strRef>
+              <c:f>Sheet1!$B$1</c:f>
+              <c:strCache>
+                <c:ptCount val="1"/>
+                <c:pt idx="0">
+                  <c:v>Revenue!</c:v>
+                </c:pt>
+              </c:strCache>
+            </c:strRef>
+          </c:tx>
+          <c:spPr>
+            <a:solidFill>
+              <a:srgbClr val="C00000"/>
+            </a:solidFill>
+            <a:ln>
+              <a:noFill/>
+            </a:ln>
+          </c:spPr>
+          <c:marker>
+            <c:symbol val="circle"/>
+            <c:spPr>
+              <a:solidFill>
+                <a:srgbClr val="C00000"/>
+              </a:solidFill>
+              <a:ln>
+                <a:solidFill>
+                  <a:srgbClr val="C00000"/>
+                </a:solidFill>
+              </a:ln>
+            </c:spPr>
+          </c:marker>
+          <c:xVal>
+            <c:numRef>
+              <c:f>Sheet1!$A$2:$A$5</c:f>
+              <c:numCache>
+                <c:formatCode>General</c:formatCode>
+                <c:ptCount val="4"/>
+                <c:pt idx="0">
+                  <c:v>0</c:v>
+                </c:pt>
+                <c:pt idx="1">
+                  <c:v>1</c:v>
+                </c:pt>
+                <c:pt idx="2">
+                  <c:v>2</c:v>
+                </c:pt>
+                <c:pt idx="3">
+                  <c:v>3</c:v>
+                </c:pt>
+              </c:numCache>
+            </c:numRef>
+          </c:xVal>
+          <c:yVal>
+            <c:numRef>
+              <c:f>Sheet1!$B$2:$B$5</c:f>
+              <c:numCache>
+                <c:formatCode>General</c:formatCode>
+                <c:ptCount val="4"/>
+                <c:pt idx="0">
+                  <c:v>10</c:v>
+                </c:pt>
+                <c:pt idx="1">
+                  <c:v>14</c:v>
+                </c:pt>
+                <c:pt idx="2">
+                  <c:v>9</c:v>
+                </c:pt>
+                <c:pt idx="3">
+                  <c:v>18</c:v>
+                </c:pt>
+              </c:numCache>
+            </c:numRef>
+          </c:yVal>
+          <c:smooth val="0"/>
+        </c:ser>
+        <c:ser>
+          <c:idx val="1"/>
+          <c:order val="1"/>
+          <c:tx>
+            <c:strRef>
+              <c:f>Sheet1!$B$7</c:f>
+              <c:strCache>
+                <c:ptCount val="1"/>
+                <c:pt idx="0">
+                  <c:v>Cost!</c:v>
+                </c:pt>
+              </c:strCache>
+            </c:strRef>
+          </c:tx>
+          <c:spPr>
+            <a:solidFill>
+              <a:srgbClr val="7030A0"/>
+            </a:solidFill>
+            <a:ln>
+              <a:noFill/>
+            </a:ln>
+          </c:spPr>
+          <c:marker>
+            <c:symbol val="circle"/>
+            <c:spPr>
+              <a:solidFill>
+                <a:srgbClr val="7030A0"/>
+              </a:solidFill>
+              <a:ln>
+                <a:solidFill>
+                  <a:srgbClr val="7030A0"/>
+                </a:solidFill>
+              </a:ln>
+            </c:spPr>
+          </c:marker>
+          <c:xVal>
+            <c:numRef>
+              <c:f>Sheet1!$A$8:$A$11</c:f>
+              <c:numCache>
+                <c:formatCode>General</c:formatCode>
+                <c:ptCount val="4"/>
+                <c:pt idx="0">
+                  <c:v>0</c:v>
+                </c:pt>
+                <c:pt idx="1">
+                  <c:v>1</c:v>
+                </c:pt>
+                <c:pt idx="2">
+                  <c:v>2</c:v>
+                </c:pt>
+                <c:pt idx="3">
+                  <c:v>3</c:v>
+                </c:pt>
+              </c:numCache>
+            </c:numRef>
+          </c:xVal>
+          <c:yVal>
+            <c:numRef>
+              <c:f>Sheet1!$B$8:$B$11</c:f>
+              <c:numCache>
+                <c:formatCode>General</c:formatCode>
+                <c:ptCount val="4"/>
+                <c:pt idx="0">
+                  <c:v>2</c:v>
+                </c:pt>
+                <c:pt idx="1">
+                  <c:v>4</c:v>
+                </c:pt>
+                <c:pt idx="2">
+                  <c:v>3</c:v>
+                </c:pt>
+                <c:pt idx="3">
+                  <c:v>1</c:v>
+                </c:pt>
+              </c:numCache>
+            </c:numRef>
+          </c:yVal>
+          <c:smooth val="0"/>
+        </c:ser>
+        <c:axId val="-2128940872"/>
+        <c:axId val="-2129643912"/>
+      </c:scatterChart>
+      <c:valAx>
+        <c:axId val="-2128940872"/>
+        <c:scaling>
+          <c:orientation val="minMax"/>
+        </c:scaling>
+        <c:delete val="0"/>
+        <c:axPos val="b"/>
+        <c:numFmt formatCode="General" sourceLinked="1"/>
+        <c:majorTickMark val="out"/>
+        <c:minorTickMark val="none"/>
+        <c:tickLblPos val="low"/>
+        <c:txPr>
+          <a:bodyPr/>
+          <a:lstStyle/>
+          <a:p>
+            <a:pPr>
+              <a:defRPr sz="1400"/>
+            </a:pPr>
+          </a:p>
+        </c:txPr>
+        <c:crossAx val="-2129643912"/>
+        <c:crosses val="autoZero"/>
+        <c:crossBetween val="midCat"/>
+      </c:valAx>
+      <c:valAx>
+        <c:axId val="-2129643912"/>
+        <c:scaling>
+          <c:orientation val="minMax"/>
+          <c:max val="100.0"/>
+          <c:min val="0.0"/>
+        </c:scaling>
+        <c:delete val="0"/>
+        <c:axPos val="l"/>
+        <c:numFmt formatCode="$0.0" sourceLinked="0"/>
+        <c:majorTickMark val="out"/>
+        <c:minorTickMark val="none"/>
+        <c:tickLblPos val="nextTo"/>
+        <c:txPr>
+          <a:bodyPr/>
+          <a:lstStyle/>
+          <a:p>
+            <a:pPr>
+              <a:defRPr sz="1400"/>
+            </a:pPr>
+          </a:p>
+        </c:txPr>
+        <c:crossAx val="-2128940872"/>
+        <c:crosses val="autoZero"/>
+        <c:crossBetween val="midCat"/>
       </c:valAx>
     </c:plotArea>
     <c:legend>
@@ -8696,6 +9894,76 @@
 </p:sld>
 </file>
 
+<file path=ppt/slides/slide10.xml><?xml version="1.0" encoding="utf-8"?>
+<p:sld xmlns:a="http://schemas.openxmlformats.org/drawingml/2006/main" xmlns:p="http://schemas.openxmlformats.org/presentationml/2006/main" xmlns:r="http://schemas.openxmlformats.org/officeDocument/2006/relationships">
+  <p:cSld>
+    <p:spTree>
+      <p:nvGrpSpPr>
+        <p:cNvPr id="1" name=""/>
+        <p:cNvGrpSpPr/>
+        <p:nvPr/>
+      </p:nvGrpSpPr>
+      <p:grpSpPr/>
+      <p:sp>
+        <p:nvSpPr>
+          <p:cNvPr id="2" name="TextBox 1"/>
+          <p:cNvSpPr txBox="1"/>
+          <p:nvPr/>
+        </p:nvSpPr>
+        <p:spPr>
+          <a:xfrm>
+            <a:off x="457200" y="91440"/>
+            <a:ext cx="11430000" cy="731520"/>
+          </a:xfrm>
+          <a:prstGeom prst="rect">
+            <a:avLst/>
+          </a:prstGeom>
+          <a:noFill/>
+        </p:spPr>
+        <p:txBody>
+          <a:bodyPr wrap="none" anchor="t">
+            <a:spAutoFit/>
+          </a:bodyPr>
+          <a:lstStyle/>
+          <a:p>
+            <a:pPr algn="l"/>
+            <a:r>
+              <a:rPr sz="2000" b="1" i="0" u="none">
+                <a:solidFill>
+                  <a:srgbClr val="7F7F7F"/>
+                </a:solidFill>
+              </a:rPr>
+              <a:t>Revenue Trend - Slide Title</a:t>
+            </a:r>
+          </a:p>
+        </p:txBody>
+      </p:sp>
+      <p:graphicFrame>
+        <p:nvGraphicFramePr>
+          <p:cNvPr id="3" name="chart_1"/>
+          <p:cNvGraphicFramePr>
+            <a:graphicFrameLocks noGrp="1"/>
+          </p:cNvGraphicFramePr>
+          <p:nvPr/>
+        </p:nvGraphicFramePr>
+        <p:xfrm>
+          <a:off x="457200" y="1463040"/>
+          <a:ext cx="11430000" cy="4800600"/>
+        </p:xfrm>
+        <a:graphic>
+          <a:graphicData uri="http://schemas.openxmlformats.org/drawingml/2006/chart">
+            <c:chart xmlns:c="http://schemas.openxmlformats.org/drawingml/2006/chart" r:id="rId2"/>
+          </a:graphicData>
+        </a:graphic>
+      </p:graphicFrame>
+    </p:spTree>
+  </p:cSld>
+  <p:clrMapOvr>
+    <a:masterClrMapping/>
+  </p:clrMapOvr>
+</p:sld>
+</file>
+
 <file path=ppt/slides/slide2.xml><?xml version="1.0" encoding="utf-8"?>
 <p:sld xmlns:a="http://schemas.openxmlformats.org/drawingml/2006/main" xmlns:p="http://schemas.openxmlformats.org/presentationml/2006/main" xmlns:r="http://schemas.openxmlformats.org/officeDocument/2006/relationships">
   <p:cSld>
@@ -10797,6 +12065,130 @@
 </p:sld>
 </file>
 
+<file path=ppt/slides/slide9.xml><?xml version="1.0" encoding="utf-8"?>
+<p:sld xmlns:a="http://schemas.openxmlformats.org/drawingml/2006/main" xmlns:p="http://schemas.openxmlformats.org/presentationml/2006/main" xmlns:r="http://schemas.openxmlformats.org/officeDocument/2006/relationships">
+  <p:cSld>
+    <p:spTree>
+      <p:nvGrpSpPr>
+        <p:cNvPr id="1" name=""/>
+        <p:cNvGrpSpPr/>
+        <p:nvPr/>
+      </p:nvGrpSpPr>
+      <p:grpSpPr/>
+      <p:sp>
+        <p:nvSpPr>
+          <p:cNvPr id="2" name="TextBox 1"/>
+          <p:cNvSpPr txBox="1"/>
+          <p:nvPr/>
+        </p:nvSpPr>
+        <p:spPr>
+          <a:xfrm>
+            <a:off x="457200" y="91440"/>
+            <a:ext cx="11430000" cy="731520"/>
+          </a:xfrm>
+          <a:prstGeom prst="rect">
+            <a:avLst/>
+          </a:prstGeom>
+          <a:noFill/>
+        </p:spPr>
+        <p:txBody>
+          <a:bodyPr wrap="none" anchor="t">
+            <a:spAutoFit/>
+          </a:bodyPr>
+          <a:lstStyle/>
+          <a:p>
+            <a:pPr algn="l"/>
+            <a:r>
+              <a:rPr sz="2000" b="1" i="0" u="none">
+                <a:solidFill>
+                  <a:srgbClr val="7F7F7F"/>
+                </a:solidFill>
+              </a:rPr>
+              <a:t>Revenue Trend - Slide Title</a:t>
+            </a:r>
+          </a:p>
+        </p:txBody>
+      </p:sp>
+      <p:graphicFrame>
+        <p:nvGraphicFramePr>
+          <p:cNvPr id="3" name="chart_1"/>
+          <p:cNvGraphicFramePr>
+            <a:graphicFrameLocks noGrp="1"/>
+          </p:cNvGraphicFramePr>
+          <p:nvPr/>
+        </p:nvGraphicFramePr>
+        <p:xfrm>
+          <a:off x="457200" y="1463040"/>
+          <a:ext cx="2862072" cy="4800600"/>
+        </p:xfrm>
+        <a:graphic>
+          <a:graphicData uri="http://schemas.openxmlformats.org/drawingml/2006/chart">
+            <c:chart xmlns:c="http://schemas.openxmlformats.org/drawingml/2006/chart" r:id="rId2"/>
+          </a:graphicData>
+        </a:graphic>
+      </p:graphicFrame>
+      <p:graphicFrame>
+        <p:nvGraphicFramePr>
+          <p:cNvPr id="4" name="chart_2"/>
+          <p:cNvGraphicFramePr>
+            <a:graphicFrameLocks noGrp="1"/>
+          </p:cNvGraphicFramePr>
+          <p:nvPr/>
+        </p:nvGraphicFramePr>
+        <p:xfrm>
+          <a:off x="3319272" y="1463040"/>
+          <a:ext cx="2862072" cy="4800600"/>
+        </p:xfrm>
+        <a:graphic>
+          <a:graphicData uri="http://schemas.openxmlformats.org/drawingml/2006/chart">
+            <c:chart xmlns:c="http://schemas.openxmlformats.org/drawingml/2006/chart" r:id="rId3"/>
+          </a:graphicData>
+        </a:graphic>
+      </p:graphicFrame>
+      <p:graphicFrame>
+        <p:nvGraphicFramePr>
+          <p:cNvPr id="5" name="chart_3"/>
+          <p:cNvGraphicFramePr>
+            <a:graphicFrameLocks noGrp="1"/>
+          </p:cNvGraphicFramePr>
+          <p:nvPr/>
+        </p:nvGraphicFramePr>
+        <p:xfrm>
+          <a:off x="6181344" y="1463040"/>
+          <a:ext cx="2862072" cy="4800600"/>
+        </p:xfrm>
+        <a:graphic>
+          <a:graphicData uri="http://schemas.openxmlformats.org/drawingml/2006/chart">
+            <c:chart xmlns:c="http://schemas.openxmlformats.org/drawingml/2006/chart" r:id="rId4"/>
+          </a:graphicData>
+        </a:graphic>
+      </p:graphicFrame>
+      <p:graphicFrame>
+        <p:nvGraphicFramePr>
+          <p:cNvPr id="6" name="chart_4"/>
+          <p:cNvGraphicFramePr>
+            <a:graphicFrameLocks noGrp="1"/>
+          </p:cNvGraphicFramePr>
+          <p:nvPr/>
+        </p:nvGraphicFramePr>
+        <p:xfrm>
+          <a:off x="9043416" y="1463040"/>
+          <a:ext cx="2862072" cy="4800600"/>
+        </p:xfrm>
+        <a:graphic>
+          <a:graphicData uri="http://schemas.openxmlformats.org/drawingml/2006/chart">
+            <c:chart xmlns:c="http://schemas.openxmlformats.org/drawingml/2006/chart" r:id="rId5"/>
+          </a:graphicData>
+        </a:graphic>
+      </p:graphicFrame>
+    </p:spTree>
+  </p:cSld>
+  <p:clrMapOvr>
+    <a:masterClrMapping/>
+  </p:clrMapOvr>
+</p:sld>
+</file>
+
 <file path=ppt/theme/theme1.xml><?xml version="1.0" encoding="utf-8"?>
 <a:theme xmlns:a="http://schemas.openxmlformats.org/drawingml/2006/main" name="Simple Light">
   <a:themeElements>

</xml_diff>

<commit_message>
enable overrides for ChartBlock
</commit_message>
<xml_diff>
--- a/notebooks/demo.pptx
+++ b/notebooks/demo.pptx
@@ -5081,19 +5081,6 @@
         <c:crosses val="autoZero"/>
       </c:valAx>
     </c:plotArea>
-    <c:legend>
-      <c:legendPos val="b"/>
-      <c:overlay val="0"/>
-      <c:txPr>
-        <a:bodyPr/>
-        <a:lstStyle/>
-        <a:p>
-          <a:pPr>
-            <a:defRPr sz="1400"/>
-          </a:pPr>
-        </a:p>
-      </c:txPr>
-    </c:legend>
     <c:dispBlanksAs val="gap"/>
   </c:chart>
   <c:txPr>
@@ -10702,7 +10689,7 @@
           <a:p>
             <a:pPr algn="ctr"/>
             <a:r>
-              <a:rPr sz="1400" b="1" i="0" u="sng">
+              <a:rPr sz="1600" b="1" i="0" u="sng">
                 <a:solidFill>
                   <a:srgbClr val="000000"/>
                 </a:solidFill>

</xml_diff>